<commit_message>
feat(slides): sync slides with OneDrive version
</commit_message>
<xml_diff>
--- a/slides/1-intro.pptx
+++ b/slides/1-intro.pptx
@@ -136,7 +136,7 @@
 <file path=ppt/revisionInfo.xml><?xml version="1.0" encoding="utf-8"?>
 <p1510:revInfo xmlns:a="http://schemas.openxmlformats.org/drawingml/2006/main" xmlns:r="http://schemas.openxmlformats.org/officeDocument/2006/relationships" xmlns:p1510="http://schemas.microsoft.com/office/powerpoint/2015/10/main">
   <p1510:revLst>
-    <p1510:client id="{319BC8FD-C455-96ED-2801-3920832F5F55}" v="17" dt="2025-09-13T08:47:10.864"/>
+    <p1510:client id="{E26B6609-0461-3689-64DB-6E59DF0EFC74}" v="4" dt="2025-09-30T10:40:58.045"/>
   </p1510:revLst>
 </p1510:revInfo>
 </file>
@@ -162,6 +162,30 @@
             <pc:docMk/>
             <pc:sldMk cId="570589333" sldId="259"/>
             <ac:spMk id="3" creationId="{D83C43F5-34A7-8640-01DC-E67800E0C470}"/>
+          </ac:spMkLst>
+        </pc:spChg>
+      </pc:sldChg>
+    </pc:docChg>
+  </pc:docChgLst>
+  <pc:docChgLst>
+    <pc:chgData name="Ryan Daniels" userId="S::rkd43@cam.ac.uk::aaa4fbe9-f474-4140-b10b-5257398ac308" providerId="AD" clId="Web-{E26B6609-0461-3689-64DB-6E59DF0EFC74}"/>
+    <pc:docChg chg="modSld">
+      <pc:chgData name="Ryan Daniels" userId="S::rkd43@cam.ac.uk::aaa4fbe9-f474-4140-b10b-5257398ac308" providerId="AD" clId="Web-{E26B6609-0461-3689-64DB-6E59DF0EFC74}" dt="2025-09-30T10:40:58.045" v="3" actId="20577"/>
+      <pc:docMkLst>
+        <pc:docMk/>
+      </pc:docMkLst>
+      <pc:sldChg chg="modSp">
+        <pc:chgData name="Ryan Daniels" userId="S::rkd43@cam.ac.uk::aaa4fbe9-f474-4140-b10b-5257398ac308" providerId="AD" clId="Web-{E26B6609-0461-3689-64DB-6E59DF0EFC74}" dt="2025-09-30T10:40:58.045" v="3" actId="20577"/>
+        <pc:sldMkLst>
+          <pc:docMk/>
+          <pc:sldMk cId="1719520842" sldId="273"/>
+        </pc:sldMkLst>
+        <pc:spChg chg="mod">
+          <ac:chgData name="Ryan Daniels" userId="S::rkd43@cam.ac.uk::aaa4fbe9-f474-4140-b10b-5257398ac308" providerId="AD" clId="Web-{E26B6609-0461-3689-64DB-6E59DF0EFC74}" dt="2025-09-30T10:40:58.045" v="3" actId="20577"/>
+          <ac:spMkLst>
+            <pc:docMk/>
+            <pc:sldMk cId="1719520842" sldId="273"/>
+            <ac:spMk id="3" creationId="{8E3982A0-7BFF-76E6-00A2-2D4A08CAC85F}"/>
           </ac:spMkLst>
         </pc:spChg>
       </pc:sldChg>
@@ -196,681 +220,6 @@
           </ac:spMkLst>
         </pc:spChg>
       </pc:sldChg>
-      <pc:sldChg chg="modSp new del">
-        <pc:chgData name="Ryan Daniels" userId="S::rkd43@cam.ac.uk::aaa4fbe9-f474-4140-b10b-5257398ac308" providerId="AD" clId="Web-{61261352-28B5-F6B1-1A56-AB06BC1060C3}" dt="2025-09-03T11:59:39.309" v="38"/>
-        <pc:sldMkLst>
-          <pc:docMk/>
-          <pc:sldMk cId="3506924465" sldId="275"/>
-        </pc:sldMkLst>
-      </pc:sldChg>
-    </pc:docChg>
-  </pc:docChgLst>
-  <pc:docChgLst>
-    <pc:chgData name="Ryan Daniels" userId="S::rkd43@cam.ac.uk::aaa4fbe9-f474-4140-b10b-5257398ac308" providerId="AD" clId="Web-{18FF2062-0BBC-DAD2-02B5-122056399AF9}"/>
-    <pc:docChg chg="addSld modSld sldOrd">
-      <pc:chgData name="Ryan Daniels" userId="S::rkd43@cam.ac.uk::aaa4fbe9-f474-4140-b10b-5257398ac308" providerId="AD" clId="Web-{18FF2062-0BBC-DAD2-02B5-122056399AF9}" dt="2025-07-01T11:14:59.690" v="377" actId="20577"/>
-      <pc:docMkLst>
-        <pc:docMk/>
-      </pc:docMkLst>
-      <pc:sldChg chg="modSp">
-        <pc:chgData name="Ryan Daniels" userId="S::rkd43@cam.ac.uk::aaa4fbe9-f474-4140-b10b-5257398ac308" providerId="AD" clId="Web-{18FF2062-0BBC-DAD2-02B5-122056399AF9}" dt="2025-06-30T20:51:05.903" v="316" actId="20577"/>
-        <pc:sldMkLst>
-          <pc:docMk/>
-          <pc:sldMk cId="3011003677" sldId="261"/>
-        </pc:sldMkLst>
-      </pc:sldChg>
-      <pc:sldChg chg="modSp addAnim delAnim">
-        <pc:chgData name="Ryan Daniels" userId="S::rkd43@cam.ac.uk::aaa4fbe9-f474-4140-b10b-5257398ac308" providerId="AD" clId="Web-{18FF2062-0BBC-DAD2-02B5-122056399AF9}" dt="2025-06-30T20:26:51.106" v="35" actId="20577"/>
-        <pc:sldMkLst>
-          <pc:docMk/>
-          <pc:sldMk cId="1865729139" sldId="266"/>
-        </pc:sldMkLst>
-      </pc:sldChg>
-      <pc:sldChg chg="modSp add replId delAnim">
-        <pc:chgData name="Ryan Daniels" userId="S::rkd43@cam.ac.uk::aaa4fbe9-f474-4140-b10b-5257398ac308" providerId="AD" clId="Web-{18FF2062-0BBC-DAD2-02B5-122056399AF9}" dt="2025-06-30T20:27:53.389" v="47"/>
-        <pc:sldMkLst>
-          <pc:docMk/>
-          <pc:sldMk cId="288595263" sldId="267"/>
-        </pc:sldMkLst>
-      </pc:sldChg>
-      <pc:sldChg chg="modSp add replId delAnim">
-        <pc:chgData name="Ryan Daniels" userId="S::rkd43@cam.ac.uk::aaa4fbe9-f474-4140-b10b-5257398ac308" providerId="AD" clId="Web-{18FF2062-0BBC-DAD2-02B5-122056399AF9}" dt="2025-06-30T20:28:42.987" v="55"/>
-        <pc:sldMkLst>
-          <pc:docMk/>
-          <pc:sldMk cId="459657627" sldId="268"/>
-        </pc:sldMkLst>
-      </pc:sldChg>
-      <pc:sldChg chg="modSp add replId delAnim">
-        <pc:chgData name="Ryan Daniels" userId="S::rkd43@cam.ac.uk::aaa4fbe9-f474-4140-b10b-5257398ac308" providerId="AD" clId="Web-{18FF2062-0BBC-DAD2-02B5-122056399AF9}" dt="2025-06-30T20:28:46.362" v="57"/>
-        <pc:sldMkLst>
-          <pc:docMk/>
-          <pc:sldMk cId="490861023" sldId="269"/>
-        </pc:sldMkLst>
-      </pc:sldChg>
-      <pc:sldChg chg="modSp add replId">
-        <pc:chgData name="Ryan Daniels" userId="S::rkd43@cam.ac.uk::aaa4fbe9-f474-4140-b10b-5257398ac308" providerId="AD" clId="Web-{18FF2062-0BBC-DAD2-02B5-122056399AF9}" dt="2025-06-30T20:32:42.466" v="70" actId="20577"/>
-        <pc:sldMkLst>
-          <pc:docMk/>
-          <pc:sldMk cId="1534518163" sldId="270"/>
-        </pc:sldMkLst>
-      </pc:sldChg>
-      <pc:sldChg chg="modSp add replId addAnim">
-        <pc:chgData name="Ryan Daniels" userId="S::rkd43@cam.ac.uk::aaa4fbe9-f474-4140-b10b-5257398ac308" providerId="AD" clId="Web-{18FF2062-0BBC-DAD2-02B5-122056399AF9}" dt="2025-06-30T20:44:40.168" v="268"/>
-        <pc:sldMkLst>
-          <pc:docMk/>
-          <pc:sldMk cId="2760384188" sldId="271"/>
-        </pc:sldMkLst>
-      </pc:sldChg>
-      <pc:sldChg chg="modSp add replId addAnim">
-        <pc:chgData name="Ryan Daniels" userId="S::rkd43@cam.ac.uk::aaa4fbe9-f474-4140-b10b-5257398ac308" providerId="AD" clId="Web-{18FF2062-0BBC-DAD2-02B5-122056399AF9}" dt="2025-06-30T20:44:48.934" v="269"/>
-        <pc:sldMkLst>
-          <pc:docMk/>
-          <pc:sldMk cId="3516369541" sldId="272"/>
-        </pc:sldMkLst>
-      </pc:sldChg>
-      <pc:sldChg chg="modSp new addAnim delAnim">
-        <pc:chgData name="Ryan Daniels" userId="S::rkd43@cam.ac.uk::aaa4fbe9-f474-4140-b10b-5257398ac308" providerId="AD" clId="Web-{18FF2062-0BBC-DAD2-02B5-122056399AF9}" dt="2025-07-01T11:13:44.297" v="355" actId="20577"/>
-        <pc:sldMkLst>
-          <pc:docMk/>
-          <pc:sldMk cId="1719520842" sldId="273"/>
-        </pc:sldMkLst>
-      </pc:sldChg>
-      <pc:sldChg chg="modSp add ord replId delAnim">
-        <pc:chgData name="Ryan Daniels" userId="S::rkd43@cam.ac.uk::aaa4fbe9-f474-4140-b10b-5257398ac308" providerId="AD" clId="Web-{18FF2062-0BBC-DAD2-02B5-122056399AF9}" dt="2025-07-01T11:14:59.690" v="377" actId="20577"/>
-        <pc:sldMkLst>
-          <pc:docMk/>
-          <pc:sldMk cId="3607703828" sldId="274"/>
-        </pc:sldMkLst>
-      </pc:sldChg>
-    </pc:docChg>
-  </pc:docChgLst>
-  <pc:docChgLst>
-    <pc:chgData name="Ryan Daniels" userId="S::rkd43@cam.ac.uk::aaa4fbe9-f474-4140-b10b-5257398ac308" providerId="AD" clId="Web-{66FA9984-1297-DB07-42B1-D9D9D0C443D0}"/>
-    <pc:docChg chg="modSld addMainMaster delMainMaster">
-      <pc:chgData name="Ryan Daniels" userId="S::rkd43@cam.ac.uk::aaa4fbe9-f474-4140-b10b-5257398ac308" providerId="AD" clId="Web-{66FA9984-1297-DB07-42B1-D9D9D0C443D0}" dt="2025-06-17T14:36:17.194" v="2"/>
-      <pc:docMkLst>
-        <pc:docMk/>
-      </pc:docMkLst>
-      <pc:sldChg chg="modSp mod modClrScheme chgLayout">
-        <pc:chgData name="Ryan Daniels" userId="S::rkd43@cam.ac.uk::aaa4fbe9-f474-4140-b10b-5257398ac308" providerId="AD" clId="Web-{66FA9984-1297-DB07-42B1-D9D9D0C443D0}" dt="2025-06-17T14:36:17.194" v="2"/>
-        <pc:sldMkLst>
-          <pc:docMk/>
-          <pc:sldMk cId="109857222" sldId="256"/>
-        </pc:sldMkLst>
-      </pc:sldChg>
-      <pc:sldChg chg="modSp mod modClrScheme chgLayout">
-        <pc:chgData name="Ryan Daniels" userId="S::rkd43@cam.ac.uk::aaa4fbe9-f474-4140-b10b-5257398ac308" providerId="AD" clId="Web-{66FA9984-1297-DB07-42B1-D9D9D0C443D0}" dt="2025-06-17T14:36:17.194" v="2"/>
-        <pc:sldMkLst>
-          <pc:docMk/>
-          <pc:sldMk cId="2776984732" sldId="257"/>
-        </pc:sldMkLst>
-      </pc:sldChg>
-      <pc:sldChg chg="modSp mod modClrScheme chgLayout">
-        <pc:chgData name="Ryan Daniels" userId="S::rkd43@cam.ac.uk::aaa4fbe9-f474-4140-b10b-5257398ac308" providerId="AD" clId="Web-{66FA9984-1297-DB07-42B1-D9D9D0C443D0}" dt="2025-06-17T14:36:17.194" v="2"/>
-        <pc:sldMkLst>
-          <pc:docMk/>
-          <pc:sldMk cId="3802117303" sldId="258"/>
-        </pc:sldMkLst>
-      </pc:sldChg>
-      <pc:sldChg chg="modSp mod modClrScheme chgLayout">
-        <pc:chgData name="Ryan Daniels" userId="S::rkd43@cam.ac.uk::aaa4fbe9-f474-4140-b10b-5257398ac308" providerId="AD" clId="Web-{66FA9984-1297-DB07-42B1-D9D9D0C443D0}" dt="2025-06-17T14:36:17.194" v="2"/>
-        <pc:sldMkLst>
-          <pc:docMk/>
-          <pc:sldMk cId="570589333" sldId="259"/>
-        </pc:sldMkLst>
-      </pc:sldChg>
-      <pc:sldChg chg="modSp mod modClrScheme chgLayout">
-        <pc:chgData name="Ryan Daniels" userId="S::rkd43@cam.ac.uk::aaa4fbe9-f474-4140-b10b-5257398ac308" providerId="AD" clId="Web-{66FA9984-1297-DB07-42B1-D9D9D0C443D0}" dt="2025-06-17T14:36:17.194" v="2"/>
-        <pc:sldMkLst>
-          <pc:docMk/>
-          <pc:sldMk cId="3408820217" sldId="260"/>
-        </pc:sldMkLst>
-      </pc:sldChg>
-      <pc:sldChg chg="modSp mod modClrScheme chgLayout">
-        <pc:chgData name="Ryan Daniels" userId="S::rkd43@cam.ac.uk::aaa4fbe9-f474-4140-b10b-5257398ac308" providerId="AD" clId="Web-{66FA9984-1297-DB07-42B1-D9D9D0C443D0}" dt="2025-06-17T14:36:17.194" v="2"/>
-        <pc:sldMkLst>
-          <pc:docMk/>
-          <pc:sldMk cId="3011003677" sldId="261"/>
-        </pc:sldMkLst>
-      </pc:sldChg>
-      <pc:sldChg chg="modSp mod modClrScheme chgLayout">
-        <pc:chgData name="Ryan Daniels" userId="S::rkd43@cam.ac.uk::aaa4fbe9-f474-4140-b10b-5257398ac308" providerId="AD" clId="Web-{66FA9984-1297-DB07-42B1-D9D9D0C443D0}" dt="2025-06-17T14:36:17.194" v="2"/>
-        <pc:sldMkLst>
-          <pc:docMk/>
-          <pc:sldMk cId="2828243406" sldId="262"/>
-        </pc:sldMkLst>
-      </pc:sldChg>
-      <pc:sldChg chg="modSp mod modClrScheme chgLayout">
-        <pc:chgData name="Ryan Daniels" userId="S::rkd43@cam.ac.uk::aaa4fbe9-f474-4140-b10b-5257398ac308" providerId="AD" clId="Web-{66FA9984-1297-DB07-42B1-D9D9D0C443D0}" dt="2025-06-17T14:36:17.194" v="2"/>
-        <pc:sldMkLst>
-          <pc:docMk/>
-          <pc:sldMk cId="455639456" sldId="263"/>
-        </pc:sldMkLst>
-      </pc:sldChg>
-      <pc:sldChg chg="modSp mod modClrScheme chgLayout">
-        <pc:chgData name="Ryan Daniels" userId="S::rkd43@cam.ac.uk::aaa4fbe9-f474-4140-b10b-5257398ac308" providerId="AD" clId="Web-{66FA9984-1297-DB07-42B1-D9D9D0C443D0}" dt="2025-06-17T14:36:17.194" v="2"/>
-        <pc:sldMkLst>
-          <pc:docMk/>
-          <pc:sldMk cId="1409691837" sldId="264"/>
-        </pc:sldMkLst>
-      </pc:sldChg>
-      <pc:sldChg chg="modSp mod modClrScheme chgLayout">
-        <pc:chgData name="Ryan Daniels" userId="S::rkd43@cam.ac.uk::aaa4fbe9-f474-4140-b10b-5257398ac308" providerId="AD" clId="Web-{66FA9984-1297-DB07-42B1-D9D9D0C443D0}" dt="2025-06-17T14:36:17.194" v="2"/>
-        <pc:sldMkLst>
-          <pc:docMk/>
-          <pc:sldMk cId="1834275082" sldId="265"/>
-        </pc:sldMkLst>
-      </pc:sldChg>
-      <pc:sldChg chg="modSp mod modClrScheme chgLayout">
-        <pc:chgData name="Ryan Daniels" userId="S::rkd43@cam.ac.uk::aaa4fbe9-f474-4140-b10b-5257398ac308" providerId="AD" clId="Web-{66FA9984-1297-DB07-42B1-D9D9D0C443D0}" dt="2025-06-17T14:36:17.194" v="2"/>
-        <pc:sldMkLst>
-          <pc:docMk/>
-          <pc:sldMk cId="1865729139" sldId="266"/>
-        </pc:sldMkLst>
-      </pc:sldChg>
-      <pc:sldMasterChg chg="del delSldLayout">
-        <pc:chgData name="Ryan Daniels" userId="S::rkd43@cam.ac.uk::aaa4fbe9-f474-4140-b10b-5257398ac308" providerId="AD" clId="Web-{66FA9984-1297-DB07-42B1-D9D9D0C443D0}" dt="2025-06-17T14:36:07.271" v="0"/>
-        <pc:sldMasterMkLst>
-          <pc:docMk/>
-          <pc:sldMasterMk cId="2460954070" sldId="2147483660"/>
-        </pc:sldMasterMkLst>
-        <pc:sldLayoutChg chg="del">
-          <pc:chgData name="Ryan Daniels" userId="S::rkd43@cam.ac.uk::aaa4fbe9-f474-4140-b10b-5257398ac308" providerId="AD" clId="Web-{66FA9984-1297-DB07-42B1-D9D9D0C443D0}" dt="2025-06-17T14:36:07.271" v="0"/>
-          <pc:sldLayoutMkLst>
-            <pc:docMk/>
-            <pc:sldMasterMk cId="2460954070" sldId="2147483660"/>
-            <pc:sldLayoutMk cId="2385387890" sldId="2147483661"/>
-          </pc:sldLayoutMkLst>
-        </pc:sldLayoutChg>
-        <pc:sldLayoutChg chg="del">
-          <pc:chgData name="Ryan Daniels" userId="S::rkd43@cam.ac.uk::aaa4fbe9-f474-4140-b10b-5257398ac308" providerId="AD" clId="Web-{66FA9984-1297-DB07-42B1-D9D9D0C443D0}" dt="2025-06-17T14:36:07.271" v="0"/>
-          <pc:sldLayoutMkLst>
-            <pc:docMk/>
-            <pc:sldMasterMk cId="2460954070" sldId="2147483660"/>
-            <pc:sldLayoutMk cId="949138452" sldId="2147483662"/>
-          </pc:sldLayoutMkLst>
-        </pc:sldLayoutChg>
-        <pc:sldLayoutChg chg="del">
-          <pc:chgData name="Ryan Daniels" userId="S::rkd43@cam.ac.uk::aaa4fbe9-f474-4140-b10b-5257398ac308" providerId="AD" clId="Web-{66FA9984-1297-DB07-42B1-D9D9D0C443D0}" dt="2025-06-17T14:36:07.271" v="0"/>
-          <pc:sldLayoutMkLst>
-            <pc:docMk/>
-            <pc:sldMasterMk cId="2460954070" sldId="2147483660"/>
-            <pc:sldLayoutMk cId="2591524520" sldId="2147483663"/>
-          </pc:sldLayoutMkLst>
-        </pc:sldLayoutChg>
-        <pc:sldLayoutChg chg="del">
-          <pc:chgData name="Ryan Daniels" userId="S::rkd43@cam.ac.uk::aaa4fbe9-f474-4140-b10b-5257398ac308" providerId="AD" clId="Web-{66FA9984-1297-DB07-42B1-D9D9D0C443D0}" dt="2025-06-17T14:36:07.271" v="0"/>
-          <pc:sldLayoutMkLst>
-            <pc:docMk/>
-            <pc:sldMasterMk cId="2460954070" sldId="2147483660"/>
-            <pc:sldLayoutMk cId="1203092039" sldId="2147483664"/>
-          </pc:sldLayoutMkLst>
-        </pc:sldLayoutChg>
-        <pc:sldLayoutChg chg="del">
-          <pc:chgData name="Ryan Daniels" userId="S::rkd43@cam.ac.uk::aaa4fbe9-f474-4140-b10b-5257398ac308" providerId="AD" clId="Web-{66FA9984-1297-DB07-42B1-D9D9D0C443D0}" dt="2025-06-17T14:36:07.271" v="0"/>
-          <pc:sldLayoutMkLst>
-            <pc:docMk/>
-            <pc:sldMasterMk cId="2460954070" sldId="2147483660"/>
-            <pc:sldLayoutMk cId="3733172339" sldId="2147483665"/>
-          </pc:sldLayoutMkLst>
-        </pc:sldLayoutChg>
-        <pc:sldLayoutChg chg="del">
-          <pc:chgData name="Ryan Daniels" userId="S::rkd43@cam.ac.uk::aaa4fbe9-f474-4140-b10b-5257398ac308" providerId="AD" clId="Web-{66FA9984-1297-DB07-42B1-D9D9D0C443D0}" dt="2025-06-17T14:36:07.271" v="0"/>
-          <pc:sldLayoutMkLst>
-            <pc:docMk/>
-            <pc:sldMasterMk cId="2460954070" sldId="2147483660"/>
-            <pc:sldLayoutMk cId="3210312558" sldId="2147483666"/>
-          </pc:sldLayoutMkLst>
-        </pc:sldLayoutChg>
-        <pc:sldLayoutChg chg="del">
-          <pc:chgData name="Ryan Daniels" userId="S::rkd43@cam.ac.uk::aaa4fbe9-f474-4140-b10b-5257398ac308" providerId="AD" clId="Web-{66FA9984-1297-DB07-42B1-D9D9D0C443D0}" dt="2025-06-17T14:36:07.271" v="0"/>
-          <pc:sldLayoutMkLst>
-            <pc:docMk/>
-            <pc:sldMasterMk cId="2460954070" sldId="2147483660"/>
-            <pc:sldLayoutMk cId="3146388984" sldId="2147483667"/>
-          </pc:sldLayoutMkLst>
-        </pc:sldLayoutChg>
-        <pc:sldLayoutChg chg="del">
-          <pc:chgData name="Ryan Daniels" userId="S::rkd43@cam.ac.uk::aaa4fbe9-f474-4140-b10b-5257398ac308" providerId="AD" clId="Web-{66FA9984-1297-DB07-42B1-D9D9D0C443D0}" dt="2025-06-17T14:36:07.271" v="0"/>
-          <pc:sldLayoutMkLst>
-            <pc:docMk/>
-            <pc:sldMasterMk cId="2460954070" sldId="2147483660"/>
-            <pc:sldLayoutMk cId="3171841454" sldId="2147483668"/>
-          </pc:sldLayoutMkLst>
-        </pc:sldLayoutChg>
-        <pc:sldLayoutChg chg="del">
-          <pc:chgData name="Ryan Daniels" userId="S::rkd43@cam.ac.uk::aaa4fbe9-f474-4140-b10b-5257398ac308" providerId="AD" clId="Web-{66FA9984-1297-DB07-42B1-D9D9D0C443D0}" dt="2025-06-17T14:36:07.271" v="0"/>
-          <pc:sldLayoutMkLst>
-            <pc:docMk/>
-            <pc:sldMasterMk cId="2460954070" sldId="2147483660"/>
-            <pc:sldLayoutMk cId="1718958274" sldId="2147483669"/>
-          </pc:sldLayoutMkLst>
-        </pc:sldLayoutChg>
-        <pc:sldLayoutChg chg="del">
-          <pc:chgData name="Ryan Daniels" userId="S::rkd43@cam.ac.uk::aaa4fbe9-f474-4140-b10b-5257398ac308" providerId="AD" clId="Web-{66FA9984-1297-DB07-42B1-D9D9D0C443D0}" dt="2025-06-17T14:36:07.271" v="0"/>
-          <pc:sldLayoutMkLst>
-            <pc:docMk/>
-            <pc:sldMasterMk cId="2460954070" sldId="2147483660"/>
-            <pc:sldLayoutMk cId="2202905451" sldId="2147483670"/>
-          </pc:sldLayoutMkLst>
-        </pc:sldLayoutChg>
-        <pc:sldLayoutChg chg="del">
-          <pc:chgData name="Ryan Daniels" userId="S::rkd43@cam.ac.uk::aaa4fbe9-f474-4140-b10b-5257398ac308" providerId="AD" clId="Web-{66FA9984-1297-DB07-42B1-D9D9D0C443D0}" dt="2025-06-17T14:36:07.271" v="0"/>
-          <pc:sldLayoutMkLst>
-            <pc:docMk/>
-            <pc:sldMasterMk cId="2460954070" sldId="2147483660"/>
-            <pc:sldLayoutMk cId="3479445657" sldId="2147483671"/>
-          </pc:sldLayoutMkLst>
-        </pc:sldLayoutChg>
-      </pc:sldMasterChg>
-      <pc:sldMasterChg chg="add del addSldLayout delSldLayout modSldLayout">
-        <pc:chgData name="Ryan Daniels" userId="S::rkd43@cam.ac.uk::aaa4fbe9-f474-4140-b10b-5257398ac308" providerId="AD" clId="Web-{66FA9984-1297-DB07-42B1-D9D9D0C443D0}" dt="2025-06-17T14:36:15.241" v="1"/>
-        <pc:sldMasterMkLst>
-          <pc:docMk/>
-          <pc:sldMasterMk cId="2055110940" sldId="2147483672"/>
-        </pc:sldMasterMkLst>
-        <pc:sldLayoutChg chg="add del mod replId">
-          <pc:chgData name="Ryan Daniels" userId="S::rkd43@cam.ac.uk::aaa4fbe9-f474-4140-b10b-5257398ac308" providerId="AD" clId="Web-{66FA9984-1297-DB07-42B1-D9D9D0C443D0}" dt="2025-06-17T14:36:15.241" v="1"/>
-          <pc:sldLayoutMkLst>
-            <pc:docMk/>
-            <pc:sldMasterMk cId="2055110940" sldId="2147483672"/>
-            <pc:sldLayoutMk cId="2729814945" sldId="2147483673"/>
-          </pc:sldLayoutMkLst>
-        </pc:sldLayoutChg>
-        <pc:sldLayoutChg chg="add del mod replId">
-          <pc:chgData name="Ryan Daniels" userId="S::rkd43@cam.ac.uk::aaa4fbe9-f474-4140-b10b-5257398ac308" providerId="AD" clId="Web-{66FA9984-1297-DB07-42B1-D9D9D0C443D0}" dt="2025-06-17T14:36:15.241" v="1"/>
-          <pc:sldLayoutMkLst>
-            <pc:docMk/>
-            <pc:sldMasterMk cId="2055110940" sldId="2147483672"/>
-            <pc:sldLayoutMk cId="4186517850" sldId="2147483674"/>
-          </pc:sldLayoutMkLst>
-        </pc:sldLayoutChg>
-        <pc:sldLayoutChg chg="add del mod replId">
-          <pc:chgData name="Ryan Daniels" userId="S::rkd43@cam.ac.uk::aaa4fbe9-f474-4140-b10b-5257398ac308" providerId="AD" clId="Web-{66FA9984-1297-DB07-42B1-D9D9D0C443D0}" dt="2025-06-17T14:36:15.241" v="1"/>
-          <pc:sldLayoutMkLst>
-            <pc:docMk/>
-            <pc:sldMasterMk cId="2055110940" sldId="2147483672"/>
-            <pc:sldLayoutMk cId="4073447601" sldId="2147483675"/>
-          </pc:sldLayoutMkLst>
-        </pc:sldLayoutChg>
-        <pc:sldLayoutChg chg="add del mod replId">
-          <pc:chgData name="Ryan Daniels" userId="S::rkd43@cam.ac.uk::aaa4fbe9-f474-4140-b10b-5257398ac308" providerId="AD" clId="Web-{66FA9984-1297-DB07-42B1-D9D9D0C443D0}" dt="2025-06-17T14:36:15.241" v="1"/>
-          <pc:sldLayoutMkLst>
-            <pc:docMk/>
-            <pc:sldMasterMk cId="2055110940" sldId="2147483672"/>
-            <pc:sldLayoutMk cId="689555587" sldId="2147483676"/>
-          </pc:sldLayoutMkLst>
-        </pc:sldLayoutChg>
-        <pc:sldLayoutChg chg="add del mod replId">
-          <pc:chgData name="Ryan Daniels" userId="S::rkd43@cam.ac.uk::aaa4fbe9-f474-4140-b10b-5257398ac308" providerId="AD" clId="Web-{66FA9984-1297-DB07-42B1-D9D9D0C443D0}" dt="2025-06-17T14:36:15.241" v="1"/>
-          <pc:sldLayoutMkLst>
-            <pc:docMk/>
-            <pc:sldMasterMk cId="2055110940" sldId="2147483672"/>
-            <pc:sldLayoutMk cId="1250712085" sldId="2147483677"/>
-          </pc:sldLayoutMkLst>
-        </pc:sldLayoutChg>
-        <pc:sldLayoutChg chg="add del mod replId">
-          <pc:chgData name="Ryan Daniels" userId="S::rkd43@cam.ac.uk::aaa4fbe9-f474-4140-b10b-5257398ac308" providerId="AD" clId="Web-{66FA9984-1297-DB07-42B1-D9D9D0C443D0}" dt="2025-06-17T14:36:15.241" v="1"/>
-          <pc:sldLayoutMkLst>
-            <pc:docMk/>
-            <pc:sldMasterMk cId="2055110940" sldId="2147483672"/>
-            <pc:sldLayoutMk cId="1908829154" sldId="2147483678"/>
-          </pc:sldLayoutMkLst>
-        </pc:sldLayoutChg>
-        <pc:sldLayoutChg chg="add del mod replId">
-          <pc:chgData name="Ryan Daniels" userId="S::rkd43@cam.ac.uk::aaa4fbe9-f474-4140-b10b-5257398ac308" providerId="AD" clId="Web-{66FA9984-1297-DB07-42B1-D9D9D0C443D0}" dt="2025-06-17T14:36:15.241" v="1"/>
-          <pc:sldLayoutMkLst>
-            <pc:docMk/>
-            <pc:sldMasterMk cId="2055110940" sldId="2147483672"/>
-            <pc:sldLayoutMk cId="732328988" sldId="2147483679"/>
-          </pc:sldLayoutMkLst>
-        </pc:sldLayoutChg>
-        <pc:sldLayoutChg chg="add del mod replId">
-          <pc:chgData name="Ryan Daniels" userId="S::rkd43@cam.ac.uk::aaa4fbe9-f474-4140-b10b-5257398ac308" providerId="AD" clId="Web-{66FA9984-1297-DB07-42B1-D9D9D0C443D0}" dt="2025-06-17T14:36:15.241" v="1"/>
-          <pc:sldLayoutMkLst>
-            <pc:docMk/>
-            <pc:sldMasterMk cId="2055110940" sldId="2147483672"/>
-            <pc:sldLayoutMk cId="2243372565" sldId="2147483680"/>
-          </pc:sldLayoutMkLst>
-        </pc:sldLayoutChg>
-        <pc:sldLayoutChg chg="add del mod replId">
-          <pc:chgData name="Ryan Daniels" userId="S::rkd43@cam.ac.uk::aaa4fbe9-f474-4140-b10b-5257398ac308" providerId="AD" clId="Web-{66FA9984-1297-DB07-42B1-D9D9D0C443D0}" dt="2025-06-17T14:36:15.241" v="1"/>
-          <pc:sldLayoutMkLst>
-            <pc:docMk/>
-            <pc:sldMasterMk cId="2055110940" sldId="2147483672"/>
-            <pc:sldLayoutMk cId="3155551187" sldId="2147483681"/>
-          </pc:sldLayoutMkLst>
-        </pc:sldLayoutChg>
-        <pc:sldLayoutChg chg="add del mod replId">
-          <pc:chgData name="Ryan Daniels" userId="S::rkd43@cam.ac.uk::aaa4fbe9-f474-4140-b10b-5257398ac308" providerId="AD" clId="Web-{66FA9984-1297-DB07-42B1-D9D9D0C443D0}" dt="2025-06-17T14:36:15.241" v="1"/>
-          <pc:sldLayoutMkLst>
-            <pc:docMk/>
-            <pc:sldMasterMk cId="2055110940" sldId="2147483672"/>
-            <pc:sldLayoutMk cId="951678835" sldId="2147483682"/>
-          </pc:sldLayoutMkLst>
-        </pc:sldLayoutChg>
-        <pc:sldLayoutChg chg="add del mod replId">
-          <pc:chgData name="Ryan Daniels" userId="S::rkd43@cam.ac.uk::aaa4fbe9-f474-4140-b10b-5257398ac308" providerId="AD" clId="Web-{66FA9984-1297-DB07-42B1-D9D9D0C443D0}" dt="2025-06-17T14:36:15.241" v="1"/>
-          <pc:sldLayoutMkLst>
-            <pc:docMk/>
-            <pc:sldMasterMk cId="2055110940" sldId="2147483672"/>
-            <pc:sldLayoutMk cId="2767807970" sldId="2147483683"/>
-          </pc:sldLayoutMkLst>
-        </pc:sldLayoutChg>
-      </pc:sldMasterChg>
-      <pc:sldMasterChg chg="add del addSldLayout delSldLayout modSldLayout">
-        <pc:chgData name="Ryan Daniels" userId="S::rkd43@cam.ac.uk::aaa4fbe9-f474-4140-b10b-5257398ac308" providerId="AD" clId="Web-{66FA9984-1297-DB07-42B1-D9D9D0C443D0}" dt="2025-06-17T14:36:17.194" v="2"/>
-        <pc:sldMasterMkLst>
-          <pc:docMk/>
-          <pc:sldMasterMk cId="819875423" sldId="2147483684"/>
-        </pc:sldMasterMkLst>
-        <pc:sldLayoutChg chg="add del mod replId">
-          <pc:chgData name="Ryan Daniels" userId="S::rkd43@cam.ac.uk::aaa4fbe9-f474-4140-b10b-5257398ac308" providerId="AD" clId="Web-{66FA9984-1297-DB07-42B1-D9D9D0C443D0}" dt="2025-06-17T14:36:17.194" v="2"/>
-          <pc:sldLayoutMkLst>
-            <pc:docMk/>
-            <pc:sldMasterMk cId="819875423" sldId="2147483684"/>
-            <pc:sldLayoutMk cId="2773126515" sldId="2147483685"/>
-          </pc:sldLayoutMkLst>
-        </pc:sldLayoutChg>
-        <pc:sldLayoutChg chg="add del mod replId">
-          <pc:chgData name="Ryan Daniels" userId="S::rkd43@cam.ac.uk::aaa4fbe9-f474-4140-b10b-5257398ac308" providerId="AD" clId="Web-{66FA9984-1297-DB07-42B1-D9D9D0C443D0}" dt="2025-06-17T14:36:17.194" v="2"/>
-          <pc:sldLayoutMkLst>
-            <pc:docMk/>
-            <pc:sldMasterMk cId="819875423" sldId="2147483684"/>
-            <pc:sldLayoutMk cId="2530099027" sldId="2147483686"/>
-          </pc:sldLayoutMkLst>
-        </pc:sldLayoutChg>
-        <pc:sldLayoutChg chg="add del mod replId">
-          <pc:chgData name="Ryan Daniels" userId="S::rkd43@cam.ac.uk::aaa4fbe9-f474-4140-b10b-5257398ac308" providerId="AD" clId="Web-{66FA9984-1297-DB07-42B1-D9D9D0C443D0}" dt="2025-06-17T14:36:17.194" v="2"/>
-          <pc:sldLayoutMkLst>
-            <pc:docMk/>
-            <pc:sldMasterMk cId="819875423" sldId="2147483684"/>
-            <pc:sldLayoutMk cId="568452127" sldId="2147483687"/>
-          </pc:sldLayoutMkLst>
-        </pc:sldLayoutChg>
-        <pc:sldLayoutChg chg="add del mod replId">
-          <pc:chgData name="Ryan Daniels" userId="S::rkd43@cam.ac.uk::aaa4fbe9-f474-4140-b10b-5257398ac308" providerId="AD" clId="Web-{66FA9984-1297-DB07-42B1-D9D9D0C443D0}" dt="2025-06-17T14:36:17.194" v="2"/>
-          <pc:sldLayoutMkLst>
-            <pc:docMk/>
-            <pc:sldMasterMk cId="819875423" sldId="2147483684"/>
-            <pc:sldLayoutMk cId="1940790982" sldId="2147483688"/>
-          </pc:sldLayoutMkLst>
-        </pc:sldLayoutChg>
-        <pc:sldLayoutChg chg="add del mod replId">
-          <pc:chgData name="Ryan Daniels" userId="S::rkd43@cam.ac.uk::aaa4fbe9-f474-4140-b10b-5257398ac308" providerId="AD" clId="Web-{66FA9984-1297-DB07-42B1-D9D9D0C443D0}" dt="2025-06-17T14:36:17.194" v="2"/>
-          <pc:sldLayoutMkLst>
-            <pc:docMk/>
-            <pc:sldMasterMk cId="819875423" sldId="2147483684"/>
-            <pc:sldLayoutMk cId="3104327962" sldId="2147483689"/>
-          </pc:sldLayoutMkLst>
-        </pc:sldLayoutChg>
-        <pc:sldLayoutChg chg="add del mod replId">
-          <pc:chgData name="Ryan Daniels" userId="S::rkd43@cam.ac.uk::aaa4fbe9-f474-4140-b10b-5257398ac308" providerId="AD" clId="Web-{66FA9984-1297-DB07-42B1-D9D9D0C443D0}" dt="2025-06-17T14:36:17.194" v="2"/>
-          <pc:sldLayoutMkLst>
-            <pc:docMk/>
-            <pc:sldMasterMk cId="819875423" sldId="2147483684"/>
-            <pc:sldLayoutMk cId="170188911" sldId="2147483690"/>
-          </pc:sldLayoutMkLst>
-        </pc:sldLayoutChg>
-        <pc:sldLayoutChg chg="add del mod replId">
-          <pc:chgData name="Ryan Daniels" userId="S::rkd43@cam.ac.uk::aaa4fbe9-f474-4140-b10b-5257398ac308" providerId="AD" clId="Web-{66FA9984-1297-DB07-42B1-D9D9D0C443D0}" dt="2025-06-17T14:36:17.194" v="2"/>
-          <pc:sldLayoutMkLst>
-            <pc:docMk/>
-            <pc:sldMasterMk cId="819875423" sldId="2147483684"/>
-            <pc:sldLayoutMk cId="4201638502" sldId="2147483691"/>
-          </pc:sldLayoutMkLst>
-        </pc:sldLayoutChg>
-        <pc:sldLayoutChg chg="add del mod replId">
-          <pc:chgData name="Ryan Daniels" userId="S::rkd43@cam.ac.uk::aaa4fbe9-f474-4140-b10b-5257398ac308" providerId="AD" clId="Web-{66FA9984-1297-DB07-42B1-D9D9D0C443D0}" dt="2025-06-17T14:36:17.194" v="2"/>
-          <pc:sldLayoutMkLst>
-            <pc:docMk/>
-            <pc:sldMasterMk cId="819875423" sldId="2147483684"/>
-            <pc:sldLayoutMk cId="2989150192" sldId="2147483692"/>
-          </pc:sldLayoutMkLst>
-        </pc:sldLayoutChg>
-        <pc:sldLayoutChg chg="add del mod replId">
-          <pc:chgData name="Ryan Daniels" userId="S::rkd43@cam.ac.uk::aaa4fbe9-f474-4140-b10b-5257398ac308" providerId="AD" clId="Web-{66FA9984-1297-DB07-42B1-D9D9D0C443D0}" dt="2025-06-17T14:36:17.194" v="2"/>
-          <pc:sldLayoutMkLst>
-            <pc:docMk/>
-            <pc:sldMasterMk cId="819875423" sldId="2147483684"/>
-            <pc:sldLayoutMk cId="791824927" sldId="2147483693"/>
-          </pc:sldLayoutMkLst>
-        </pc:sldLayoutChg>
-        <pc:sldLayoutChg chg="add del mod replId">
-          <pc:chgData name="Ryan Daniels" userId="S::rkd43@cam.ac.uk::aaa4fbe9-f474-4140-b10b-5257398ac308" providerId="AD" clId="Web-{66FA9984-1297-DB07-42B1-D9D9D0C443D0}" dt="2025-06-17T14:36:17.194" v="2"/>
-          <pc:sldLayoutMkLst>
-            <pc:docMk/>
-            <pc:sldMasterMk cId="819875423" sldId="2147483684"/>
-            <pc:sldLayoutMk cId="3516590136" sldId="2147483694"/>
-          </pc:sldLayoutMkLst>
-        </pc:sldLayoutChg>
-        <pc:sldLayoutChg chg="add del mod replId">
-          <pc:chgData name="Ryan Daniels" userId="S::rkd43@cam.ac.uk::aaa4fbe9-f474-4140-b10b-5257398ac308" providerId="AD" clId="Web-{66FA9984-1297-DB07-42B1-D9D9D0C443D0}" dt="2025-06-17T14:36:17.194" v="2"/>
-          <pc:sldLayoutMkLst>
-            <pc:docMk/>
-            <pc:sldMasterMk cId="819875423" sldId="2147483684"/>
-            <pc:sldLayoutMk cId="122760176" sldId="2147483695"/>
-          </pc:sldLayoutMkLst>
-        </pc:sldLayoutChg>
-      </pc:sldMasterChg>
-      <pc:sldMasterChg chg="add addSldLayout modSldLayout">
-        <pc:chgData name="Ryan Daniels" userId="S::rkd43@cam.ac.uk::aaa4fbe9-f474-4140-b10b-5257398ac308" providerId="AD" clId="Web-{66FA9984-1297-DB07-42B1-D9D9D0C443D0}" dt="2025-06-17T14:36:17.194" v="2"/>
-        <pc:sldMasterMkLst>
-          <pc:docMk/>
-          <pc:sldMasterMk cId="2566986982" sldId="2147483696"/>
-        </pc:sldMasterMkLst>
-        <pc:sldLayoutChg chg="add mod replId">
-          <pc:chgData name="Ryan Daniels" userId="S::rkd43@cam.ac.uk::aaa4fbe9-f474-4140-b10b-5257398ac308" providerId="AD" clId="Web-{66FA9984-1297-DB07-42B1-D9D9D0C443D0}" dt="2025-06-17T14:36:17.194" v="2"/>
-          <pc:sldLayoutMkLst>
-            <pc:docMk/>
-            <pc:sldMasterMk cId="2566986982" sldId="2147483696"/>
-            <pc:sldLayoutMk cId="2661217146" sldId="2147483697"/>
-          </pc:sldLayoutMkLst>
-        </pc:sldLayoutChg>
-        <pc:sldLayoutChg chg="add mod replId">
-          <pc:chgData name="Ryan Daniels" userId="S::rkd43@cam.ac.uk::aaa4fbe9-f474-4140-b10b-5257398ac308" providerId="AD" clId="Web-{66FA9984-1297-DB07-42B1-D9D9D0C443D0}" dt="2025-06-17T14:36:17.194" v="2"/>
-          <pc:sldLayoutMkLst>
-            <pc:docMk/>
-            <pc:sldMasterMk cId="2566986982" sldId="2147483696"/>
-            <pc:sldLayoutMk cId="1221414830" sldId="2147483698"/>
-          </pc:sldLayoutMkLst>
-        </pc:sldLayoutChg>
-        <pc:sldLayoutChg chg="add mod replId">
-          <pc:chgData name="Ryan Daniels" userId="S::rkd43@cam.ac.uk::aaa4fbe9-f474-4140-b10b-5257398ac308" providerId="AD" clId="Web-{66FA9984-1297-DB07-42B1-D9D9D0C443D0}" dt="2025-06-17T14:36:17.194" v="2"/>
-          <pc:sldLayoutMkLst>
-            <pc:docMk/>
-            <pc:sldMasterMk cId="2566986982" sldId="2147483696"/>
-            <pc:sldLayoutMk cId="115500601" sldId="2147483699"/>
-          </pc:sldLayoutMkLst>
-        </pc:sldLayoutChg>
-        <pc:sldLayoutChg chg="add mod replId">
-          <pc:chgData name="Ryan Daniels" userId="S::rkd43@cam.ac.uk::aaa4fbe9-f474-4140-b10b-5257398ac308" providerId="AD" clId="Web-{66FA9984-1297-DB07-42B1-D9D9D0C443D0}" dt="2025-06-17T14:36:17.194" v="2"/>
-          <pc:sldLayoutMkLst>
-            <pc:docMk/>
-            <pc:sldMasterMk cId="2566986982" sldId="2147483696"/>
-            <pc:sldLayoutMk cId="210809345" sldId="2147483700"/>
-          </pc:sldLayoutMkLst>
-        </pc:sldLayoutChg>
-        <pc:sldLayoutChg chg="add mod replId">
-          <pc:chgData name="Ryan Daniels" userId="S::rkd43@cam.ac.uk::aaa4fbe9-f474-4140-b10b-5257398ac308" providerId="AD" clId="Web-{66FA9984-1297-DB07-42B1-D9D9D0C443D0}" dt="2025-06-17T14:36:17.194" v="2"/>
-          <pc:sldLayoutMkLst>
-            <pc:docMk/>
-            <pc:sldMasterMk cId="2566986982" sldId="2147483696"/>
-            <pc:sldLayoutMk cId="1764180412" sldId="2147483701"/>
-          </pc:sldLayoutMkLst>
-        </pc:sldLayoutChg>
-        <pc:sldLayoutChg chg="add mod replId">
-          <pc:chgData name="Ryan Daniels" userId="S::rkd43@cam.ac.uk::aaa4fbe9-f474-4140-b10b-5257398ac308" providerId="AD" clId="Web-{66FA9984-1297-DB07-42B1-D9D9D0C443D0}" dt="2025-06-17T14:36:17.194" v="2"/>
-          <pc:sldLayoutMkLst>
-            <pc:docMk/>
-            <pc:sldMasterMk cId="2566986982" sldId="2147483696"/>
-            <pc:sldLayoutMk cId="137392330" sldId="2147483702"/>
-          </pc:sldLayoutMkLst>
-        </pc:sldLayoutChg>
-        <pc:sldLayoutChg chg="add mod replId">
-          <pc:chgData name="Ryan Daniels" userId="S::rkd43@cam.ac.uk::aaa4fbe9-f474-4140-b10b-5257398ac308" providerId="AD" clId="Web-{66FA9984-1297-DB07-42B1-D9D9D0C443D0}" dt="2025-06-17T14:36:17.194" v="2"/>
-          <pc:sldLayoutMkLst>
-            <pc:docMk/>
-            <pc:sldMasterMk cId="2566986982" sldId="2147483696"/>
-            <pc:sldLayoutMk cId="299030596" sldId="2147483703"/>
-          </pc:sldLayoutMkLst>
-        </pc:sldLayoutChg>
-        <pc:sldLayoutChg chg="add mod replId">
-          <pc:chgData name="Ryan Daniels" userId="S::rkd43@cam.ac.uk::aaa4fbe9-f474-4140-b10b-5257398ac308" providerId="AD" clId="Web-{66FA9984-1297-DB07-42B1-D9D9D0C443D0}" dt="2025-06-17T14:36:17.194" v="2"/>
-          <pc:sldLayoutMkLst>
-            <pc:docMk/>
-            <pc:sldMasterMk cId="2566986982" sldId="2147483696"/>
-            <pc:sldLayoutMk cId="4118341341" sldId="2147483704"/>
-          </pc:sldLayoutMkLst>
-        </pc:sldLayoutChg>
-        <pc:sldLayoutChg chg="add mod replId">
-          <pc:chgData name="Ryan Daniels" userId="S::rkd43@cam.ac.uk::aaa4fbe9-f474-4140-b10b-5257398ac308" providerId="AD" clId="Web-{66FA9984-1297-DB07-42B1-D9D9D0C443D0}" dt="2025-06-17T14:36:17.194" v="2"/>
-          <pc:sldLayoutMkLst>
-            <pc:docMk/>
-            <pc:sldMasterMk cId="2566986982" sldId="2147483696"/>
-            <pc:sldLayoutMk cId="450196488" sldId="2147483705"/>
-          </pc:sldLayoutMkLst>
-        </pc:sldLayoutChg>
-        <pc:sldLayoutChg chg="add mod replId">
-          <pc:chgData name="Ryan Daniels" userId="S::rkd43@cam.ac.uk::aaa4fbe9-f474-4140-b10b-5257398ac308" providerId="AD" clId="Web-{66FA9984-1297-DB07-42B1-D9D9D0C443D0}" dt="2025-06-17T14:36:17.194" v="2"/>
-          <pc:sldLayoutMkLst>
-            <pc:docMk/>
-            <pc:sldMasterMk cId="2566986982" sldId="2147483696"/>
-            <pc:sldLayoutMk cId="4136549470" sldId="2147483706"/>
-          </pc:sldLayoutMkLst>
-        </pc:sldLayoutChg>
-        <pc:sldLayoutChg chg="add mod replId">
-          <pc:chgData name="Ryan Daniels" userId="S::rkd43@cam.ac.uk::aaa4fbe9-f474-4140-b10b-5257398ac308" providerId="AD" clId="Web-{66FA9984-1297-DB07-42B1-D9D9D0C443D0}" dt="2025-06-17T14:36:17.194" v="2"/>
-          <pc:sldLayoutMkLst>
-            <pc:docMk/>
-            <pc:sldMasterMk cId="2566986982" sldId="2147483696"/>
-            <pc:sldLayoutMk cId="1035061791" sldId="2147483707"/>
-          </pc:sldLayoutMkLst>
-        </pc:sldLayoutChg>
-      </pc:sldMasterChg>
-    </pc:docChg>
-  </pc:docChgLst>
-  <pc:docChgLst>
-    <pc:chgData name="Ryan Daniels" userId="S::rkd43@cam.ac.uk::aaa4fbe9-f474-4140-b10b-5257398ac308" providerId="AD" clId="Web-{7298A54E-B507-B0BE-DC4E-587E9C54C5F7}"/>
-    <pc:docChg chg="addSld delSld modSld sldOrd">
-      <pc:chgData name="Ryan Daniels" userId="S::rkd43@cam.ac.uk::aaa4fbe9-f474-4140-b10b-5257398ac308" providerId="AD" clId="Web-{7298A54E-B507-B0BE-DC4E-587E9C54C5F7}" dt="2025-06-13T11:29:10.661" v="1105" actId="20577"/>
-      <pc:docMkLst>
-        <pc:docMk/>
-      </pc:docMkLst>
-      <pc:sldChg chg="modSp">
-        <pc:chgData name="Ryan Daniels" userId="S::rkd43@cam.ac.uk::aaa4fbe9-f474-4140-b10b-5257398ac308" providerId="AD" clId="Web-{7298A54E-B507-B0BE-DC4E-587E9C54C5F7}" dt="2025-06-13T09:17:11.819" v="28" actId="20577"/>
-        <pc:sldMkLst>
-          <pc:docMk/>
-          <pc:sldMk cId="109857222" sldId="256"/>
-        </pc:sldMkLst>
-      </pc:sldChg>
-      <pc:sldChg chg="modSp new">
-        <pc:chgData name="Ryan Daniels" userId="S::rkd43@cam.ac.uk::aaa4fbe9-f474-4140-b10b-5257398ac308" providerId="AD" clId="Web-{7298A54E-B507-B0BE-DC4E-587E9C54C5F7}" dt="2025-06-13T10:35:51.102" v="1023" actId="20577"/>
-        <pc:sldMkLst>
-          <pc:docMk/>
-          <pc:sldMk cId="2776984732" sldId="257"/>
-        </pc:sldMkLst>
-      </pc:sldChg>
-      <pc:sldChg chg="new del">
-        <pc:chgData name="Ryan Daniels" userId="S::rkd43@cam.ac.uk::aaa4fbe9-f474-4140-b10b-5257398ac308" providerId="AD" clId="Web-{7298A54E-B507-B0BE-DC4E-587E9C54C5F7}" dt="2025-06-13T08:58:39.236" v="1"/>
-        <pc:sldMkLst>
-          <pc:docMk/>
-          <pc:sldMk cId="2979638681" sldId="257"/>
-        </pc:sldMkLst>
-      </pc:sldChg>
-      <pc:sldChg chg="addSp delSp modSp new addAnim delAnim modAnim">
-        <pc:chgData name="Ryan Daniels" userId="S::rkd43@cam.ac.uk::aaa4fbe9-f474-4140-b10b-5257398ac308" providerId="AD" clId="Web-{7298A54E-B507-B0BE-DC4E-587E9C54C5F7}" dt="2025-06-13T10:39:00.999" v="1079"/>
-        <pc:sldMkLst>
-          <pc:docMk/>
-          <pc:sldMk cId="3802117303" sldId="258"/>
-        </pc:sldMkLst>
-      </pc:sldChg>
-      <pc:sldChg chg="addSp modSp new addAnim modAnim">
-        <pc:chgData name="Ryan Daniels" userId="S::rkd43@cam.ac.uk::aaa4fbe9-f474-4140-b10b-5257398ac308" providerId="AD" clId="Web-{7298A54E-B507-B0BE-DC4E-587E9C54C5F7}" dt="2025-06-13T09:53:42.852" v="326"/>
-        <pc:sldMkLst>
-          <pc:docMk/>
-          <pc:sldMk cId="570589333" sldId="259"/>
-        </pc:sldMkLst>
-      </pc:sldChg>
-      <pc:sldChg chg="add del replId">
-        <pc:chgData name="Ryan Daniels" userId="S::rkd43@cam.ac.uk::aaa4fbe9-f474-4140-b10b-5257398ac308" providerId="AD" clId="Web-{7298A54E-B507-B0BE-DC4E-587E9C54C5F7}" dt="2025-06-13T09:43:26.877" v="225"/>
-        <pc:sldMkLst>
-          <pc:docMk/>
-          <pc:sldMk cId="2653770474" sldId="259"/>
-        </pc:sldMkLst>
-      </pc:sldChg>
-      <pc:sldChg chg="add del replId">
-        <pc:chgData name="Ryan Daniels" userId="S::rkd43@cam.ac.uk::aaa4fbe9-f474-4140-b10b-5257398ac308" providerId="AD" clId="Web-{7298A54E-B507-B0BE-DC4E-587E9C54C5F7}" dt="2025-06-13T09:43:25.908" v="224"/>
-        <pc:sldMkLst>
-          <pc:docMk/>
-          <pc:sldMk cId="2614785151" sldId="260"/>
-        </pc:sldMkLst>
-      </pc:sldChg>
-      <pc:sldChg chg="modSp new addAnim modNotes">
-        <pc:chgData name="Ryan Daniels" userId="S::rkd43@cam.ac.uk::aaa4fbe9-f474-4140-b10b-5257398ac308" providerId="AD" clId="Web-{7298A54E-B507-B0BE-DC4E-587E9C54C5F7}" dt="2025-06-13T10:08:50.229" v="560" actId="20577"/>
-        <pc:sldMkLst>
-          <pc:docMk/>
-          <pc:sldMk cId="3408820217" sldId="260"/>
-        </pc:sldMkLst>
-      </pc:sldChg>
-      <pc:sldChg chg="modSp new">
-        <pc:chgData name="Ryan Daniels" userId="S::rkd43@cam.ac.uk::aaa4fbe9-f474-4140-b10b-5257398ac308" providerId="AD" clId="Web-{7298A54E-B507-B0BE-DC4E-587E9C54C5F7}" dt="2025-06-13T10:05:30.581" v="480" actId="20577"/>
-        <pc:sldMkLst>
-          <pc:docMk/>
-          <pc:sldMk cId="3011003677" sldId="261"/>
-        </pc:sldMkLst>
-      </pc:sldChg>
-      <pc:sldChg chg="modSp new">
-        <pc:chgData name="Ryan Daniels" userId="S::rkd43@cam.ac.uk::aaa4fbe9-f474-4140-b10b-5257398ac308" providerId="AD" clId="Web-{7298A54E-B507-B0BE-DC4E-587E9C54C5F7}" dt="2025-06-13T10:08:41.854" v="559" actId="20577"/>
-        <pc:sldMkLst>
-          <pc:docMk/>
-          <pc:sldMk cId="2828243406" sldId="262"/>
-        </pc:sldMkLst>
-      </pc:sldChg>
-      <pc:sldChg chg="addSp delSp modSp new">
-        <pc:chgData name="Ryan Daniels" userId="S::rkd43@cam.ac.uk::aaa4fbe9-f474-4140-b10b-5257398ac308" providerId="AD" clId="Web-{7298A54E-B507-B0BE-DC4E-587E9C54C5F7}" dt="2025-06-13T10:30:40.903" v="902"/>
-        <pc:sldMkLst>
-          <pc:docMk/>
-          <pc:sldMk cId="455639456" sldId="263"/>
-        </pc:sldMkLst>
-      </pc:sldChg>
-      <pc:sldChg chg="modSp new">
-        <pc:chgData name="Ryan Daniels" userId="S::rkd43@cam.ac.uk::aaa4fbe9-f474-4140-b10b-5257398ac308" providerId="AD" clId="Web-{7298A54E-B507-B0BE-DC4E-587E9C54C5F7}" dt="2025-06-13T10:32:45.220" v="933" actId="20577"/>
-        <pc:sldMkLst>
-          <pc:docMk/>
-          <pc:sldMk cId="1409691837" sldId="264"/>
-        </pc:sldMkLst>
-      </pc:sldChg>
-      <pc:sldChg chg="modSp new ord addAnim">
-        <pc:chgData name="Ryan Daniels" userId="S::rkd43@cam.ac.uk::aaa4fbe9-f474-4140-b10b-5257398ac308" providerId="AD" clId="Web-{7298A54E-B507-B0BE-DC4E-587E9C54C5F7}" dt="2025-06-13T10:35:15.835" v="1020"/>
-        <pc:sldMkLst>
-          <pc:docMk/>
-          <pc:sldMk cId="1834275082" sldId="265"/>
-        </pc:sldMkLst>
-      </pc:sldChg>
-      <pc:sldChg chg="modSp new">
-        <pc:chgData name="Ryan Daniels" userId="S::rkd43@cam.ac.uk::aaa4fbe9-f474-4140-b10b-5257398ac308" providerId="AD" clId="Web-{7298A54E-B507-B0BE-DC4E-587E9C54C5F7}" dt="2025-06-13T11:29:10.661" v="1105" actId="20577"/>
-        <pc:sldMkLst>
-          <pc:docMk/>
-          <pc:sldMk cId="1865729139" sldId="266"/>
-        </pc:sldMkLst>
-      </pc:sldChg>
-    </pc:docChg>
-  </pc:docChgLst>
-  <pc:docChgLst>
-    <pc:chgData name="Ryan Daniels" userId="S::rkd43@cam.ac.uk::aaa4fbe9-f474-4140-b10b-5257398ac308" providerId="AD" clId="Web-{5F819EE1-08D4-61C3-7B5E-537D82061095}"/>
-    <pc:docChg chg="modSld">
-      <pc:chgData name="Ryan Daniels" userId="S::rkd43@cam.ac.uk::aaa4fbe9-f474-4140-b10b-5257398ac308" providerId="AD" clId="Web-{5F819EE1-08D4-61C3-7B5E-537D82061095}" dt="2025-07-30T16:57:24.556" v="1" actId="1076"/>
-      <pc:docMkLst>
-        <pc:docMk/>
-      </pc:docMkLst>
-      <pc:sldChg chg="modSp">
-        <pc:chgData name="Ryan Daniels" userId="S::rkd43@cam.ac.uk::aaa4fbe9-f474-4140-b10b-5257398ac308" providerId="AD" clId="Web-{5F819EE1-08D4-61C3-7B5E-537D82061095}" dt="2025-07-30T16:57:24.556" v="1" actId="1076"/>
-        <pc:sldMkLst>
-          <pc:docMk/>
-          <pc:sldMk cId="570589333" sldId="259"/>
-        </pc:sldMkLst>
-      </pc:sldChg>
     </pc:docChg>
   </pc:docChgLst>
   <pc:docChgLst>
@@ -880,45 +229,6 @@
       <pc:docMkLst>
         <pc:docMk/>
       </pc:docMkLst>
-      <pc:sldChg chg="addSp delSp modSp new del">
-        <pc:chgData name="Ryan Daniels" userId="S::rkd43@cam.ac.uk::aaa4fbe9-f474-4140-b10b-5257398ac308" providerId="AD" clId="Web-{319BC8FD-C455-96ED-2801-3920832F5F55}" dt="2025-09-13T08:47:10.864" v="13"/>
-        <pc:sldMkLst>
-          <pc:docMk/>
-          <pc:sldMk cId="3362305236" sldId="275"/>
-        </pc:sldMkLst>
-        <pc:spChg chg="mod">
-          <ac:chgData name="Ryan Daniels" userId="S::rkd43@cam.ac.uk::aaa4fbe9-f474-4140-b10b-5257398ac308" providerId="AD" clId="Web-{319BC8FD-C455-96ED-2801-3920832F5F55}" dt="2025-09-13T08:44:45.221" v="3" actId="20577"/>
-          <ac:spMkLst>
-            <pc:docMk/>
-            <pc:sldMk cId="3362305236" sldId="275"/>
-            <ac:spMk id="2" creationId="{2363C0B7-87FB-4E91-7E38-615E8140109D}"/>
-          </ac:spMkLst>
-        </pc:spChg>
-        <pc:spChg chg="del mod">
-          <ac:chgData name="Ryan Daniels" userId="S::rkd43@cam.ac.uk::aaa4fbe9-f474-4140-b10b-5257398ac308" providerId="AD" clId="Web-{319BC8FD-C455-96ED-2801-3920832F5F55}" dt="2025-09-13T08:45:20.488" v="5"/>
-          <ac:spMkLst>
-            <pc:docMk/>
-            <pc:sldMk cId="3362305236" sldId="275"/>
-            <ac:spMk id="3" creationId="{9BB34098-0379-9296-50B4-0B1330CB6587}"/>
-          </ac:spMkLst>
-        </pc:spChg>
-        <pc:picChg chg="add mod">
-          <ac:chgData name="Ryan Daniels" userId="S::rkd43@cam.ac.uk::aaa4fbe9-f474-4140-b10b-5257398ac308" providerId="AD" clId="Web-{319BC8FD-C455-96ED-2801-3920832F5F55}" dt="2025-09-13T08:45:31.644" v="9" actId="14100"/>
-          <ac:picMkLst>
-            <pc:docMk/>
-            <pc:sldMk cId="3362305236" sldId="275"/>
-            <ac:picMk id="4" creationId="{C0857385-4310-2005-51E1-570F5346EA66}"/>
-          </ac:picMkLst>
-        </pc:picChg>
-        <pc:picChg chg="add mod">
-          <ac:chgData name="Ryan Daniels" userId="S::rkd43@cam.ac.uk::aaa4fbe9-f474-4140-b10b-5257398ac308" providerId="AD" clId="Web-{319BC8FD-C455-96ED-2801-3920832F5F55}" dt="2025-09-13T08:46:41.082" v="12" actId="1076"/>
-          <ac:picMkLst>
-            <pc:docMk/>
-            <pc:sldMk cId="3362305236" sldId="275"/>
-            <ac:picMk id="5" creationId="{47861EA1-675B-8F61-3B01-F3C485559C4E}"/>
-          </ac:picMkLst>
-        </pc:picChg>
-      </pc:sldChg>
     </pc:docChg>
   </pc:docChgLst>
 </pc:chgInfo>
@@ -1005,7 +315,7 @@
           </a:lstStyle>
           <a:p>
             <a:fld id="{2DE082D9-00CE-4FDC-82D3-FDE16CD37225}" type="datetimeFigureOut">
-              <a:t>9/13/2025</a:t>
+              <a:t>9/30/2025</a:t>
             </a:fld>
             <a:endParaRPr lang="en-US"/>
           </a:p>
@@ -1502,7 +812,7 @@
           <a:p>
             <a:fld id="{C764DE79-268F-4C1A-8933-263129D2AF90}" type="datetimeFigureOut">
               <a:rPr lang="en-US" dirty="0"/>
-              <a:t>9/13/2025</a:t>
+              <a:t>9/30/2025</a:t>
             </a:fld>
             <a:endParaRPr lang="en-US" dirty="0"/>
           </a:p>
@@ -1670,7 +980,7 @@
           <a:p>
             <a:fld id="{C764DE79-268F-4C1A-8933-263129D2AF90}" type="datetimeFigureOut">
               <a:rPr lang="en-US" dirty="0"/>
-              <a:t>9/13/2025</a:t>
+              <a:t>9/30/2025</a:t>
             </a:fld>
             <a:endParaRPr lang="en-US" dirty="0"/>
           </a:p>
@@ -1848,7 +1158,7 @@
           <a:p>
             <a:fld id="{C764DE79-268F-4C1A-8933-263129D2AF90}" type="datetimeFigureOut">
               <a:rPr lang="en-US" dirty="0"/>
-              <a:t>9/13/2025</a:t>
+              <a:t>9/30/2025</a:t>
             </a:fld>
             <a:endParaRPr lang="en-US" dirty="0"/>
           </a:p>
@@ -2016,7 +1326,7 @@
           <a:p>
             <a:fld id="{C764DE79-268F-4C1A-8933-263129D2AF90}" type="datetimeFigureOut">
               <a:rPr lang="en-US" dirty="0"/>
-              <a:t>9/13/2025</a:t>
+              <a:t>9/30/2025</a:t>
             </a:fld>
             <a:endParaRPr lang="en-US" dirty="0"/>
           </a:p>
@@ -2261,7 +1571,7 @@
           <a:p>
             <a:fld id="{C764DE79-268F-4C1A-8933-263129D2AF90}" type="datetimeFigureOut">
               <a:rPr lang="en-US" dirty="0"/>
-              <a:t>9/13/2025</a:t>
+              <a:t>9/30/2025</a:t>
             </a:fld>
             <a:endParaRPr lang="en-US" dirty="0"/>
           </a:p>
@@ -2490,7 +1800,7 @@
           <a:p>
             <a:fld id="{C764DE79-268F-4C1A-8933-263129D2AF90}" type="datetimeFigureOut">
               <a:rPr lang="en-US" dirty="0"/>
-              <a:t>9/13/2025</a:t>
+              <a:t>9/30/2025</a:t>
             </a:fld>
             <a:endParaRPr lang="en-US" dirty="0"/>
           </a:p>
@@ -2854,7 +2164,7 @@
           <a:p>
             <a:fld id="{C764DE79-268F-4C1A-8933-263129D2AF90}" type="datetimeFigureOut">
               <a:rPr lang="en-US" dirty="0"/>
-              <a:t>9/13/2025</a:t>
+              <a:t>9/30/2025</a:t>
             </a:fld>
             <a:endParaRPr lang="en-US" dirty="0"/>
           </a:p>
@@ -2971,7 +2281,7 @@
           <a:p>
             <a:fld id="{C764DE79-268F-4C1A-8933-263129D2AF90}" type="datetimeFigureOut">
               <a:rPr lang="en-US" dirty="0"/>
-              <a:t>9/13/2025</a:t>
+              <a:t>9/30/2025</a:t>
             </a:fld>
             <a:endParaRPr lang="en-US" dirty="0"/>
           </a:p>
@@ -3066,7 +2376,7 @@
           <a:p>
             <a:fld id="{C764DE79-268F-4C1A-8933-263129D2AF90}" type="datetimeFigureOut">
               <a:rPr lang="en-US" dirty="0"/>
-              <a:t>9/13/2025</a:t>
+              <a:t>9/30/2025</a:t>
             </a:fld>
             <a:endParaRPr lang="en-US" dirty="0"/>
           </a:p>
@@ -3341,7 +2651,7 @@
           <a:p>
             <a:fld id="{C764DE79-268F-4C1A-8933-263129D2AF90}" type="datetimeFigureOut">
               <a:rPr lang="en-US" dirty="0"/>
-              <a:t>9/13/2025</a:t>
+              <a:t>9/30/2025</a:t>
             </a:fld>
             <a:endParaRPr lang="en-US" dirty="0"/>
           </a:p>
@@ -3593,7 +2903,7 @@
           <a:p>
             <a:fld id="{C764DE79-268F-4C1A-8933-263129D2AF90}" type="datetimeFigureOut">
               <a:rPr lang="en-US" dirty="0"/>
-              <a:t>9/13/2025</a:t>
+              <a:t>9/30/2025</a:t>
             </a:fld>
             <a:endParaRPr lang="en-US" dirty="0"/>
           </a:p>
@@ -3804,7 +3114,7 @@
           <a:p>
             <a:fld id="{C764DE79-268F-4C1A-8933-263129D2AF90}" type="datetimeFigureOut">
               <a:rPr lang="en-US" dirty="0"/>
-              <a:t>9/13/2025</a:t>
+              <a:t>9/30/2025</a:t>
             </a:fld>
             <a:endParaRPr lang="en-US" dirty="0"/>
           </a:p>
@@ -6265,15 +5575,6 @@
             </a:pPr>
             <a:endParaRPr lang="en-US" dirty="0"/>
           </a:p>
-          <a:p>
-            <a:pPr marL="0" indent="0">
-              <a:buNone/>
-            </a:pPr>
-            <a:r>
-              <a:rPr lang="en-US" dirty="0"/>
-              <a:t>And we'll come back to this idea again, and again...</a:t>
-            </a:r>
-          </a:p>
         </p:txBody>
       </p:sp>
     </p:spTree>
@@ -6323,55 +5624,6 @@
                                           <p:spTgt spid="3">
                                             <p:txEl>
                                               <p:pRg st="2" end="2"/>
-                                            </p:txEl>
-                                          </p:spTgt>
-                                        </p:tgtEl>
-                                        <p:attrNameLst>
-                                          <p:attrName>style.visibility</p:attrName>
-                                        </p:attrNameLst>
-                                      </p:cBhvr>
-                                      <p:to>
-                                        <p:strVal val="visible"/>
-                                      </p:to>
-                                    </p:set>
-                                  </p:childTnLst>
-                                </p:cTn>
-                              </p:par>
-                            </p:childTnLst>
-                          </p:cTn>
-                        </p:par>
-                      </p:childTnLst>
-                    </p:cTn>
-                  </p:par>
-                  <p:par>
-                    <p:cTn id="7" fill="hold">
-                      <p:stCondLst>
-                        <p:cond delay="indefinite"/>
-                      </p:stCondLst>
-                      <p:childTnLst>
-                        <p:par>
-                          <p:cTn id="8" fill="hold">
-                            <p:stCondLst>
-                              <p:cond delay="0"/>
-                            </p:stCondLst>
-                            <p:childTnLst>
-                              <p:par>
-                                <p:cTn id="9" presetID="1" presetClass="entr" presetSubtype="0" fill="hold" grpId="0" nodeType="clickEffect">
-                                  <p:stCondLst>
-                                    <p:cond delay="0"/>
-                                  </p:stCondLst>
-                                  <p:childTnLst>
-                                    <p:set>
-                                      <p:cBhvr>
-                                        <p:cTn id="10" dur="1" fill="hold">
-                                          <p:stCondLst>
-                                            <p:cond delay="0"/>
-                                          </p:stCondLst>
-                                        </p:cTn>
-                                        <p:tgtEl>
-                                          <p:spTgt spid="3">
-                                            <p:txEl>
-                                              <p:pRg st="4" end="4"/>
                                             </p:txEl>
                                           </p:spTgt>
                                         </p:tgtEl>

</xml_diff>

<commit_message>
feat(slides): add intro slides
</commit_message>
<xml_diff>
--- a/slides/1-intro.pptx
+++ b/slides/1-intro.pptx
@@ -315,7 +315,7 @@
           </a:lstStyle>
           <a:p>
             <a:fld id="{2DE082D9-00CE-4FDC-82D3-FDE16CD37225}" type="datetimeFigureOut">
-              <a:t>9/30/2025</a:t>
+              <a:t>4/30/26</a:t>
             </a:fld>
             <a:endParaRPr lang="en-US"/>
           </a:p>
@@ -812,7 +812,7 @@
           <a:p>
             <a:fld id="{C764DE79-268F-4C1A-8933-263129D2AF90}" type="datetimeFigureOut">
               <a:rPr lang="en-US" dirty="0"/>
-              <a:t>9/30/2025</a:t>
+              <a:t>4/30/26</a:t>
             </a:fld>
             <a:endParaRPr lang="en-US" dirty="0"/>
           </a:p>
@@ -980,7 +980,7 @@
           <a:p>
             <a:fld id="{C764DE79-268F-4C1A-8933-263129D2AF90}" type="datetimeFigureOut">
               <a:rPr lang="en-US" dirty="0"/>
-              <a:t>9/30/2025</a:t>
+              <a:t>4/30/26</a:t>
             </a:fld>
             <a:endParaRPr lang="en-US" dirty="0"/>
           </a:p>
@@ -1158,7 +1158,7 @@
           <a:p>
             <a:fld id="{C764DE79-268F-4C1A-8933-263129D2AF90}" type="datetimeFigureOut">
               <a:rPr lang="en-US" dirty="0"/>
-              <a:t>9/30/2025</a:t>
+              <a:t>4/30/26</a:t>
             </a:fld>
             <a:endParaRPr lang="en-US" dirty="0"/>
           </a:p>
@@ -1326,7 +1326,7 @@
           <a:p>
             <a:fld id="{C764DE79-268F-4C1A-8933-263129D2AF90}" type="datetimeFigureOut">
               <a:rPr lang="en-US" dirty="0"/>
-              <a:t>9/30/2025</a:t>
+              <a:t>4/30/26</a:t>
             </a:fld>
             <a:endParaRPr lang="en-US" dirty="0"/>
           </a:p>
@@ -1571,7 +1571,7 @@
           <a:p>
             <a:fld id="{C764DE79-268F-4C1A-8933-263129D2AF90}" type="datetimeFigureOut">
               <a:rPr lang="en-US" dirty="0"/>
-              <a:t>9/30/2025</a:t>
+              <a:t>4/30/26</a:t>
             </a:fld>
             <a:endParaRPr lang="en-US" dirty="0"/>
           </a:p>
@@ -1800,7 +1800,7 @@
           <a:p>
             <a:fld id="{C764DE79-268F-4C1A-8933-263129D2AF90}" type="datetimeFigureOut">
               <a:rPr lang="en-US" dirty="0"/>
-              <a:t>9/30/2025</a:t>
+              <a:t>4/30/26</a:t>
             </a:fld>
             <a:endParaRPr lang="en-US" dirty="0"/>
           </a:p>
@@ -2164,7 +2164,7 @@
           <a:p>
             <a:fld id="{C764DE79-268F-4C1A-8933-263129D2AF90}" type="datetimeFigureOut">
               <a:rPr lang="en-US" dirty="0"/>
-              <a:t>9/30/2025</a:t>
+              <a:t>4/30/26</a:t>
             </a:fld>
             <a:endParaRPr lang="en-US" dirty="0"/>
           </a:p>
@@ -2281,7 +2281,7 @@
           <a:p>
             <a:fld id="{C764DE79-268F-4C1A-8933-263129D2AF90}" type="datetimeFigureOut">
               <a:rPr lang="en-US" dirty="0"/>
-              <a:t>9/30/2025</a:t>
+              <a:t>4/30/26</a:t>
             </a:fld>
             <a:endParaRPr lang="en-US" dirty="0"/>
           </a:p>
@@ -2376,7 +2376,7 @@
           <a:p>
             <a:fld id="{C764DE79-268F-4C1A-8933-263129D2AF90}" type="datetimeFigureOut">
               <a:rPr lang="en-US" dirty="0"/>
-              <a:t>9/30/2025</a:t>
+              <a:t>4/30/26</a:t>
             </a:fld>
             <a:endParaRPr lang="en-US" dirty="0"/>
           </a:p>
@@ -2651,7 +2651,7 @@
           <a:p>
             <a:fld id="{C764DE79-268F-4C1A-8933-263129D2AF90}" type="datetimeFigureOut">
               <a:rPr lang="en-US" dirty="0"/>
-              <a:t>9/30/2025</a:t>
+              <a:t>4/30/26</a:t>
             </a:fld>
             <a:endParaRPr lang="en-US" dirty="0"/>
           </a:p>
@@ -2903,7 +2903,7 @@
           <a:p>
             <a:fld id="{C764DE79-268F-4C1A-8933-263129D2AF90}" type="datetimeFigureOut">
               <a:rPr lang="en-US" dirty="0"/>
-              <a:t>9/30/2025</a:t>
+              <a:t>4/30/26</a:t>
             </a:fld>
             <a:endParaRPr lang="en-US" dirty="0"/>
           </a:p>
@@ -3114,7 +3114,7 @@
           <a:p>
             <a:fld id="{C764DE79-268F-4C1A-8933-263129D2AF90}" type="datetimeFigureOut">
               <a:rPr lang="en-US" dirty="0"/>
-              <a:t>9/30/2025</a:t>
+              <a:t>4/30/26</a:t>
             </a:fld>
             <a:endParaRPr lang="en-US" dirty="0"/>
           </a:p>
@@ -6035,33 +6035,33 @@
           <a:custGeom>
             <a:avLst/>
             <a:gdLst>
-              <a:gd name="connsiteX0" fmla="*/ 0 w 457200"/>
-              <a:gd name="connsiteY0" fmla="*/ 228600 h 457200"/>
-              <a:gd name="connsiteX1" fmla="*/ 228600 w 457200"/>
-              <a:gd name="connsiteY1" fmla="*/ 0 h 457200"/>
-              <a:gd name="connsiteX2" fmla="*/ 457200 w 457200"/>
-              <a:gd name="connsiteY2" fmla="*/ 228600 h 457200"/>
-              <a:gd name="connsiteX3" fmla="*/ 228600 w 457200"/>
-              <a:gd name="connsiteY3" fmla="*/ 457200 h 457200"/>
-              <a:gd name="connsiteX4" fmla="*/ 0 w 457200"/>
-              <a:gd name="connsiteY4" fmla="*/ 228600 h 457200"/>
+              <a:gd name="csX0" fmla="*/ 0 w 457200"/>
+              <a:gd name="csY0" fmla="*/ 228600 h 457200"/>
+              <a:gd name="csX1" fmla="*/ 228600 w 457200"/>
+              <a:gd name="csY1" fmla="*/ 0 h 457200"/>
+              <a:gd name="csX2" fmla="*/ 457200 w 457200"/>
+              <a:gd name="csY2" fmla="*/ 228600 h 457200"/>
+              <a:gd name="csX3" fmla="*/ 228600 w 457200"/>
+              <a:gd name="csY3" fmla="*/ 457200 h 457200"/>
+              <a:gd name="csX4" fmla="*/ 0 w 457200"/>
+              <a:gd name="csY4" fmla="*/ 228600 h 457200"/>
             </a:gdLst>
             <a:ahLst/>
             <a:cxnLst>
               <a:cxn ang="0">
-                <a:pos x="connsiteX0" y="connsiteY0"/>
-              </a:cxn>
-              <a:cxn ang="0">
-                <a:pos x="connsiteX1" y="connsiteY1"/>
-              </a:cxn>
-              <a:cxn ang="0">
-                <a:pos x="connsiteX2" y="connsiteY2"/>
-              </a:cxn>
-              <a:cxn ang="0">
-                <a:pos x="connsiteX3" y="connsiteY3"/>
-              </a:cxn>
-              <a:cxn ang="0">
-                <a:pos x="connsiteX4" y="connsiteY4"/>
+                <a:pos x="csX0" y="csY0"/>
+              </a:cxn>
+              <a:cxn ang="0">
+                <a:pos x="csX1" y="csY1"/>
+              </a:cxn>
+              <a:cxn ang="0">
+                <a:pos x="csX2" y="csY2"/>
+              </a:cxn>
+              <a:cxn ang="0">
+                <a:pos x="csX3" y="csY3"/>
+              </a:cxn>
+              <a:cxn ang="0">
+                <a:pos x="csX4" y="csY4"/>
               </a:cxn>
             </a:cxnLst>
             <a:rect l="l" t="t" r="r" b="b"/>
@@ -6302,33 +6302,33 @@
           <a:custGeom>
             <a:avLst/>
             <a:gdLst>
-              <a:gd name="connsiteX0" fmla="*/ 0 w 457200"/>
-              <a:gd name="connsiteY0" fmla="*/ 228600 h 457200"/>
-              <a:gd name="connsiteX1" fmla="*/ 228600 w 457200"/>
-              <a:gd name="connsiteY1" fmla="*/ 0 h 457200"/>
-              <a:gd name="connsiteX2" fmla="*/ 457200 w 457200"/>
-              <a:gd name="connsiteY2" fmla="*/ 228600 h 457200"/>
-              <a:gd name="connsiteX3" fmla="*/ 228600 w 457200"/>
-              <a:gd name="connsiteY3" fmla="*/ 457200 h 457200"/>
-              <a:gd name="connsiteX4" fmla="*/ 0 w 457200"/>
-              <a:gd name="connsiteY4" fmla="*/ 228600 h 457200"/>
+              <a:gd name="csX0" fmla="*/ 0 w 457200"/>
+              <a:gd name="csY0" fmla="*/ 228600 h 457200"/>
+              <a:gd name="csX1" fmla="*/ 228600 w 457200"/>
+              <a:gd name="csY1" fmla="*/ 0 h 457200"/>
+              <a:gd name="csX2" fmla="*/ 457200 w 457200"/>
+              <a:gd name="csY2" fmla="*/ 228600 h 457200"/>
+              <a:gd name="csX3" fmla="*/ 228600 w 457200"/>
+              <a:gd name="csY3" fmla="*/ 457200 h 457200"/>
+              <a:gd name="csX4" fmla="*/ 0 w 457200"/>
+              <a:gd name="csY4" fmla="*/ 228600 h 457200"/>
             </a:gdLst>
             <a:ahLst/>
             <a:cxnLst>
               <a:cxn ang="0">
-                <a:pos x="connsiteX0" y="connsiteY0"/>
-              </a:cxn>
-              <a:cxn ang="0">
-                <a:pos x="connsiteX1" y="connsiteY1"/>
-              </a:cxn>
-              <a:cxn ang="0">
-                <a:pos x="connsiteX2" y="connsiteY2"/>
-              </a:cxn>
-              <a:cxn ang="0">
-                <a:pos x="connsiteX3" y="connsiteY3"/>
-              </a:cxn>
-              <a:cxn ang="0">
-                <a:pos x="connsiteX4" y="connsiteY4"/>
+                <a:pos x="csX0" y="csY0"/>
+              </a:cxn>
+              <a:cxn ang="0">
+                <a:pos x="csX1" y="csY1"/>
+              </a:cxn>
+              <a:cxn ang="0">
+                <a:pos x="csX2" y="csY2"/>
+              </a:cxn>
+              <a:cxn ang="0">
+                <a:pos x="csX3" y="csY3"/>
+              </a:cxn>
+              <a:cxn ang="0">
+                <a:pos x="csX4" y="csY4"/>
               </a:cxn>
             </a:cxnLst>
             <a:rect l="l" t="t" r="r" b="b"/>
@@ -6448,33 +6448,33 @@
           <a:custGeom>
             <a:avLst/>
             <a:gdLst>
-              <a:gd name="connsiteX0" fmla="*/ 0 w 457200"/>
-              <a:gd name="connsiteY0" fmla="*/ 228600 h 457200"/>
-              <a:gd name="connsiteX1" fmla="*/ 228600 w 457200"/>
-              <a:gd name="connsiteY1" fmla="*/ 0 h 457200"/>
-              <a:gd name="connsiteX2" fmla="*/ 457200 w 457200"/>
-              <a:gd name="connsiteY2" fmla="*/ 228600 h 457200"/>
-              <a:gd name="connsiteX3" fmla="*/ 228600 w 457200"/>
-              <a:gd name="connsiteY3" fmla="*/ 457200 h 457200"/>
-              <a:gd name="connsiteX4" fmla="*/ 0 w 457200"/>
-              <a:gd name="connsiteY4" fmla="*/ 228600 h 457200"/>
+              <a:gd name="csX0" fmla="*/ 0 w 457200"/>
+              <a:gd name="csY0" fmla="*/ 228600 h 457200"/>
+              <a:gd name="csX1" fmla="*/ 228600 w 457200"/>
+              <a:gd name="csY1" fmla="*/ 0 h 457200"/>
+              <a:gd name="csX2" fmla="*/ 457200 w 457200"/>
+              <a:gd name="csY2" fmla="*/ 228600 h 457200"/>
+              <a:gd name="csX3" fmla="*/ 228600 w 457200"/>
+              <a:gd name="csY3" fmla="*/ 457200 h 457200"/>
+              <a:gd name="csX4" fmla="*/ 0 w 457200"/>
+              <a:gd name="csY4" fmla="*/ 228600 h 457200"/>
             </a:gdLst>
             <a:ahLst/>
             <a:cxnLst>
               <a:cxn ang="0">
-                <a:pos x="connsiteX0" y="connsiteY0"/>
-              </a:cxn>
-              <a:cxn ang="0">
-                <a:pos x="connsiteX1" y="connsiteY1"/>
-              </a:cxn>
-              <a:cxn ang="0">
-                <a:pos x="connsiteX2" y="connsiteY2"/>
-              </a:cxn>
-              <a:cxn ang="0">
-                <a:pos x="connsiteX3" y="connsiteY3"/>
-              </a:cxn>
-              <a:cxn ang="0">
-                <a:pos x="connsiteX4" y="connsiteY4"/>
+                <a:pos x="csX0" y="csY0"/>
+              </a:cxn>
+              <a:cxn ang="0">
+                <a:pos x="csX1" y="csY1"/>
+              </a:cxn>
+              <a:cxn ang="0">
+                <a:pos x="csX2" y="csY2"/>
+              </a:cxn>
+              <a:cxn ang="0">
+                <a:pos x="csX3" y="csY3"/>
+              </a:cxn>
+              <a:cxn ang="0">
+                <a:pos x="csX4" y="csY4"/>
               </a:cxn>
             </a:cxnLst>
             <a:rect l="l" t="t" r="r" b="b"/>
@@ -6594,33 +6594,33 @@
           <a:custGeom>
             <a:avLst/>
             <a:gdLst>
-              <a:gd name="connsiteX0" fmla="*/ 0 w 457200"/>
-              <a:gd name="connsiteY0" fmla="*/ 228600 h 457200"/>
-              <a:gd name="connsiteX1" fmla="*/ 228600 w 457200"/>
-              <a:gd name="connsiteY1" fmla="*/ 0 h 457200"/>
-              <a:gd name="connsiteX2" fmla="*/ 457200 w 457200"/>
-              <a:gd name="connsiteY2" fmla="*/ 228600 h 457200"/>
-              <a:gd name="connsiteX3" fmla="*/ 228600 w 457200"/>
-              <a:gd name="connsiteY3" fmla="*/ 457200 h 457200"/>
-              <a:gd name="connsiteX4" fmla="*/ 0 w 457200"/>
-              <a:gd name="connsiteY4" fmla="*/ 228600 h 457200"/>
+              <a:gd name="csX0" fmla="*/ 0 w 457200"/>
+              <a:gd name="csY0" fmla="*/ 228600 h 457200"/>
+              <a:gd name="csX1" fmla="*/ 228600 w 457200"/>
+              <a:gd name="csY1" fmla="*/ 0 h 457200"/>
+              <a:gd name="csX2" fmla="*/ 457200 w 457200"/>
+              <a:gd name="csY2" fmla="*/ 228600 h 457200"/>
+              <a:gd name="csX3" fmla="*/ 228600 w 457200"/>
+              <a:gd name="csY3" fmla="*/ 457200 h 457200"/>
+              <a:gd name="csX4" fmla="*/ 0 w 457200"/>
+              <a:gd name="csY4" fmla="*/ 228600 h 457200"/>
             </a:gdLst>
             <a:ahLst/>
             <a:cxnLst>
               <a:cxn ang="0">
-                <a:pos x="connsiteX0" y="connsiteY0"/>
-              </a:cxn>
-              <a:cxn ang="0">
-                <a:pos x="connsiteX1" y="connsiteY1"/>
-              </a:cxn>
-              <a:cxn ang="0">
-                <a:pos x="connsiteX2" y="connsiteY2"/>
-              </a:cxn>
-              <a:cxn ang="0">
-                <a:pos x="connsiteX3" y="connsiteY3"/>
-              </a:cxn>
-              <a:cxn ang="0">
-                <a:pos x="connsiteX4" y="connsiteY4"/>
+                <a:pos x="csX0" y="csY0"/>
+              </a:cxn>
+              <a:cxn ang="0">
+                <a:pos x="csX1" y="csY1"/>
+              </a:cxn>
+              <a:cxn ang="0">
+                <a:pos x="csX2" y="csY2"/>
+              </a:cxn>
+              <a:cxn ang="0">
+                <a:pos x="csX3" y="csY3"/>
+              </a:cxn>
+              <a:cxn ang="0">
+                <a:pos x="csX4" y="csY4"/>
               </a:cxn>
             </a:cxnLst>
             <a:rect l="l" t="t" r="r" b="b"/>
@@ -6740,33 +6740,33 @@
           <a:custGeom>
             <a:avLst/>
             <a:gdLst>
-              <a:gd name="connsiteX0" fmla="*/ 0 w 457200"/>
-              <a:gd name="connsiteY0" fmla="*/ 228600 h 457200"/>
-              <a:gd name="connsiteX1" fmla="*/ 228600 w 457200"/>
-              <a:gd name="connsiteY1" fmla="*/ 0 h 457200"/>
-              <a:gd name="connsiteX2" fmla="*/ 457200 w 457200"/>
-              <a:gd name="connsiteY2" fmla="*/ 228600 h 457200"/>
-              <a:gd name="connsiteX3" fmla="*/ 228600 w 457200"/>
-              <a:gd name="connsiteY3" fmla="*/ 457200 h 457200"/>
-              <a:gd name="connsiteX4" fmla="*/ 0 w 457200"/>
-              <a:gd name="connsiteY4" fmla="*/ 228600 h 457200"/>
+              <a:gd name="csX0" fmla="*/ 0 w 457200"/>
+              <a:gd name="csY0" fmla="*/ 228600 h 457200"/>
+              <a:gd name="csX1" fmla="*/ 228600 w 457200"/>
+              <a:gd name="csY1" fmla="*/ 0 h 457200"/>
+              <a:gd name="csX2" fmla="*/ 457200 w 457200"/>
+              <a:gd name="csY2" fmla="*/ 228600 h 457200"/>
+              <a:gd name="csX3" fmla="*/ 228600 w 457200"/>
+              <a:gd name="csY3" fmla="*/ 457200 h 457200"/>
+              <a:gd name="csX4" fmla="*/ 0 w 457200"/>
+              <a:gd name="csY4" fmla="*/ 228600 h 457200"/>
             </a:gdLst>
             <a:ahLst/>
             <a:cxnLst>
               <a:cxn ang="0">
-                <a:pos x="connsiteX0" y="connsiteY0"/>
-              </a:cxn>
-              <a:cxn ang="0">
-                <a:pos x="connsiteX1" y="connsiteY1"/>
-              </a:cxn>
-              <a:cxn ang="0">
-                <a:pos x="connsiteX2" y="connsiteY2"/>
-              </a:cxn>
-              <a:cxn ang="0">
-                <a:pos x="connsiteX3" y="connsiteY3"/>
-              </a:cxn>
-              <a:cxn ang="0">
-                <a:pos x="connsiteX4" y="connsiteY4"/>
+                <a:pos x="csX0" y="csY0"/>
+              </a:cxn>
+              <a:cxn ang="0">
+                <a:pos x="csX1" y="csY1"/>
+              </a:cxn>
+              <a:cxn ang="0">
+                <a:pos x="csX2" y="csY2"/>
+              </a:cxn>
+              <a:cxn ang="0">
+                <a:pos x="csX3" y="csY3"/>
+              </a:cxn>
+              <a:cxn ang="0">
+                <a:pos x="csX4" y="csY4"/>
               </a:cxn>
             </a:cxnLst>
             <a:rect l="l" t="t" r="r" b="b"/>
@@ -6886,33 +6886,33 @@
           <a:custGeom>
             <a:avLst/>
             <a:gdLst>
-              <a:gd name="connsiteX0" fmla="*/ 0 w 457200"/>
-              <a:gd name="connsiteY0" fmla="*/ 228600 h 457200"/>
-              <a:gd name="connsiteX1" fmla="*/ 228600 w 457200"/>
-              <a:gd name="connsiteY1" fmla="*/ 0 h 457200"/>
-              <a:gd name="connsiteX2" fmla="*/ 457200 w 457200"/>
-              <a:gd name="connsiteY2" fmla="*/ 228600 h 457200"/>
-              <a:gd name="connsiteX3" fmla="*/ 228600 w 457200"/>
-              <a:gd name="connsiteY3" fmla="*/ 457200 h 457200"/>
-              <a:gd name="connsiteX4" fmla="*/ 0 w 457200"/>
-              <a:gd name="connsiteY4" fmla="*/ 228600 h 457200"/>
+              <a:gd name="csX0" fmla="*/ 0 w 457200"/>
+              <a:gd name="csY0" fmla="*/ 228600 h 457200"/>
+              <a:gd name="csX1" fmla="*/ 228600 w 457200"/>
+              <a:gd name="csY1" fmla="*/ 0 h 457200"/>
+              <a:gd name="csX2" fmla="*/ 457200 w 457200"/>
+              <a:gd name="csY2" fmla="*/ 228600 h 457200"/>
+              <a:gd name="csX3" fmla="*/ 228600 w 457200"/>
+              <a:gd name="csY3" fmla="*/ 457200 h 457200"/>
+              <a:gd name="csX4" fmla="*/ 0 w 457200"/>
+              <a:gd name="csY4" fmla="*/ 228600 h 457200"/>
             </a:gdLst>
             <a:ahLst/>
             <a:cxnLst>
               <a:cxn ang="0">
-                <a:pos x="connsiteX0" y="connsiteY0"/>
-              </a:cxn>
-              <a:cxn ang="0">
-                <a:pos x="connsiteX1" y="connsiteY1"/>
-              </a:cxn>
-              <a:cxn ang="0">
-                <a:pos x="connsiteX2" y="connsiteY2"/>
-              </a:cxn>
-              <a:cxn ang="0">
-                <a:pos x="connsiteX3" y="connsiteY3"/>
-              </a:cxn>
-              <a:cxn ang="0">
-                <a:pos x="connsiteX4" y="connsiteY4"/>
+                <a:pos x="csX0" y="csY0"/>
+              </a:cxn>
+              <a:cxn ang="0">
+                <a:pos x="csX1" y="csY1"/>
+              </a:cxn>
+              <a:cxn ang="0">
+                <a:pos x="csX2" y="csY2"/>
+              </a:cxn>
+              <a:cxn ang="0">
+                <a:pos x="csX3" y="csY3"/>
+              </a:cxn>
+              <a:cxn ang="0">
+                <a:pos x="csX4" y="csY4"/>
               </a:cxn>
             </a:cxnLst>
             <a:rect l="l" t="t" r="r" b="b"/>
@@ -7032,33 +7032,33 @@
           <a:custGeom>
             <a:avLst/>
             <a:gdLst>
-              <a:gd name="connsiteX0" fmla="*/ 0 w 457200"/>
-              <a:gd name="connsiteY0" fmla="*/ 228600 h 457200"/>
-              <a:gd name="connsiteX1" fmla="*/ 228600 w 457200"/>
-              <a:gd name="connsiteY1" fmla="*/ 0 h 457200"/>
-              <a:gd name="connsiteX2" fmla="*/ 457200 w 457200"/>
-              <a:gd name="connsiteY2" fmla="*/ 228600 h 457200"/>
-              <a:gd name="connsiteX3" fmla="*/ 228600 w 457200"/>
-              <a:gd name="connsiteY3" fmla="*/ 457200 h 457200"/>
-              <a:gd name="connsiteX4" fmla="*/ 0 w 457200"/>
-              <a:gd name="connsiteY4" fmla="*/ 228600 h 457200"/>
+              <a:gd name="csX0" fmla="*/ 0 w 457200"/>
+              <a:gd name="csY0" fmla="*/ 228600 h 457200"/>
+              <a:gd name="csX1" fmla="*/ 228600 w 457200"/>
+              <a:gd name="csY1" fmla="*/ 0 h 457200"/>
+              <a:gd name="csX2" fmla="*/ 457200 w 457200"/>
+              <a:gd name="csY2" fmla="*/ 228600 h 457200"/>
+              <a:gd name="csX3" fmla="*/ 228600 w 457200"/>
+              <a:gd name="csY3" fmla="*/ 457200 h 457200"/>
+              <a:gd name="csX4" fmla="*/ 0 w 457200"/>
+              <a:gd name="csY4" fmla="*/ 228600 h 457200"/>
             </a:gdLst>
             <a:ahLst/>
             <a:cxnLst>
               <a:cxn ang="0">
-                <a:pos x="connsiteX0" y="connsiteY0"/>
-              </a:cxn>
-              <a:cxn ang="0">
-                <a:pos x="connsiteX1" y="connsiteY1"/>
-              </a:cxn>
-              <a:cxn ang="0">
-                <a:pos x="connsiteX2" y="connsiteY2"/>
-              </a:cxn>
-              <a:cxn ang="0">
-                <a:pos x="connsiteX3" y="connsiteY3"/>
-              </a:cxn>
-              <a:cxn ang="0">
-                <a:pos x="connsiteX4" y="connsiteY4"/>
+                <a:pos x="csX0" y="csY0"/>
+              </a:cxn>
+              <a:cxn ang="0">
+                <a:pos x="csX1" y="csY1"/>
+              </a:cxn>
+              <a:cxn ang="0">
+                <a:pos x="csX2" y="csY2"/>
+              </a:cxn>
+              <a:cxn ang="0">
+                <a:pos x="csX3" y="csY3"/>
+              </a:cxn>
+              <a:cxn ang="0">
+                <a:pos x="csX4" y="csY4"/>
               </a:cxn>
             </a:cxnLst>
             <a:rect l="l" t="t" r="r" b="b"/>
@@ -7178,33 +7178,33 @@
           <a:custGeom>
             <a:avLst/>
             <a:gdLst>
-              <a:gd name="connsiteX0" fmla="*/ 0 w 457200"/>
-              <a:gd name="connsiteY0" fmla="*/ 228600 h 457200"/>
-              <a:gd name="connsiteX1" fmla="*/ 228600 w 457200"/>
-              <a:gd name="connsiteY1" fmla="*/ 0 h 457200"/>
-              <a:gd name="connsiteX2" fmla="*/ 457200 w 457200"/>
-              <a:gd name="connsiteY2" fmla="*/ 228600 h 457200"/>
-              <a:gd name="connsiteX3" fmla="*/ 228600 w 457200"/>
-              <a:gd name="connsiteY3" fmla="*/ 457200 h 457200"/>
-              <a:gd name="connsiteX4" fmla="*/ 0 w 457200"/>
-              <a:gd name="connsiteY4" fmla="*/ 228600 h 457200"/>
+              <a:gd name="csX0" fmla="*/ 0 w 457200"/>
+              <a:gd name="csY0" fmla="*/ 228600 h 457200"/>
+              <a:gd name="csX1" fmla="*/ 228600 w 457200"/>
+              <a:gd name="csY1" fmla="*/ 0 h 457200"/>
+              <a:gd name="csX2" fmla="*/ 457200 w 457200"/>
+              <a:gd name="csY2" fmla="*/ 228600 h 457200"/>
+              <a:gd name="csX3" fmla="*/ 228600 w 457200"/>
+              <a:gd name="csY3" fmla="*/ 457200 h 457200"/>
+              <a:gd name="csX4" fmla="*/ 0 w 457200"/>
+              <a:gd name="csY4" fmla="*/ 228600 h 457200"/>
             </a:gdLst>
             <a:ahLst/>
             <a:cxnLst>
               <a:cxn ang="0">
-                <a:pos x="connsiteX0" y="connsiteY0"/>
-              </a:cxn>
-              <a:cxn ang="0">
-                <a:pos x="connsiteX1" y="connsiteY1"/>
-              </a:cxn>
-              <a:cxn ang="0">
-                <a:pos x="connsiteX2" y="connsiteY2"/>
-              </a:cxn>
-              <a:cxn ang="0">
-                <a:pos x="connsiteX3" y="connsiteY3"/>
-              </a:cxn>
-              <a:cxn ang="0">
-                <a:pos x="connsiteX4" y="connsiteY4"/>
+                <a:pos x="csX0" y="csY0"/>
+              </a:cxn>
+              <a:cxn ang="0">
+                <a:pos x="csX1" y="csY1"/>
+              </a:cxn>
+              <a:cxn ang="0">
+                <a:pos x="csX2" y="csY2"/>
+              </a:cxn>
+              <a:cxn ang="0">
+                <a:pos x="csX3" y="csY3"/>
+              </a:cxn>
+              <a:cxn ang="0">
+                <a:pos x="csX4" y="csY4"/>
               </a:cxn>
             </a:cxnLst>
             <a:rect l="l" t="t" r="r" b="b"/>
@@ -7324,63 +7324,63 @@
           <a:custGeom>
             <a:avLst/>
             <a:gdLst>
-              <a:gd name="connsiteX0" fmla="*/ 0 w 2333625"/>
-              <a:gd name="connsiteY0" fmla="*/ 0 h 369332"/>
-              <a:gd name="connsiteX1" fmla="*/ 583406 w 2333625"/>
-              <a:gd name="connsiteY1" fmla="*/ 0 h 369332"/>
-              <a:gd name="connsiteX2" fmla="*/ 1213485 w 2333625"/>
-              <a:gd name="connsiteY2" fmla="*/ 0 h 369332"/>
-              <a:gd name="connsiteX3" fmla="*/ 1773555 w 2333625"/>
-              <a:gd name="connsiteY3" fmla="*/ 0 h 369332"/>
-              <a:gd name="connsiteX4" fmla="*/ 2333625 w 2333625"/>
-              <a:gd name="connsiteY4" fmla="*/ 0 h 369332"/>
-              <a:gd name="connsiteX5" fmla="*/ 2333625 w 2333625"/>
-              <a:gd name="connsiteY5" fmla="*/ 369332 h 369332"/>
-              <a:gd name="connsiteX6" fmla="*/ 1703546 w 2333625"/>
-              <a:gd name="connsiteY6" fmla="*/ 369332 h 369332"/>
-              <a:gd name="connsiteX7" fmla="*/ 1143476 w 2333625"/>
-              <a:gd name="connsiteY7" fmla="*/ 369332 h 369332"/>
-              <a:gd name="connsiteX8" fmla="*/ 583406 w 2333625"/>
-              <a:gd name="connsiteY8" fmla="*/ 369332 h 369332"/>
-              <a:gd name="connsiteX9" fmla="*/ 0 w 2333625"/>
-              <a:gd name="connsiteY9" fmla="*/ 369332 h 369332"/>
-              <a:gd name="connsiteX10" fmla="*/ 0 w 2333625"/>
-              <a:gd name="connsiteY10" fmla="*/ 0 h 369332"/>
+              <a:gd name="csX0" fmla="*/ 0 w 2333625"/>
+              <a:gd name="csY0" fmla="*/ 0 h 369332"/>
+              <a:gd name="csX1" fmla="*/ 583406 w 2333625"/>
+              <a:gd name="csY1" fmla="*/ 0 h 369332"/>
+              <a:gd name="csX2" fmla="*/ 1213485 w 2333625"/>
+              <a:gd name="csY2" fmla="*/ 0 h 369332"/>
+              <a:gd name="csX3" fmla="*/ 1773555 w 2333625"/>
+              <a:gd name="csY3" fmla="*/ 0 h 369332"/>
+              <a:gd name="csX4" fmla="*/ 2333625 w 2333625"/>
+              <a:gd name="csY4" fmla="*/ 0 h 369332"/>
+              <a:gd name="csX5" fmla="*/ 2333625 w 2333625"/>
+              <a:gd name="csY5" fmla="*/ 369332 h 369332"/>
+              <a:gd name="csX6" fmla="*/ 1703546 w 2333625"/>
+              <a:gd name="csY6" fmla="*/ 369332 h 369332"/>
+              <a:gd name="csX7" fmla="*/ 1143476 w 2333625"/>
+              <a:gd name="csY7" fmla="*/ 369332 h 369332"/>
+              <a:gd name="csX8" fmla="*/ 583406 w 2333625"/>
+              <a:gd name="csY8" fmla="*/ 369332 h 369332"/>
+              <a:gd name="csX9" fmla="*/ 0 w 2333625"/>
+              <a:gd name="csY9" fmla="*/ 369332 h 369332"/>
+              <a:gd name="csX10" fmla="*/ 0 w 2333625"/>
+              <a:gd name="csY10" fmla="*/ 0 h 369332"/>
             </a:gdLst>
             <a:ahLst/>
             <a:cxnLst>
               <a:cxn ang="0">
-                <a:pos x="connsiteX0" y="connsiteY0"/>
-              </a:cxn>
-              <a:cxn ang="0">
-                <a:pos x="connsiteX1" y="connsiteY1"/>
-              </a:cxn>
-              <a:cxn ang="0">
-                <a:pos x="connsiteX2" y="connsiteY2"/>
-              </a:cxn>
-              <a:cxn ang="0">
-                <a:pos x="connsiteX3" y="connsiteY3"/>
-              </a:cxn>
-              <a:cxn ang="0">
-                <a:pos x="connsiteX4" y="connsiteY4"/>
-              </a:cxn>
-              <a:cxn ang="0">
-                <a:pos x="connsiteX5" y="connsiteY5"/>
-              </a:cxn>
-              <a:cxn ang="0">
-                <a:pos x="connsiteX6" y="connsiteY6"/>
-              </a:cxn>
-              <a:cxn ang="0">
-                <a:pos x="connsiteX7" y="connsiteY7"/>
-              </a:cxn>
-              <a:cxn ang="0">
-                <a:pos x="connsiteX8" y="connsiteY8"/>
-              </a:cxn>
-              <a:cxn ang="0">
-                <a:pos x="connsiteX9" y="connsiteY9"/>
-              </a:cxn>
-              <a:cxn ang="0">
-                <a:pos x="connsiteX10" y="connsiteY10"/>
+                <a:pos x="csX0" y="csY0"/>
+              </a:cxn>
+              <a:cxn ang="0">
+                <a:pos x="csX1" y="csY1"/>
+              </a:cxn>
+              <a:cxn ang="0">
+                <a:pos x="csX2" y="csY2"/>
+              </a:cxn>
+              <a:cxn ang="0">
+                <a:pos x="csX3" y="csY3"/>
+              </a:cxn>
+              <a:cxn ang="0">
+                <a:pos x="csX4" y="csY4"/>
+              </a:cxn>
+              <a:cxn ang="0">
+                <a:pos x="csX5" y="csY5"/>
+              </a:cxn>
+              <a:cxn ang="0">
+                <a:pos x="csX6" y="csY6"/>
+              </a:cxn>
+              <a:cxn ang="0">
+                <a:pos x="csX7" y="csY7"/>
+              </a:cxn>
+              <a:cxn ang="0">
+                <a:pos x="csX8" y="csY8"/>
+              </a:cxn>
+              <a:cxn ang="0">
+                <a:pos x="csX9" y="csY9"/>
+              </a:cxn>
+              <a:cxn ang="0">
+                <a:pos x="csX10" y="csY10"/>
               </a:cxn>
             </a:cxnLst>
             <a:rect l="l" t="t" r="r" b="b"/>
@@ -7565,63 +7565,63 @@
           <a:custGeom>
             <a:avLst/>
             <a:gdLst>
-              <a:gd name="connsiteX0" fmla="*/ 0 w 2333625"/>
-              <a:gd name="connsiteY0" fmla="*/ 0 h 369332"/>
-              <a:gd name="connsiteX1" fmla="*/ 583406 w 2333625"/>
-              <a:gd name="connsiteY1" fmla="*/ 0 h 369332"/>
-              <a:gd name="connsiteX2" fmla="*/ 1213485 w 2333625"/>
-              <a:gd name="connsiteY2" fmla="*/ 0 h 369332"/>
-              <a:gd name="connsiteX3" fmla="*/ 1773555 w 2333625"/>
-              <a:gd name="connsiteY3" fmla="*/ 0 h 369332"/>
-              <a:gd name="connsiteX4" fmla="*/ 2333625 w 2333625"/>
-              <a:gd name="connsiteY4" fmla="*/ 0 h 369332"/>
-              <a:gd name="connsiteX5" fmla="*/ 2333625 w 2333625"/>
-              <a:gd name="connsiteY5" fmla="*/ 369332 h 369332"/>
-              <a:gd name="connsiteX6" fmla="*/ 1703546 w 2333625"/>
-              <a:gd name="connsiteY6" fmla="*/ 369332 h 369332"/>
-              <a:gd name="connsiteX7" fmla="*/ 1143476 w 2333625"/>
-              <a:gd name="connsiteY7" fmla="*/ 369332 h 369332"/>
-              <a:gd name="connsiteX8" fmla="*/ 583406 w 2333625"/>
-              <a:gd name="connsiteY8" fmla="*/ 369332 h 369332"/>
-              <a:gd name="connsiteX9" fmla="*/ 0 w 2333625"/>
-              <a:gd name="connsiteY9" fmla="*/ 369332 h 369332"/>
-              <a:gd name="connsiteX10" fmla="*/ 0 w 2333625"/>
-              <a:gd name="connsiteY10" fmla="*/ 0 h 369332"/>
+              <a:gd name="csX0" fmla="*/ 0 w 2333625"/>
+              <a:gd name="csY0" fmla="*/ 0 h 369332"/>
+              <a:gd name="csX1" fmla="*/ 583406 w 2333625"/>
+              <a:gd name="csY1" fmla="*/ 0 h 369332"/>
+              <a:gd name="csX2" fmla="*/ 1213485 w 2333625"/>
+              <a:gd name="csY2" fmla="*/ 0 h 369332"/>
+              <a:gd name="csX3" fmla="*/ 1773555 w 2333625"/>
+              <a:gd name="csY3" fmla="*/ 0 h 369332"/>
+              <a:gd name="csX4" fmla="*/ 2333625 w 2333625"/>
+              <a:gd name="csY4" fmla="*/ 0 h 369332"/>
+              <a:gd name="csX5" fmla="*/ 2333625 w 2333625"/>
+              <a:gd name="csY5" fmla="*/ 369332 h 369332"/>
+              <a:gd name="csX6" fmla="*/ 1703546 w 2333625"/>
+              <a:gd name="csY6" fmla="*/ 369332 h 369332"/>
+              <a:gd name="csX7" fmla="*/ 1143476 w 2333625"/>
+              <a:gd name="csY7" fmla="*/ 369332 h 369332"/>
+              <a:gd name="csX8" fmla="*/ 583406 w 2333625"/>
+              <a:gd name="csY8" fmla="*/ 369332 h 369332"/>
+              <a:gd name="csX9" fmla="*/ 0 w 2333625"/>
+              <a:gd name="csY9" fmla="*/ 369332 h 369332"/>
+              <a:gd name="csX10" fmla="*/ 0 w 2333625"/>
+              <a:gd name="csY10" fmla="*/ 0 h 369332"/>
             </a:gdLst>
             <a:ahLst/>
             <a:cxnLst>
               <a:cxn ang="0">
-                <a:pos x="connsiteX0" y="connsiteY0"/>
-              </a:cxn>
-              <a:cxn ang="0">
-                <a:pos x="connsiteX1" y="connsiteY1"/>
-              </a:cxn>
-              <a:cxn ang="0">
-                <a:pos x="connsiteX2" y="connsiteY2"/>
-              </a:cxn>
-              <a:cxn ang="0">
-                <a:pos x="connsiteX3" y="connsiteY3"/>
-              </a:cxn>
-              <a:cxn ang="0">
-                <a:pos x="connsiteX4" y="connsiteY4"/>
-              </a:cxn>
-              <a:cxn ang="0">
-                <a:pos x="connsiteX5" y="connsiteY5"/>
-              </a:cxn>
-              <a:cxn ang="0">
-                <a:pos x="connsiteX6" y="connsiteY6"/>
-              </a:cxn>
-              <a:cxn ang="0">
-                <a:pos x="connsiteX7" y="connsiteY7"/>
-              </a:cxn>
-              <a:cxn ang="0">
-                <a:pos x="connsiteX8" y="connsiteY8"/>
-              </a:cxn>
-              <a:cxn ang="0">
-                <a:pos x="connsiteX9" y="connsiteY9"/>
-              </a:cxn>
-              <a:cxn ang="0">
-                <a:pos x="connsiteX10" y="connsiteY10"/>
+                <a:pos x="csX0" y="csY0"/>
+              </a:cxn>
+              <a:cxn ang="0">
+                <a:pos x="csX1" y="csY1"/>
+              </a:cxn>
+              <a:cxn ang="0">
+                <a:pos x="csX2" y="csY2"/>
+              </a:cxn>
+              <a:cxn ang="0">
+                <a:pos x="csX3" y="csY3"/>
+              </a:cxn>
+              <a:cxn ang="0">
+                <a:pos x="csX4" y="csY4"/>
+              </a:cxn>
+              <a:cxn ang="0">
+                <a:pos x="csX5" y="csY5"/>
+              </a:cxn>
+              <a:cxn ang="0">
+                <a:pos x="csX6" y="csY6"/>
+              </a:cxn>
+              <a:cxn ang="0">
+                <a:pos x="csX7" y="csY7"/>
+              </a:cxn>
+              <a:cxn ang="0">
+                <a:pos x="csX8" y="csY8"/>
+              </a:cxn>
+              <a:cxn ang="0">
+                <a:pos x="csX9" y="csY9"/>
+              </a:cxn>
+              <a:cxn ang="0">
+                <a:pos x="csX10" y="csY10"/>
               </a:cxn>
             </a:cxnLst>
             <a:rect l="l" t="t" r="r" b="b"/>
@@ -7806,63 +7806,63 @@
           <a:custGeom>
             <a:avLst/>
             <a:gdLst>
-              <a:gd name="connsiteX0" fmla="*/ 0 w 2333625"/>
-              <a:gd name="connsiteY0" fmla="*/ 0 h 369332"/>
-              <a:gd name="connsiteX1" fmla="*/ 583406 w 2333625"/>
-              <a:gd name="connsiteY1" fmla="*/ 0 h 369332"/>
-              <a:gd name="connsiteX2" fmla="*/ 1213485 w 2333625"/>
-              <a:gd name="connsiteY2" fmla="*/ 0 h 369332"/>
-              <a:gd name="connsiteX3" fmla="*/ 1773555 w 2333625"/>
-              <a:gd name="connsiteY3" fmla="*/ 0 h 369332"/>
-              <a:gd name="connsiteX4" fmla="*/ 2333625 w 2333625"/>
-              <a:gd name="connsiteY4" fmla="*/ 0 h 369332"/>
-              <a:gd name="connsiteX5" fmla="*/ 2333625 w 2333625"/>
-              <a:gd name="connsiteY5" fmla="*/ 369332 h 369332"/>
-              <a:gd name="connsiteX6" fmla="*/ 1703546 w 2333625"/>
-              <a:gd name="connsiteY6" fmla="*/ 369332 h 369332"/>
-              <a:gd name="connsiteX7" fmla="*/ 1143476 w 2333625"/>
-              <a:gd name="connsiteY7" fmla="*/ 369332 h 369332"/>
-              <a:gd name="connsiteX8" fmla="*/ 583406 w 2333625"/>
-              <a:gd name="connsiteY8" fmla="*/ 369332 h 369332"/>
-              <a:gd name="connsiteX9" fmla="*/ 0 w 2333625"/>
-              <a:gd name="connsiteY9" fmla="*/ 369332 h 369332"/>
-              <a:gd name="connsiteX10" fmla="*/ 0 w 2333625"/>
-              <a:gd name="connsiteY10" fmla="*/ 0 h 369332"/>
+              <a:gd name="csX0" fmla="*/ 0 w 2333625"/>
+              <a:gd name="csY0" fmla="*/ 0 h 369332"/>
+              <a:gd name="csX1" fmla="*/ 583406 w 2333625"/>
+              <a:gd name="csY1" fmla="*/ 0 h 369332"/>
+              <a:gd name="csX2" fmla="*/ 1213485 w 2333625"/>
+              <a:gd name="csY2" fmla="*/ 0 h 369332"/>
+              <a:gd name="csX3" fmla="*/ 1773555 w 2333625"/>
+              <a:gd name="csY3" fmla="*/ 0 h 369332"/>
+              <a:gd name="csX4" fmla="*/ 2333625 w 2333625"/>
+              <a:gd name="csY4" fmla="*/ 0 h 369332"/>
+              <a:gd name="csX5" fmla="*/ 2333625 w 2333625"/>
+              <a:gd name="csY5" fmla="*/ 369332 h 369332"/>
+              <a:gd name="csX6" fmla="*/ 1703546 w 2333625"/>
+              <a:gd name="csY6" fmla="*/ 369332 h 369332"/>
+              <a:gd name="csX7" fmla="*/ 1143476 w 2333625"/>
+              <a:gd name="csY7" fmla="*/ 369332 h 369332"/>
+              <a:gd name="csX8" fmla="*/ 583406 w 2333625"/>
+              <a:gd name="csY8" fmla="*/ 369332 h 369332"/>
+              <a:gd name="csX9" fmla="*/ 0 w 2333625"/>
+              <a:gd name="csY9" fmla="*/ 369332 h 369332"/>
+              <a:gd name="csX10" fmla="*/ 0 w 2333625"/>
+              <a:gd name="csY10" fmla="*/ 0 h 369332"/>
             </a:gdLst>
             <a:ahLst/>
             <a:cxnLst>
               <a:cxn ang="0">
-                <a:pos x="connsiteX0" y="connsiteY0"/>
-              </a:cxn>
-              <a:cxn ang="0">
-                <a:pos x="connsiteX1" y="connsiteY1"/>
-              </a:cxn>
-              <a:cxn ang="0">
-                <a:pos x="connsiteX2" y="connsiteY2"/>
-              </a:cxn>
-              <a:cxn ang="0">
-                <a:pos x="connsiteX3" y="connsiteY3"/>
-              </a:cxn>
-              <a:cxn ang="0">
-                <a:pos x="connsiteX4" y="connsiteY4"/>
-              </a:cxn>
-              <a:cxn ang="0">
-                <a:pos x="connsiteX5" y="connsiteY5"/>
-              </a:cxn>
-              <a:cxn ang="0">
-                <a:pos x="connsiteX6" y="connsiteY6"/>
-              </a:cxn>
-              <a:cxn ang="0">
-                <a:pos x="connsiteX7" y="connsiteY7"/>
-              </a:cxn>
-              <a:cxn ang="0">
-                <a:pos x="connsiteX8" y="connsiteY8"/>
-              </a:cxn>
-              <a:cxn ang="0">
-                <a:pos x="connsiteX9" y="connsiteY9"/>
-              </a:cxn>
-              <a:cxn ang="0">
-                <a:pos x="connsiteX10" y="connsiteY10"/>
+                <a:pos x="csX0" y="csY0"/>
+              </a:cxn>
+              <a:cxn ang="0">
+                <a:pos x="csX1" y="csY1"/>
+              </a:cxn>
+              <a:cxn ang="0">
+                <a:pos x="csX2" y="csY2"/>
+              </a:cxn>
+              <a:cxn ang="0">
+                <a:pos x="csX3" y="csY3"/>
+              </a:cxn>
+              <a:cxn ang="0">
+                <a:pos x="csX4" y="csY4"/>
+              </a:cxn>
+              <a:cxn ang="0">
+                <a:pos x="csX5" y="csY5"/>
+              </a:cxn>
+              <a:cxn ang="0">
+                <a:pos x="csX6" y="csY6"/>
+              </a:cxn>
+              <a:cxn ang="0">
+                <a:pos x="csX7" y="csY7"/>
+              </a:cxn>
+              <a:cxn ang="0">
+                <a:pos x="csX8" y="csY8"/>
+              </a:cxn>
+              <a:cxn ang="0">
+                <a:pos x="csX9" y="csY9"/>
+              </a:cxn>
+              <a:cxn ang="0">
+                <a:pos x="csX10" y="csY10"/>
               </a:cxn>
             </a:cxnLst>
             <a:rect l="l" t="t" r="r" b="b"/>
@@ -8047,63 +8047,63 @@
           <a:custGeom>
             <a:avLst/>
             <a:gdLst>
-              <a:gd name="connsiteX0" fmla="*/ 0 w 2333625"/>
-              <a:gd name="connsiteY0" fmla="*/ 0 h 369332"/>
-              <a:gd name="connsiteX1" fmla="*/ 583406 w 2333625"/>
-              <a:gd name="connsiteY1" fmla="*/ 0 h 369332"/>
-              <a:gd name="connsiteX2" fmla="*/ 1213485 w 2333625"/>
-              <a:gd name="connsiteY2" fmla="*/ 0 h 369332"/>
-              <a:gd name="connsiteX3" fmla="*/ 1773555 w 2333625"/>
-              <a:gd name="connsiteY3" fmla="*/ 0 h 369332"/>
-              <a:gd name="connsiteX4" fmla="*/ 2333625 w 2333625"/>
-              <a:gd name="connsiteY4" fmla="*/ 0 h 369332"/>
-              <a:gd name="connsiteX5" fmla="*/ 2333625 w 2333625"/>
-              <a:gd name="connsiteY5" fmla="*/ 369332 h 369332"/>
-              <a:gd name="connsiteX6" fmla="*/ 1703546 w 2333625"/>
-              <a:gd name="connsiteY6" fmla="*/ 369332 h 369332"/>
-              <a:gd name="connsiteX7" fmla="*/ 1143476 w 2333625"/>
-              <a:gd name="connsiteY7" fmla="*/ 369332 h 369332"/>
-              <a:gd name="connsiteX8" fmla="*/ 583406 w 2333625"/>
-              <a:gd name="connsiteY8" fmla="*/ 369332 h 369332"/>
-              <a:gd name="connsiteX9" fmla="*/ 0 w 2333625"/>
-              <a:gd name="connsiteY9" fmla="*/ 369332 h 369332"/>
-              <a:gd name="connsiteX10" fmla="*/ 0 w 2333625"/>
-              <a:gd name="connsiteY10" fmla="*/ 0 h 369332"/>
+              <a:gd name="csX0" fmla="*/ 0 w 2333625"/>
+              <a:gd name="csY0" fmla="*/ 0 h 369332"/>
+              <a:gd name="csX1" fmla="*/ 583406 w 2333625"/>
+              <a:gd name="csY1" fmla="*/ 0 h 369332"/>
+              <a:gd name="csX2" fmla="*/ 1213485 w 2333625"/>
+              <a:gd name="csY2" fmla="*/ 0 h 369332"/>
+              <a:gd name="csX3" fmla="*/ 1773555 w 2333625"/>
+              <a:gd name="csY3" fmla="*/ 0 h 369332"/>
+              <a:gd name="csX4" fmla="*/ 2333625 w 2333625"/>
+              <a:gd name="csY4" fmla="*/ 0 h 369332"/>
+              <a:gd name="csX5" fmla="*/ 2333625 w 2333625"/>
+              <a:gd name="csY5" fmla="*/ 369332 h 369332"/>
+              <a:gd name="csX6" fmla="*/ 1703546 w 2333625"/>
+              <a:gd name="csY6" fmla="*/ 369332 h 369332"/>
+              <a:gd name="csX7" fmla="*/ 1143476 w 2333625"/>
+              <a:gd name="csY7" fmla="*/ 369332 h 369332"/>
+              <a:gd name="csX8" fmla="*/ 583406 w 2333625"/>
+              <a:gd name="csY8" fmla="*/ 369332 h 369332"/>
+              <a:gd name="csX9" fmla="*/ 0 w 2333625"/>
+              <a:gd name="csY9" fmla="*/ 369332 h 369332"/>
+              <a:gd name="csX10" fmla="*/ 0 w 2333625"/>
+              <a:gd name="csY10" fmla="*/ 0 h 369332"/>
             </a:gdLst>
             <a:ahLst/>
             <a:cxnLst>
               <a:cxn ang="0">
-                <a:pos x="connsiteX0" y="connsiteY0"/>
-              </a:cxn>
-              <a:cxn ang="0">
-                <a:pos x="connsiteX1" y="connsiteY1"/>
-              </a:cxn>
-              <a:cxn ang="0">
-                <a:pos x="connsiteX2" y="connsiteY2"/>
-              </a:cxn>
-              <a:cxn ang="0">
-                <a:pos x="connsiteX3" y="connsiteY3"/>
-              </a:cxn>
-              <a:cxn ang="0">
-                <a:pos x="connsiteX4" y="connsiteY4"/>
-              </a:cxn>
-              <a:cxn ang="0">
-                <a:pos x="connsiteX5" y="connsiteY5"/>
-              </a:cxn>
-              <a:cxn ang="0">
-                <a:pos x="connsiteX6" y="connsiteY6"/>
-              </a:cxn>
-              <a:cxn ang="0">
-                <a:pos x="connsiteX7" y="connsiteY7"/>
-              </a:cxn>
-              <a:cxn ang="0">
-                <a:pos x="connsiteX8" y="connsiteY8"/>
-              </a:cxn>
-              <a:cxn ang="0">
-                <a:pos x="connsiteX9" y="connsiteY9"/>
-              </a:cxn>
-              <a:cxn ang="0">
-                <a:pos x="connsiteX10" y="connsiteY10"/>
+                <a:pos x="csX0" y="csY0"/>
+              </a:cxn>
+              <a:cxn ang="0">
+                <a:pos x="csX1" y="csY1"/>
+              </a:cxn>
+              <a:cxn ang="0">
+                <a:pos x="csX2" y="csY2"/>
+              </a:cxn>
+              <a:cxn ang="0">
+                <a:pos x="csX3" y="csY3"/>
+              </a:cxn>
+              <a:cxn ang="0">
+                <a:pos x="csX4" y="csY4"/>
+              </a:cxn>
+              <a:cxn ang="0">
+                <a:pos x="csX5" y="csY5"/>
+              </a:cxn>
+              <a:cxn ang="0">
+                <a:pos x="csX6" y="csY6"/>
+              </a:cxn>
+              <a:cxn ang="0">
+                <a:pos x="csX7" y="csY7"/>
+              </a:cxn>
+              <a:cxn ang="0">
+                <a:pos x="csX8" y="csY8"/>
+              </a:cxn>
+              <a:cxn ang="0">
+                <a:pos x="csX9" y="csY9"/>
+              </a:cxn>
+              <a:cxn ang="0">
+                <a:pos x="csX10" y="csY10"/>
               </a:cxn>
             </a:cxnLst>
             <a:rect l="l" t="t" r="r" b="b"/>
@@ -8288,33 +8288,33 @@
           <a:custGeom>
             <a:avLst/>
             <a:gdLst>
-              <a:gd name="connsiteX0" fmla="*/ 0 w 457200"/>
-              <a:gd name="connsiteY0" fmla="*/ 228600 h 457200"/>
-              <a:gd name="connsiteX1" fmla="*/ 228600 w 457200"/>
-              <a:gd name="connsiteY1" fmla="*/ 0 h 457200"/>
-              <a:gd name="connsiteX2" fmla="*/ 457200 w 457200"/>
-              <a:gd name="connsiteY2" fmla="*/ 228600 h 457200"/>
-              <a:gd name="connsiteX3" fmla="*/ 228600 w 457200"/>
-              <a:gd name="connsiteY3" fmla="*/ 457200 h 457200"/>
-              <a:gd name="connsiteX4" fmla="*/ 0 w 457200"/>
-              <a:gd name="connsiteY4" fmla="*/ 228600 h 457200"/>
+              <a:gd name="csX0" fmla="*/ 0 w 457200"/>
+              <a:gd name="csY0" fmla="*/ 228600 h 457200"/>
+              <a:gd name="csX1" fmla="*/ 228600 w 457200"/>
+              <a:gd name="csY1" fmla="*/ 0 h 457200"/>
+              <a:gd name="csX2" fmla="*/ 457200 w 457200"/>
+              <a:gd name="csY2" fmla="*/ 228600 h 457200"/>
+              <a:gd name="csX3" fmla="*/ 228600 w 457200"/>
+              <a:gd name="csY3" fmla="*/ 457200 h 457200"/>
+              <a:gd name="csX4" fmla="*/ 0 w 457200"/>
+              <a:gd name="csY4" fmla="*/ 228600 h 457200"/>
             </a:gdLst>
             <a:ahLst/>
             <a:cxnLst>
               <a:cxn ang="0">
-                <a:pos x="connsiteX0" y="connsiteY0"/>
-              </a:cxn>
-              <a:cxn ang="0">
-                <a:pos x="connsiteX1" y="connsiteY1"/>
-              </a:cxn>
-              <a:cxn ang="0">
-                <a:pos x="connsiteX2" y="connsiteY2"/>
-              </a:cxn>
-              <a:cxn ang="0">
-                <a:pos x="connsiteX3" y="connsiteY3"/>
-              </a:cxn>
-              <a:cxn ang="0">
-                <a:pos x="connsiteX4" y="connsiteY4"/>
+                <a:pos x="csX0" y="csY0"/>
+              </a:cxn>
+              <a:cxn ang="0">
+                <a:pos x="csX1" y="csY1"/>
+              </a:cxn>
+              <a:cxn ang="0">
+                <a:pos x="csX2" y="csY2"/>
+              </a:cxn>
+              <a:cxn ang="0">
+                <a:pos x="csX3" y="csY3"/>
+              </a:cxn>
+              <a:cxn ang="0">
+                <a:pos x="csX4" y="csY4"/>
               </a:cxn>
             </a:cxnLst>
             <a:rect l="l" t="t" r="r" b="b"/>
@@ -8434,33 +8434,33 @@
           <a:custGeom>
             <a:avLst/>
             <a:gdLst>
-              <a:gd name="connsiteX0" fmla="*/ 0 w 457200"/>
-              <a:gd name="connsiteY0" fmla="*/ 228600 h 457200"/>
-              <a:gd name="connsiteX1" fmla="*/ 228600 w 457200"/>
-              <a:gd name="connsiteY1" fmla="*/ 0 h 457200"/>
-              <a:gd name="connsiteX2" fmla="*/ 457200 w 457200"/>
-              <a:gd name="connsiteY2" fmla="*/ 228600 h 457200"/>
-              <a:gd name="connsiteX3" fmla="*/ 228600 w 457200"/>
-              <a:gd name="connsiteY3" fmla="*/ 457200 h 457200"/>
-              <a:gd name="connsiteX4" fmla="*/ 0 w 457200"/>
-              <a:gd name="connsiteY4" fmla="*/ 228600 h 457200"/>
+              <a:gd name="csX0" fmla="*/ 0 w 457200"/>
+              <a:gd name="csY0" fmla="*/ 228600 h 457200"/>
+              <a:gd name="csX1" fmla="*/ 228600 w 457200"/>
+              <a:gd name="csY1" fmla="*/ 0 h 457200"/>
+              <a:gd name="csX2" fmla="*/ 457200 w 457200"/>
+              <a:gd name="csY2" fmla="*/ 228600 h 457200"/>
+              <a:gd name="csX3" fmla="*/ 228600 w 457200"/>
+              <a:gd name="csY3" fmla="*/ 457200 h 457200"/>
+              <a:gd name="csX4" fmla="*/ 0 w 457200"/>
+              <a:gd name="csY4" fmla="*/ 228600 h 457200"/>
             </a:gdLst>
             <a:ahLst/>
             <a:cxnLst>
               <a:cxn ang="0">
-                <a:pos x="connsiteX0" y="connsiteY0"/>
-              </a:cxn>
-              <a:cxn ang="0">
-                <a:pos x="connsiteX1" y="connsiteY1"/>
-              </a:cxn>
-              <a:cxn ang="0">
-                <a:pos x="connsiteX2" y="connsiteY2"/>
-              </a:cxn>
-              <a:cxn ang="0">
-                <a:pos x="connsiteX3" y="connsiteY3"/>
-              </a:cxn>
-              <a:cxn ang="0">
-                <a:pos x="connsiteX4" y="connsiteY4"/>
+                <a:pos x="csX0" y="csY0"/>
+              </a:cxn>
+              <a:cxn ang="0">
+                <a:pos x="csX1" y="csY1"/>
+              </a:cxn>
+              <a:cxn ang="0">
+                <a:pos x="csX2" y="csY2"/>
+              </a:cxn>
+              <a:cxn ang="0">
+                <a:pos x="csX3" y="csY3"/>
+              </a:cxn>
+              <a:cxn ang="0">
+                <a:pos x="csX4" y="csY4"/>
               </a:cxn>
             </a:cxnLst>
             <a:rect l="l" t="t" r="r" b="b"/>
@@ -8580,63 +8580,63 @@
           <a:custGeom>
             <a:avLst/>
             <a:gdLst>
-              <a:gd name="connsiteX0" fmla="*/ 0 w 2333625"/>
-              <a:gd name="connsiteY0" fmla="*/ 0 h 369332"/>
-              <a:gd name="connsiteX1" fmla="*/ 583406 w 2333625"/>
-              <a:gd name="connsiteY1" fmla="*/ 0 h 369332"/>
-              <a:gd name="connsiteX2" fmla="*/ 1213485 w 2333625"/>
-              <a:gd name="connsiteY2" fmla="*/ 0 h 369332"/>
-              <a:gd name="connsiteX3" fmla="*/ 1773555 w 2333625"/>
-              <a:gd name="connsiteY3" fmla="*/ 0 h 369332"/>
-              <a:gd name="connsiteX4" fmla="*/ 2333625 w 2333625"/>
-              <a:gd name="connsiteY4" fmla="*/ 0 h 369332"/>
-              <a:gd name="connsiteX5" fmla="*/ 2333625 w 2333625"/>
-              <a:gd name="connsiteY5" fmla="*/ 369332 h 369332"/>
-              <a:gd name="connsiteX6" fmla="*/ 1703546 w 2333625"/>
-              <a:gd name="connsiteY6" fmla="*/ 369332 h 369332"/>
-              <a:gd name="connsiteX7" fmla="*/ 1143476 w 2333625"/>
-              <a:gd name="connsiteY7" fmla="*/ 369332 h 369332"/>
-              <a:gd name="connsiteX8" fmla="*/ 583406 w 2333625"/>
-              <a:gd name="connsiteY8" fmla="*/ 369332 h 369332"/>
-              <a:gd name="connsiteX9" fmla="*/ 0 w 2333625"/>
-              <a:gd name="connsiteY9" fmla="*/ 369332 h 369332"/>
-              <a:gd name="connsiteX10" fmla="*/ 0 w 2333625"/>
-              <a:gd name="connsiteY10" fmla="*/ 0 h 369332"/>
+              <a:gd name="csX0" fmla="*/ 0 w 2333625"/>
+              <a:gd name="csY0" fmla="*/ 0 h 369332"/>
+              <a:gd name="csX1" fmla="*/ 583406 w 2333625"/>
+              <a:gd name="csY1" fmla="*/ 0 h 369332"/>
+              <a:gd name="csX2" fmla="*/ 1213485 w 2333625"/>
+              <a:gd name="csY2" fmla="*/ 0 h 369332"/>
+              <a:gd name="csX3" fmla="*/ 1773555 w 2333625"/>
+              <a:gd name="csY3" fmla="*/ 0 h 369332"/>
+              <a:gd name="csX4" fmla="*/ 2333625 w 2333625"/>
+              <a:gd name="csY4" fmla="*/ 0 h 369332"/>
+              <a:gd name="csX5" fmla="*/ 2333625 w 2333625"/>
+              <a:gd name="csY5" fmla="*/ 369332 h 369332"/>
+              <a:gd name="csX6" fmla="*/ 1703546 w 2333625"/>
+              <a:gd name="csY6" fmla="*/ 369332 h 369332"/>
+              <a:gd name="csX7" fmla="*/ 1143476 w 2333625"/>
+              <a:gd name="csY7" fmla="*/ 369332 h 369332"/>
+              <a:gd name="csX8" fmla="*/ 583406 w 2333625"/>
+              <a:gd name="csY8" fmla="*/ 369332 h 369332"/>
+              <a:gd name="csX9" fmla="*/ 0 w 2333625"/>
+              <a:gd name="csY9" fmla="*/ 369332 h 369332"/>
+              <a:gd name="csX10" fmla="*/ 0 w 2333625"/>
+              <a:gd name="csY10" fmla="*/ 0 h 369332"/>
             </a:gdLst>
             <a:ahLst/>
             <a:cxnLst>
               <a:cxn ang="0">
-                <a:pos x="connsiteX0" y="connsiteY0"/>
-              </a:cxn>
-              <a:cxn ang="0">
-                <a:pos x="connsiteX1" y="connsiteY1"/>
-              </a:cxn>
-              <a:cxn ang="0">
-                <a:pos x="connsiteX2" y="connsiteY2"/>
-              </a:cxn>
-              <a:cxn ang="0">
-                <a:pos x="connsiteX3" y="connsiteY3"/>
-              </a:cxn>
-              <a:cxn ang="0">
-                <a:pos x="connsiteX4" y="connsiteY4"/>
-              </a:cxn>
-              <a:cxn ang="0">
-                <a:pos x="connsiteX5" y="connsiteY5"/>
-              </a:cxn>
-              <a:cxn ang="0">
-                <a:pos x="connsiteX6" y="connsiteY6"/>
-              </a:cxn>
-              <a:cxn ang="0">
-                <a:pos x="connsiteX7" y="connsiteY7"/>
-              </a:cxn>
-              <a:cxn ang="0">
-                <a:pos x="connsiteX8" y="connsiteY8"/>
-              </a:cxn>
-              <a:cxn ang="0">
-                <a:pos x="connsiteX9" y="connsiteY9"/>
-              </a:cxn>
-              <a:cxn ang="0">
-                <a:pos x="connsiteX10" y="connsiteY10"/>
+                <a:pos x="csX0" y="csY0"/>
+              </a:cxn>
+              <a:cxn ang="0">
+                <a:pos x="csX1" y="csY1"/>
+              </a:cxn>
+              <a:cxn ang="0">
+                <a:pos x="csX2" y="csY2"/>
+              </a:cxn>
+              <a:cxn ang="0">
+                <a:pos x="csX3" y="csY3"/>
+              </a:cxn>
+              <a:cxn ang="0">
+                <a:pos x="csX4" y="csY4"/>
+              </a:cxn>
+              <a:cxn ang="0">
+                <a:pos x="csX5" y="csY5"/>
+              </a:cxn>
+              <a:cxn ang="0">
+                <a:pos x="csX6" y="csY6"/>
+              </a:cxn>
+              <a:cxn ang="0">
+                <a:pos x="csX7" y="csY7"/>
+              </a:cxn>
+              <a:cxn ang="0">
+                <a:pos x="csX8" y="csY8"/>
+              </a:cxn>
+              <a:cxn ang="0">
+                <a:pos x="csX9" y="csY9"/>
+              </a:cxn>
+              <a:cxn ang="0">
+                <a:pos x="csX10" y="csY10"/>
               </a:cxn>
             </a:cxnLst>
             <a:rect l="l" t="t" r="r" b="b"/>
@@ -10227,33 +10227,33 @@
           <a:custGeom>
             <a:avLst/>
             <a:gdLst>
-              <a:gd name="connsiteX0" fmla="*/ 0 w 457200"/>
-              <a:gd name="connsiteY0" fmla="*/ 228600 h 457200"/>
-              <a:gd name="connsiteX1" fmla="*/ 228600 w 457200"/>
-              <a:gd name="connsiteY1" fmla="*/ 0 h 457200"/>
-              <a:gd name="connsiteX2" fmla="*/ 457200 w 457200"/>
-              <a:gd name="connsiteY2" fmla="*/ 228600 h 457200"/>
-              <a:gd name="connsiteX3" fmla="*/ 228600 w 457200"/>
-              <a:gd name="connsiteY3" fmla="*/ 457200 h 457200"/>
-              <a:gd name="connsiteX4" fmla="*/ 0 w 457200"/>
-              <a:gd name="connsiteY4" fmla="*/ 228600 h 457200"/>
+              <a:gd name="csX0" fmla="*/ 0 w 457200"/>
+              <a:gd name="csY0" fmla="*/ 228600 h 457200"/>
+              <a:gd name="csX1" fmla="*/ 228600 w 457200"/>
+              <a:gd name="csY1" fmla="*/ 0 h 457200"/>
+              <a:gd name="csX2" fmla="*/ 457200 w 457200"/>
+              <a:gd name="csY2" fmla="*/ 228600 h 457200"/>
+              <a:gd name="csX3" fmla="*/ 228600 w 457200"/>
+              <a:gd name="csY3" fmla="*/ 457200 h 457200"/>
+              <a:gd name="csX4" fmla="*/ 0 w 457200"/>
+              <a:gd name="csY4" fmla="*/ 228600 h 457200"/>
             </a:gdLst>
             <a:ahLst/>
             <a:cxnLst>
               <a:cxn ang="0">
-                <a:pos x="connsiteX0" y="connsiteY0"/>
-              </a:cxn>
-              <a:cxn ang="0">
-                <a:pos x="connsiteX1" y="connsiteY1"/>
-              </a:cxn>
-              <a:cxn ang="0">
-                <a:pos x="connsiteX2" y="connsiteY2"/>
-              </a:cxn>
-              <a:cxn ang="0">
-                <a:pos x="connsiteX3" y="connsiteY3"/>
-              </a:cxn>
-              <a:cxn ang="0">
-                <a:pos x="connsiteX4" y="connsiteY4"/>
+                <a:pos x="csX0" y="csY0"/>
+              </a:cxn>
+              <a:cxn ang="0">
+                <a:pos x="csX1" y="csY1"/>
+              </a:cxn>
+              <a:cxn ang="0">
+                <a:pos x="csX2" y="csY2"/>
+              </a:cxn>
+              <a:cxn ang="0">
+                <a:pos x="csX3" y="csY3"/>
+              </a:cxn>
+              <a:cxn ang="0">
+                <a:pos x="csX4" y="csY4"/>
               </a:cxn>
             </a:cxnLst>
             <a:rect l="l" t="t" r="r" b="b"/>
@@ -10494,33 +10494,33 @@
           <a:custGeom>
             <a:avLst/>
             <a:gdLst>
-              <a:gd name="connsiteX0" fmla="*/ 0 w 457200"/>
-              <a:gd name="connsiteY0" fmla="*/ 228600 h 457200"/>
-              <a:gd name="connsiteX1" fmla="*/ 228600 w 457200"/>
-              <a:gd name="connsiteY1" fmla="*/ 0 h 457200"/>
-              <a:gd name="connsiteX2" fmla="*/ 457200 w 457200"/>
-              <a:gd name="connsiteY2" fmla="*/ 228600 h 457200"/>
-              <a:gd name="connsiteX3" fmla="*/ 228600 w 457200"/>
-              <a:gd name="connsiteY3" fmla="*/ 457200 h 457200"/>
-              <a:gd name="connsiteX4" fmla="*/ 0 w 457200"/>
-              <a:gd name="connsiteY4" fmla="*/ 228600 h 457200"/>
+              <a:gd name="csX0" fmla="*/ 0 w 457200"/>
+              <a:gd name="csY0" fmla="*/ 228600 h 457200"/>
+              <a:gd name="csX1" fmla="*/ 228600 w 457200"/>
+              <a:gd name="csY1" fmla="*/ 0 h 457200"/>
+              <a:gd name="csX2" fmla="*/ 457200 w 457200"/>
+              <a:gd name="csY2" fmla="*/ 228600 h 457200"/>
+              <a:gd name="csX3" fmla="*/ 228600 w 457200"/>
+              <a:gd name="csY3" fmla="*/ 457200 h 457200"/>
+              <a:gd name="csX4" fmla="*/ 0 w 457200"/>
+              <a:gd name="csY4" fmla="*/ 228600 h 457200"/>
             </a:gdLst>
             <a:ahLst/>
             <a:cxnLst>
               <a:cxn ang="0">
-                <a:pos x="connsiteX0" y="connsiteY0"/>
-              </a:cxn>
-              <a:cxn ang="0">
-                <a:pos x="connsiteX1" y="connsiteY1"/>
-              </a:cxn>
-              <a:cxn ang="0">
-                <a:pos x="connsiteX2" y="connsiteY2"/>
-              </a:cxn>
-              <a:cxn ang="0">
-                <a:pos x="connsiteX3" y="connsiteY3"/>
-              </a:cxn>
-              <a:cxn ang="0">
-                <a:pos x="connsiteX4" y="connsiteY4"/>
+                <a:pos x="csX0" y="csY0"/>
+              </a:cxn>
+              <a:cxn ang="0">
+                <a:pos x="csX1" y="csY1"/>
+              </a:cxn>
+              <a:cxn ang="0">
+                <a:pos x="csX2" y="csY2"/>
+              </a:cxn>
+              <a:cxn ang="0">
+                <a:pos x="csX3" y="csY3"/>
+              </a:cxn>
+              <a:cxn ang="0">
+                <a:pos x="csX4" y="csY4"/>
               </a:cxn>
             </a:cxnLst>
             <a:rect l="l" t="t" r="r" b="b"/>
@@ -10640,33 +10640,33 @@
           <a:custGeom>
             <a:avLst/>
             <a:gdLst>
-              <a:gd name="connsiteX0" fmla="*/ 0 w 457200"/>
-              <a:gd name="connsiteY0" fmla="*/ 228600 h 457200"/>
-              <a:gd name="connsiteX1" fmla="*/ 228600 w 457200"/>
-              <a:gd name="connsiteY1" fmla="*/ 0 h 457200"/>
-              <a:gd name="connsiteX2" fmla="*/ 457200 w 457200"/>
-              <a:gd name="connsiteY2" fmla="*/ 228600 h 457200"/>
-              <a:gd name="connsiteX3" fmla="*/ 228600 w 457200"/>
-              <a:gd name="connsiteY3" fmla="*/ 457200 h 457200"/>
-              <a:gd name="connsiteX4" fmla="*/ 0 w 457200"/>
-              <a:gd name="connsiteY4" fmla="*/ 228600 h 457200"/>
+              <a:gd name="csX0" fmla="*/ 0 w 457200"/>
+              <a:gd name="csY0" fmla="*/ 228600 h 457200"/>
+              <a:gd name="csX1" fmla="*/ 228600 w 457200"/>
+              <a:gd name="csY1" fmla="*/ 0 h 457200"/>
+              <a:gd name="csX2" fmla="*/ 457200 w 457200"/>
+              <a:gd name="csY2" fmla="*/ 228600 h 457200"/>
+              <a:gd name="csX3" fmla="*/ 228600 w 457200"/>
+              <a:gd name="csY3" fmla="*/ 457200 h 457200"/>
+              <a:gd name="csX4" fmla="*/ 0 w 457200"/>
+              <a:gd name="csY4" fmla="*/ 228600 h 457200"/>
             </a:gdLst>
             <a:ahLst/>
             <a:cxnLst>
               <a:cxn ang="0">
-                <a:pos x="connsiteX0" y="connsiteY0"/>
-              </a:cxn>
-              <a:cxn ang="0">
-                <a:pos x="connsiteX1" y="connsiteY1"/>
-              </a:cxn>
-              <a:cxn ang="0">
-                <a:pos x="connsiteX2" y="connsiteY2"/>
-              </a:cxn>
-              <a:cxn ang="0">
-                <a:pos x="connsiteX3" y="connsiteY3"/>
-              </a:cxn>
-              <a:cxn ang="0">
-                <a:pos x="connsiteX4" y="connsiteY4"/>
+                <a:pos x="csX0" y="csY0"/>
+              </a:cxn>
+              <a:cxn ang="0">
+                <a:pos x="csX1" y="csY1"/>
+              </a:cxn>
+              <a:cxn ang="0">
+                <a:pos x="csX2" y="csY2"/>
+              </a:cxn>
+              <a:cxn ang="0">
+                <a:pos x="csX3" y="csY3"/>
+              </a:cxn>
+              <a:cxn ang="0">
+                <a:pos x="csX4" y="csY4"/>
               </a:cxn>
             </a:cxnLst>
             <a:rect l="l" t="t" r="r" b="b"/>
@@ -10786,33 +10786,33 @@
           <a:custGeom>
             <a:avLst/>
             <a:gdLst>
-              <a:gd name="connsiteX0" fmla="*/ 0 w 457200"/>
-              <a:gd name="connsiteY0" fmla="*/ 228600 h 457200"/>
-              <a:gd name="connsiteX1" fmla="*/ 228600 w 457200"/>
-              <a:gd name="connsiteY1" fmla="*/ 0 h 457200"/>
-              <a:gd name="connsiteX2" fmla="*/ 457200 w 457200"/>
-              <a:gd name="connsiteY2" fmla="*/ 228600 h 457200"/>
-              <a:gd name="connsiteX3" fmla="*/ 228600 w 457200"/>
-              <a:gd name="connsiteY3" fmla="*/ 457200 h 457200"/>
-              <a:gd name="connsiteX4" fmla="*/ 0 w 457200"/>
-              <a:gd name="connsiteY4" fmla="*/ 228600 h 457200"/>
+              <a:gd name="csX0" fmla="*/ 0 w 457200"/>
+              <a:gd name="csY0" fmla="*/ 228600 h 457200"/>
+              <a:gd name="csX1" fmla="*/ 228600 w 457200"/>
+              <a:gd name="csY1" fmla="*/ 0 h 457200"/>
+              <a:gd name="csX2" fmla="*/ 457200 w 457200"/>
+              <a:gd name="csY2" fmla="*/ 228600 h 457200"/>
+              <a:gd name="csX3" fmla="*/ 228600 w 457200"/>
+              <a:gd name="csY3" fmla="*/ 457200 h 457200"/>
+              <a:gd name="csX4" fmla="*/ 0 w 457200"/>
+              <a:gd name="csY4" fmla="*/ 228600 h 457200"/>
             </a:gdLst>
             <a:ahLst/>
             <a:cxnLst>
               <a:cxn ang="0">
-                <a:pos x="connsiteX0" y="connsiteY0"/>
-              </a:cxn>
-              <a:cxn ang="0">
-                <a:pos x="connsiteX1" y="connsiteY1"/>
-              </a:cxn>
-              <a:cxn ang="0">
-                <a:pos x="connsiteX2" y="connsiteY2"/>
-              </a:cxn>
-              <a:cxn ang="0">
-                <a:pos x="connsiteX3" y="connsiteY3"/>
-              </a:cxn>
-              <a:cxn ang="0">
-                <a:pos x="connsiteX4" y="connsiteY4"/>
+                <a:pos x="csX0" y="csY0"/>
+              </a:cxn>
+              <a:cxn ang="0">
+                <a:pos x="csX1" y="csY1"/>
+              </a:cxn>
+              <a:cxn ang="0">
+                <a:pos x="csX2" y="csY2"/>
+              </a:cxn>
+              <a:cxn ang="0">
+                <a:pos x="csX3" y="csY3"/>
+              </a:cxn>
+              <a:cxn ang="0">
+                <a:pos x="csX4" y="csY4"/>
               </a:cxn>
             </a:cxnLst>
             <a:rect l="l" t="t" r="r" b="b"/>
@@ -10932,33 +10932,33 @@
           <a:custGeom>
             <a:avLst/>
             <a:gdLst>
-              <a:gd name="connsiteX0" fmla="*/ 0 w 457200"/>
-              <a:gd name="connsiteY0" fmla="*/ 228600 h 457200"/>
-              <a:gd name="connsiteX1" fmla="*/ 228600 w 457200"/>
-              <a:gd name="connsiteY1" fmla="*/ 0 h 457200"/>
-              <a:gd name="connsiteX2" fmla="*/ 457200 w 457200"/>
-              <a:gd name="connsiteY2" fmla="*/ 228600 h 457200"/>
-              <a:gd name="connsiteX3" fmla="*/ 228600 w 457200"/>
-              <a:gd name="connsiteY3" fmla="*/ 457200 h 457200"/>
-              <a:gd name="connsiteX4" fmla="*/ 0 w 457200"/>
-              <a:gd name="connsiteY4" fmla="*/ 228600 h 457200"/>
+              <a:gd name="csX0" fmla="*/ 0 w 457200"/>
+              <a:gd name="csY0" fmla="*/ 228600 h 457200"/>
+              <a:gd name="csX1" fmla="*/ 228600 w 457200"/>
+              <a:gd name="csY1" fmla="*/ 0 h 457200"/>
+              <a:gd name="csX2" fmla="*/ 457200 w 457200"/>
+              <a:gd name="csY2" fmla="*/ 228600 h 457200"/>
+              <a:gd name="csX3" fmla="*/ 228600 w 457200"/>
+              <a:gd name="csY3" fmla="*/ 457200 h 457200"/>
+              <a:gd name="csX4" fmla="*/ 0 w 457200"/>
+              <a:gd name="csY4" fmla="*/ 228600 h 457200"/>
             </a:gdLst>
             <a:ahLst/>
             <a:cxnLst>
               <a:cxn ang="0">
-                <a:pos x="connsiteX0" y="connsiteY0"/>
-              </a:cxn>
-              <a:cxn ang="0">
-                <a:pos x="connsiteX1" y="connsiteY1"/>
-              </a:cxn>
-              <a:cxn ang="0">
-                <a:pos x="connsiteX2" y="connsiteY2"/>
-              </a:cxn>
-              <a:cxn ang="0">
-                <a:pos x="connsiteX3" y="connsiteY3"/>
-              </a:cxn>
-              <a:cxn ang="0">
-                <a:pos x="connsiteX4" y="connsiteY4"/>
+                <a:pos x="csX0" y="csY0"/>
+              </a:cxn>
+              <a:cxn ang="0">
+                <a:pos x="csX1" y="csY1"/>
+              </a:cxn>
+              <a:cxn ang="0">
+                <a:pos x="csX2" y="csY2"/>
+              </a:cxn>
+              <a:cxn ang="0">
+                <a:pos x="csX3" y="csY3"/>
+              </a:cxn>
+              <a:cxn ang="0">
+                <a:pos x="csX4" y="csY4"/>
               </a:cxn>
             </a:cxnLst>
             <a:rect l="l" t="t" r="r" b="b"/>
@@ -11078,33 +11078,33 @@
           <a:custGeom>
             <a:avLst/>
             <a:gdLst>
-              <a:gd name="connsiteX0" fmla="*/ 0 w 457200"/>
-              <a:gd name="connsiteY0" fmla="*/ 228600 h 457200"/>
-              <a:gd name="connsiteX1" fmla="*/ 228600 w 457200"/>
-              <a:gd name="connsiteY1" fmla="*/ 0 h 457200"/>
-              <a:gd name="connsiteX2" fmla="*/ 457200 w 457200"/>
-              <a:gd name="connsiteY2" fmla="*/ 228600 h 457200"/>
-              <a:gd name="connsiteX3" fmla="*/ 228600 w 457200"/>
-              <a:gd name="connsiteY3" fmla="*/ 457200 h 457200"/>
-              <a:gd name="connsiteX4" fmla="*/ 0 w 457200"/>
-              <a:gd name="connsiteY4" fmla="*/ 228600 h 457200"/>
+              <a:gd name="csX0" fmla="*/ 0 w 457200"/>
+              <a:gd name="csY0" fmla="*/ 228600 h 457200"/>
+              <a:gd name="csX1" fmla="*/ 228600 w 457200"/>
+              <a:gd name="csY1" fmla="*/ 0 h 457200"/>
+              <a:gd name="csX2" fmla="*/ 457200 w 457200"/>
+              <a:gd name="csY2" fmla="*/ 228600 h 457200"/>
+              <a:gd name="csX3" fmla="*/ 228600 w 457200"/>
+              <a:gd name="csY3" fmla="*/ 457200 h 457200"/>
+              <a:gd name="csX4" fmla="*/ 0 w 457200"/>
+              <a:gd name="csY4" fmla="*/ 228600 h 457200"/>
             </a:gdLst>
             <a:ahLst/>
             <a:cxnLst>
               <a:cxn ang="0">
-                <a:pos x="connsiteX0" y="connsiteY0"/>
-              </a:cxn>
-              <a:cxn ang="0">
-                <a:pos x="connsiteX1" y="connsiteY1"/>
-              </a:cxn>
-              <a:cxn ang="0">
-                <a:pos x="connsiteX2" y="connsiteY2"/>
-              </a:cxn>
-              <a:cxn ang="0">
-                <a:pos x="connsiteX3" y="connsiteY3"/>
-              </a:cxn>
-              <a:cxn ang="0">
-                <a:pos x="connsiteX4" y="connsiteY4"/>
+                <a:pos x="csX0" y="csY0"/>
+              </a:cxn>
+              <a:cxn ang="0">
+                <a:pos x="csX1" y="csY1"/>
+              </a:cxn>
+              <a:cxn ang="0">
+                <a:pos x="csX2" y="csY2"/>
+              </a:cxn>
+              <a:cxn ang="0">
+                <a:pos x="csX3" y="csY3"/>
+              </a:cxn>
+              <a:cxn ang="0">
+                <a:pos x="csX4" y="csY4"/>
               </a:cxn>
             </a:cxnLst>
             <a:rect l="l" t="t" r="r" b="b"/>
@@ -11224,33 +11224,33 @@
           <a:custGeom>
             <a:avLst/>
             <a:gdLst>
-              <a:gd name="connsiteX0" fmla="*/ 0 w 457200"/>
-              <a:gd name="connsiteY0" fmla="*/ 228600 h 457200"/>
-              <a:gd name="connsiteX1" fmla="*/ 228600 w 457200"/>
-              <a:gd name="connsiteY1" fmla="*/ 0 h 457200"/>
-              <a:gd name="connsiteX2" fmla="*/ 457200 w 457200"/>
-              <a:gd name="connsiteY2" fmla="*/ 228600 h 457200"/>
-              <a:gd name="connsiteX3" fmla="*/ 228600 w 457200"/>
-              <a:gd name="connsiteY3" fmla="*/ 457200 h 457200"/>
-              <a:gd name="connsiteX4" fmla="*/ 0 w 457200"/>
-              <a:gd name="connsiteY4" fmla="*/ 228600 h 457200"/>
+              <a:gd name="csX0" fmla="*/ 0 w 457200"/>
+              <a:gd name="csY0" fmla="*/ 228600 h 457200"/>
+              <a:gd name="csX1" fmla="*/ 228600 w 457200"/>
+              <a:gd name="csY1" fmla="*/ 0 h 457200"/>
+              <a:gd name="csX2" fmla="*/ 457200 w 457200"/>
+              <a:gd name="csY2" fmla="*/ 228600 h 457200"/>
+              <a:gd name="csX3" fmla="*/ 228600 w 457200"/>
+              <a:gd name="csY3" fmla="*/ 457200 h 457200"/>
+              <a:gd name="csX4" fmla="*/ 0 w 457200"/>
+              <a:gd name="csY4" fmla="*/ 228600 h 457200"/>
             </a:gdLst>
             <a:ahLst/>
             <a:cxnLst>
               <a:cxn ang="0">
-                <a:pos x="connsiteX0" y="connsiteY0"/>
-              </a:cxn>
-              <a:cxn ang="0">
-                <a:pos x="connsiteX1" y="connsiteY1"/>
-              </a:cxn>
-              <a:cxn ang="0">
-                <a:pos x="connsiteX2" y="connsiteY2"/>
-              </a:cxn>
-              <a:cxn ang="0">
-                <a:pos x="connsiteX3" y="connsiteY3"/>
-              </a:cxn>
-              <a:cxn ang="0">
-                <a:pos x="connsiteX4" y="connsiteY4"/>
+                <a:pos x="csX0" y="csY0"/>
+              </a:cxn>
+              <a:cxn ang="0">
+                <a:pos x="csX1" y="csY1"/>
+              </a:cxn>
+              <a:cxn ang="0">
+                <a:pos x="csX2" y="csY2"/>
+              </a:cxn>
+              <a:cxn ang="0">
+                <a:pos x="csX3" y="csY3"/>
+              </a:cxn>
+              <a:cxn ang="0">
+                <a:pos x="csX4" y="csY4"/>
               </a:cxn>
             </a:cxnLst>
             <a:rect l="l" t="t" r="r" b="b"/>
@@ -11370,33 +11370,33 @@
           <a:custGeom>
             <a:avLst/>
             <a:gdLst>
-              <a:gd name="connsiteX0" fmla="*/ 0 w 457200"/>
-              <a:gd name="connsiteY0" fmla="*/ 228600 h 457200"/>
-              <a:gd name="connsiteX1" fmla="*/ 228600 w 457200"/>
-              <a:gd name="connsiteY1" fmla="*/ 0 h 457200"/>
-              <a:gd name="connsiteX2" fmla="*/ 457200 w 457200"/>
-              <a:gd name="connsiteY2" fmla="*/ 228600 h 457200"/>
-              <a:gd name="connsiteX3" fmla="*/ 228600 w 457200"/>
-              <a:gd name="connsiteY3" fmla="*/ 457200 h 457200"/>
-              <a:gd name="connsiteX4" fmla="*/ 0 w 457200"/>
-              <a:gd name="connsiteY4" fmla="*/ 228600 h 457200"/>
+              <a:gd name="csX0" fmla="*/ 0 w 457200"/>
+              <a:gd name="csY0" fmla="*/ 228600 h 457200"/>
+              <a:gd name="csX1" fmla="*/ 228600 w 457200"/>
+              <a:gd name="csY1" fmla="*/ 0 h 457200"/>
+              <a:gd name="csX2" fmla="*/ 457200 w 457200"/>
+              <a:gd name="csY2" fmla="*/ 228600 h 457200"/>
+              <a:gd name="csX3" fmla="*/ 228600 w 457200"/>
+              <a:gd name="csY3" fmla="*/ 457200 h 457200"/>
+              <a:gd name="csX4" fmla="*/ 0 w 457200"/>
+              <a:gd name="csY4" fmla="*/ 228600 h 457200"/>
             </a:gdLst>
             <a:ahLst/>
             <a:cxnLst>
               <a:cxn ang="0">
-                <a:pos x="connsiteX0" y="connsiteY0"/>
-              </a:cxn>
-              <a:cxn ang="0">
-                <a:pos x="connsiteX1" y="connsiteY1"/>
-              </a:cxn>
-              <a:cxn ang="0">
-                <a:pos x="connsiteX2" y="connsiteY2"/>
-              </a:cxn>
-              <a:cxn ang="0">
-                <a:pos x="connsiteX3" y="connsiteY3"/>
-              </a:cxn>
-              <a:cxn ang="0">
-                <a:pos x="connsiteX4" y="connsiteY4"/>
+                <a:pos x="csX0" y="csY0"/>
+              </a:cxn>
+              <a:cxn ang="0">
+                <a:pos x="csX1" y="csY1"/>
+              </a:cxn>
+              <a:cxn ang="0">
+                <a:pos x="csX2" y="csY2"/>
+              </a:cxn>
+              <a:cxn ang="0">
+                <a:pos x="csX3" y="csY3"/>
+              </a:cxn>
+              <a:cxn ang="0">
+                <a:pos x="csX4" y="csY4"/>
               </a:cxn>
             </a:cxnLst>
             <a:rect l="l" t="t" r="r" b="b"/>
@@ -11516,63 +11516,63 @@
           <a:custGeom>
             <a:avLst/>
             <a:gdLst>
-              <a:gd name="connsiteX0" fmla="*/ 0 w 2333625"/>
-              <a:gd name="connsiteY0" fmla="*/ 0 h 369332"/>
-              <a:gd name="connsiteX1" fmla="*/ 583406 w 2333625"/>
-              <a:gd name="connsiteY1" fmla="*/ 0 h 369332"/>
-              <a:gd name="connsiteX2" fmla="*/ 1213485 w 2333625"/>
-              <a:gd name="connsiteY2" fmla="*/ 0 h 369332"/>
-              <a:gd name="connsiteX3" fmla="*/ 1773555 w 2333625"/>
-              <a:gd name="connsiteY3" fmla="*/ 0 h 369332"/>
-              <a:gd name="connsiteX4" fmla="*/ 2333625 w 2333625"/>
-              <a:gd name="connsiteY4" fmla="*/ 0 h 369332"/>
-              <a:gd name="connsiteX5" fmla="*/ 2333625 w 2333625"/>
-              <a:gd name="connsiteY5" fmla="*/ 369332 h 369332"/>
-              <a:gd name="connsiteX6" fmla="*/ 1703546 w 2333625"/>
-              <a:gd name="connsiteY6" fmla="*/ 369332 h 369332"/>
-              <a:gd name="connsiteX7" fmla="*/ 1143476 w 2333625"/>
-              <a:gd name="connsiteY7" fmla="*/ 369332 h 369332"/>
-              <a:gd name="connsiteX8" fmla="*/ 583406 w 2333625"/>
-              <a:gd name="connsiteY8" fmla="*/ 369332 h 369332"/>
-              <a:gd name="connsiteX9" fmla="*/ 0 w 2333625"/>
-              <a:gd name="connsiteY9" fmla="*/ 369332 h 369332"/>
-              <a:gd name="connsiteX10" fmla="*/ 0 w 2333625"/>
-              <a:gd name="connsiteY10" fmla="*/ 0 h 369332"/>
+              <a:gd name="csX0" fmla="*/ 0 w 2333625"/>
+              <a:gd name="csY0" fmla="*/ 0 h 369332"/>
+              <a:gd name="csX1" fmla="*/ 583406 w 2333625"/>
+              <a:gd name="csY1" fmla="*/ 0 h 369332"/>
+              <a:gd name="csX2" fmla="*/ 1213485 w 2333625"/>
+              <a:gd name="csY2" fmla="*/ 0 h 369332"/>
+              <a:gd name="csX3" fmla="*/ 1773555 w 2333625"/>
+              <a:gd name="csY3" fmla="*/ 0 h 369332"/>
+              <a:gd name="csX4" fmla="*/ 2333625 w 2333625"/>
+              <a:gd name="csY4" fmla="*/ 0 h 369332"/>
+              <a:gd name="csX5" fmla="*/ 2333625 w 2333625"/>
+              <a:gd name="csY5" fmla="*/ 369332 h 369332"/>
+              <a:gd name="csX6" fmla="*/ 1703546 w 2333625"/>
+              <a:gd name="csY6" fmla="*/ 369332 h 369332"/>
+              <a:gd name="csX7" fmla="*/ 1143476 w 2333625"/>
+              <a:gd name="csY7" fmla="*/ 369332 h 369332"/>
+              <a:gd name="csX8" fmla="*/ 583406 w 2333625"/>
+              <a:gd name="csY8" fmla="*/ 369332 h 369332"/>
+              <a:gd name="csX9" fmla="*/ 0 w 2333625"/>
+              <a:gd name="csY9" fmla="*/ 369332 h 369332"/>
+              <a:gd name="csX10" fmla="*/ 0 w 2333625"/>
+              <a:gd name="csY10" fmla="*/ 0 h 369332"/>
             </a:gdLst>
             <a:ahLst/>
             <a:cxnLst>
               <a:cxn ang="0">
-                <a:pos x="connsiteX0" y="connsiteY0"/>
-              </a:cxn>
-              <a:cxn ang="0">
-                <a:pos x="connsiteX1" y="connsiteY1"/>
-              </a:cxn>
-              <a:cxn ang="0">
-                <a:pos x="connsiteX2" y="connsiteY2"/>
-              </a:cxn>
-              <a:cxn ang="0">
-                <a:pos x="connsiteX3" y="connsiteY3"/>
-              </a:cxn>
-              <a:cxn ang="0">
-                <a:pos x="connsiteX4" y="connsiteY4"/>
-              </a:cxn>
-              <a:cxn ang="0">
-                <a:pos x="connsiteX5" y="connsiteY5"/>
-              </a:cxn>
-              <a:cxn ang="0">
-                <a:pos x="connsiteX6" y="connsiteY6"/>
-              </a:cxn>
-              <a:cxn ang="0">
-                <a:pos x="connsiteX7" y="connsiteY7"/>
-              </a:cxn>
-              <a:cxn ang="0">
-                <a:pos x="connsiteX8" y="connsiteY8"/>
-              </a:cxn>
-              <a:cxn ang="0">
-                <a:pos x="connsiteX9" y="connsiteY9"/>
-              </a:cxn>
-              <a:cxn ang="0">
-                <a:pos x="connsiteX10" y="connsiteY10"/>
+                <a:pos x="csX0" y="csY0"/>
+              </a:cxn>
+              <a:cxn ang="0">
+                <a:pos x="csX1" y="csY1"/>
+              </a:cxn>
+              <a:cxn ang="0">
+                <a:pos x="csX2" y="csY2"/>
+              </a:cxn>
+              <a:cxn ang="0">
+                <a:pos x="csX3" y="csY3"/>
+              </a:cxn>
+              <a:cxn ang="0">
+                <a:pos x="csX4" y="csY4"/>
+              </a:cxn>
+              <a:cxn ang="0">
+                <a:pos x="csX5" y="csY5"/>
+              </a:cxn>
+              <a:cxn ang="0">
+                <a:pos x="csX6" y="csY6"/>
+              </a:cxn>
+              <a:cxn ang="0">
+                <a:pos x="csX7" y="csY7"/>
+              </a:cxn>
+              <a:cxn ang="0">
+                <a:pos x="csX8" y="csY8"/>
+              </a:cxn>
+              <a:cxn ang="0">
+                <a:pos x="csX9" y="csY9"/>
+              </a:cxn>
+              <a:cxn ang="0">
+                <a:pos x="csX10" y="csY10"/>
               </a:cxn>
             </a:cxnLst>
             <a:rect l="l" t="t" r="r" b="b"/>
@@ -11757,63 +11757,63 @@
           <a:custGeom>
             <a:avLst/>
             <a:gdLst>
-              <a:gd name="connsiteX0" fmla="*/ 0 w 2333625"/>
-              <a:gd name="connsiteY0" fmla="*/ 0 h 369332"/>
-              <a:gd name="connsiteX1" fmla="*/ 583406 w 2333625"/>
-              <a:gd name="connsiteY1" fmla="*/ 0 h 369332"/>
-              <a:gd name="connsiteX2" fmla="*/ 1213485 w 2333625"/>
-              <a:gd name="connsiteY2" fmla="*/ 0 h 369332"/>
-              <a:gd name="connsiteX3" fmla="*/ 1773555 w 2333625"/>
-              <a:gd name="connsiteY3" fmla="*/ 0 h 369332"/>
-              <a:gd name="connsiteX4" fmla="*/ 2333625 w 2333625"/>
-              <a:gd name="connsiteY4" fmla="*/ 0 h 369332"/>
-              <a:gd name="connsiteX5" fmla="*/ 2333625 w 2333625"/>
-              <a:gd name="connsiteY5" fmla="*/ 369332 h 369332"/>
-              <a:gd name="connsiteX6" fmla="*/ 1703546 w 2333625"/>
-              <a:gd name="connsiteY6" fmla="*/ 369332 h 369332"/>
-              <a:gd name="connsiteX7" fmla="*/ 1143476 w 2333625"/>
-              <a:gd name="connsiteY7" fmla="*/ 369332 h 369332"/>
-              <a:gd name="connsiteX8" fmla="*/ 583406 w 2333625"/>
-              <a:gd name="connsiteY8" fmla="*/ 369332 h 369332"/>
-              <a:gd name="connsiteX9" fmla="*/ 0 w 2333625"/>
-              <a:gd name="connsiteY9" fmla="*/ 369332 h 369332"/>
-              <a:gd name="connsiteX10" fmla="*/ 0 w 2333625"/>
-              <a:gd name="connsiteY10" fmla="*/ 0 h 369332"/>
+              <a:gd name="csX0" fmla="*/ 0 w 2333625"/>
+              <a:gd name="csY0" fmla="*/ 0 h 369332"/>
+              <a:gd name="csX1" fmla="*/ 583406 w 2333625"/>
+              <a:gd name="csY1" fmla="*/ 0 h 369332"/>
+              <a:gd name="csX2" fmla="*/ 1213485 w 2333625"/>
+              <a:gd name="csY2" fmla="*/ 0 h 369332"/>
+              <a:gd name="csX3" fmla="*/ 1773555 w 2333625"/>
+              <a:gd name="csY3" fmla="*/ 0 h 369332"/>
+              <a:gd name="csX4" fmla="*/ 2333625 w 2333625"/>
+              <a:gd name="csY4" fmla="*/ 0 h 369332"/>
+              <a:gd name="csX5" fmla="*/ 2333625 w 2333625"/>
+              <a:gd name="csY5" fmla="*/ 369332 h 369332"/>
+              <a:gd name="csX6" fmla="*/ 1703546 w 2333625"/>
+              <a:gd name="csY6" fmla="*/ 369332 h 369332"/>
+              <a:gd name="csX7" fmla="*/ 1143476 w 2333625"/>
+              <a:gd name="csY7" fmla="*/ 369332 h 369332"/>
+              <a:gd name="csX8" fmla="*/ 583406 w 2333625"/>
+              <a:gd name="csY8" fmla="*/ 369332 h 369332"/>
+              <a:gd name="csX9" fmla="*/ 0 w 2333625"/>
+              <a:gd name="csY9" fmla="*/ 369332 h 369332"/>
+              <a:gd name="csX10" fmla="*/ 0 w 2333625"/>
+              <a:gd name="csY10" fmla="*/ 0 h 369332"/>
             </a:gdLst>
             <a:ahLst/>
             <a:cxnLst>
               <a:cxn ang="0">
-                <a:pos x="connsiteX0" y="connsiteY0"/>
-              </a:cxn>
-              <a:cxn ang="0">
-                <a:pos x="connsiteX1" y="connsiteY1"/>
-              </a:cxn>
-              <a:cxn ang="0">
-                <a:pos x="connsiteX2" y="connsiteY2"/>
-              </a:cxn>
-              <a:cxn ang="0">
-                <a:pos x="connsiteX3" y="connsiteY3"/>
-              </a:cxn>
-              <a:cxn ang="0">
-                <a:pos x="connsiteX4" y="connsiteY4"/>
-              </a:cxn>
-              <a:cxn ang="0">
-                <a:pos x="connsiteX5" y="connsiteY5"/>
-              </a:cxn>
-              <a:cxn ang="0">
-                <a:pos x="connsiteX6" y="connsiteY6"/>
-              </a:cxn>
-              <a:cxn ang="0">
-                <a:pos x="connsiteX7" y="connsiteY7"/>
-              </a:cxn>
-              <a:cxn ang="0">
-                <a:pos x="connsiteX8" y="connsiteY8"/>
-              </a:cxn>
-              <a:cxn ang="0">
-                <a:pos x="connsiteX9" y="connsiteY9"/>
-              </a:cxn>
-              <a:cxn ang="0">
-                <a:pos x="connsiteX10" y="connsiteY10"/>
+                <a:pos x="csX0" y="csY0"/>
+              </a:cxn>
+              <a:cxn ang="0">
+                <a:pos x="csX1" y="csY1"/>
+              </a:cxn>
+              <a:cxn ang="0">
+                <a:pos x="csX2" y="csY2"/>
+              </a:cxn>
+              <a:cxn ang="0">
+                <a:pos x="csX3" y="csY3"/>
+              </a:cxn>
+              <a:cxn ang="0">
+                <a:pos x="csX4" y="csY4"/>
+              </a:cxn>
+              <a:cxn ang="0">
+                <a:pos x="csX5" y="csY5"/>
+              </a:cxn>
+              <a:cxn ang="0">
+                <a:pos x="csX6" y="csY6"/>
+              </a:cxn>
+              <a:cxn ang="0">
+                <a:pos x="csX7" y="csY7"/>
+              </a:cxn>
+              <a:cxn ang="0">
+                <a:pos x="csX8" y="csY8"/>
+              </a:cxn>
+              <a:cxn ang="0">
+                <a:pos x="csX9" y="csY9"/>
+              </a:cxn>
+              <a:cxn ang="0">
+                <a:pos x="csX10" y="csY10"/>
               </a:cxn>
             </a:cxnLst>
             <a:rect l="l" t="t" r="r" b="b"/>
@@ -11998,63 +11998,63 @@
           <a:custGeom>
             <a:avLst/>
             <a:gdLst>
-              <a:gd name="connsiteX0" fmla="*/ 0 w 2333625"/>
-              <a:gd name="connsiteY0" fmla="*/ 0 h 369332"/>
-              <a:gd name="connsiteX1" fmla="*/ 583406 w 2333625"/>
-              <a:gd name="connsiteY1" fmla="*/ 0 h 369332"/>
-              <a:gd name="connsiteX2" fmla="*/ 1213485 w 2333625"/>
-              <a:gd name="connsiteY2" fmla="*/ 0 h 369332"/>
-              <a:gd name="connsiteX3" fmla="*/ 1773555 w 2333625"/>
-              <a:gd name="connsiteY3" fmla="*/ 0 h 369332"/>
-              <a:gd name="connsiteX4" fmla="*/ 2333625 w 2333625"/>
-              <a:gd name="connsiteY4" fmla="*/ 0 h 369332"/>
-              <a:gd name="connsiteX5" fmla="*/ 2333625 w 2333625"/>
-              <a:gd name="connsiteY5" fmla="*/ 369332 h 369332"/>
-              <a:gd name="connsiteX6" fmla="*/ 1703546 w 2333625"/>
-              <a:gd name="connsiteY6" fmla="*/ 369332 h 369332"/>
-              <a:gd name="connsiteX7" fmla="*/ 1143476 w 2333625"/>
-              <a:gd name="connsiteY7" fmla="*/ 369332 h 369332"/>
-              <a:gd name="connsiteX8" fmla="*/ 583406 w 2333625"/>
-              <a:gd name="connsiteY8" fmla="*/ 369332 h 369332"/>
-              <a:gd name="connsiteX9" fmla="*/ 0 w 2333625"/>
-              <a:gd name="connsiteY9" fmla="*/ 369332 h 369332"/>
-              <a:gd name="connsiteX10" fmla="*/ 0 w 2333625"/>
-              <a:gd name="connsiteY10" fmla="*/ 0 h 369332"/>
+              <a:gd name="csX0" fmla="*/ 0 w 2333625"/>
+              <a:gd name="csY0" fmla="*/ 0 h 369332"/>
+              <a:gd name="csX1" fmla="*/ 583406 w 2333625"/>
+              <a:gd name="csY1" fmla="*/ 0 h 369332"/>
+              <a:gd name="csX2" fmla="*/ 1213485 w 2333625"/>
+              <a:gd name="csY2" fmla="*/ 0 h 369332"/>
+              <a:gd name="csX3" fmla="*/ 1773555 w 2333625"/>
+              <a:gd name="csY3" fmla="*/ 0 h 369332"/>
+              <a:gd name="csX4" fmla="*/ 2333625 w 2333625"/>
+              <a:gd name="csY4" fmla="*/ 0 h 369332"/>
+              <a:gd name="csX5" fmla="*/ 2333625 w 2333625"/>
+              <a:gd name="csY5" fmla="*/ 369332 h 369332"/>
+              <a:gd name="csX6" fmla="*/ 1703546 w 2333625"/>
+              <a:gd name="csY6" fmla="*/ 369332 h 369332"/>
+              <a:gd name="csX7" fmla="*/ 1143476 w 2333625"/>
+              <a:gd name="csY7" fmla="*/ 369332 h 369332"/>
+              <a:gd name="csX8" fmla="*/ 583406 w 2333625"/>
+              <a:gd name="csY8" fmla="*/ 369332 h 369332"/>
+              <a:gd name="csX9" fmla="*/ 0 w 2333625"/>
+              <a:gd name="csY9" fmla="*/ 369332 h 369332"/>
+              <a:gd name="csX10" fmla="*/ 0 w 2333625"/>
+              <a:gd name="csY10" fmla="*/ 0 h 369332"/>
             </a:gdLst>
             <a:ahLst/>
             <a:cxnLst>
               <a:cxn ang="0">
-                <a:pos x="connsiteX0" y="connsiteY0"/>
-              </a:cxn>
-              <a:cxn ang="0">
-                <a:pos x="connsiteX1" y="connsiteY1"/>
-              </a:cxn>
-              <a:cxn ang="0">
-                <a:pos x="connsiteX2" y="connsiteY2"/>
-              </a:cxn>
-              <a:cxn ang="0">
-                <a:pos x="connsiteX3" y="connsiteY3"/>
-              </a:cxn>
-              <a:cxn ang="0">
-                <a:pos x="connsiteX4" y="connsiteY4"/>
-              </a:cxn>
-              <a:cxn ang="0">
-                <a:pos x="connsiteX5" y="connsiteY5"/>
-              </a:cxn>
-              <a:cxn ang="0">
-                <a:pos x="connsiteX6" y="connsiteY6"/>
-              </a:cxn>
-              <a:cxn ang="0">
-                <a:pos x="connsiteX7" y="connsiteY7"/>
-              </a:cxn>
-              <a:cxn ang="0">
-                <a:pos x="connsiteX8" y="connsiteY8"/>
-              </a:cxn>
-              <a:cxn ang="0">
-                <a:pos x="connsiteX9" y="connsiteY9"/>
-              </a:cxn>
-              <a:cxn ang="0">
-                <a:pos x="connsiteX10" y="connsiteY10"/>
+                <a:pos x="csX0" y="csY0"/>
+              </a:cxn>
+              <a:cxn ang="0">
+                <a:pos x="csX1" y="csY1"/>
+              </a:cxn>
+              <a:cxn ang="0">
+                <a:pos x="csX2" y="csY2"/>
+              </a:cxn>
+              <a:cxn ang="0">
+                <a:pos x="csX3" y="csY3"/>
+              </a:cxn>
+              <a:cxn ang="0">
+                <a:pos x="csX4" y="csY4"/>
+              </a:cxn>
+              <a:cxn ang="0">
+                <a:pos x="csX5" y="csY5"/>
+              </a:cxn>
+              <a:cxn ang="0">
+                <a:pos x="csX6" y="csY6"/>
+              </a:cxn>
+              <a:cxn ang="0">
+                <a:pos x="csX7" y="csY7"/>
+              </a:cxn>
+              <a:cxn ang="0">
+                <a:pos x="csX8" y="csY8"/>
+              </a:cxn>
+              <a:cxn ang="0">
+                <a:pos x="csX9" y="csY9"/>
+              </a:cxn>
+              <a:cxn ang="0">
+                <a:pos x="csX10" y="csY10"/>
               </a:cxn>
             </a:cxnLst>
             <a:rect l="l" t="t" r="r" b="b"/>
@@ -12239,63 +12239,63 @@
           <a:custGeom>
             <a:avLst/>
             <a:gdLst>
-              <a:gd name="connsiteX0" fmla="*/ 0 w 2333625"/>
-              <a:gd name="connsiteY0" fmla="*/ 0 h 369332"/>
-              <a:gd name="connsiteX1" fmla="*/ 583406 w 2333625"/>
-              <a:gd name="connsiteY1" fmla="*/ 0 h 369332"/>
-              <a:gd name="connsiteX2" fmla="*/ 1213485 w 2333625"/>
-              <a:gd name="connsiteY2" fmla="*/ 0 h 369332"/>
-              <a:gd name="connsiteX3" fmla="*/ 1773555 w 2333625"/>
-              <a:gd name="connsiteY3" fmla="*/ 0 h 369332"/>
-              <a:gd name="connsiteX4" fmla="*/ 2333625 w 2333625"/>
-              <a:gd name="connsiteY4" fmla="*/ 0 h 369332"/>
-              <a:gd name="connsiteX5" fmla="*/ 2333625 w 2333625"/>
-              <a:gd name="connsiteY5" fmla="*/ 369332 h 369332"/>
-              <a:gd name="connsiteX6" fmla="*/ 1703546 w 2333625"/>
-              <a:gd name="connsiteY6" fmla="*/ 369332 h 369332"/>
-              <a:gd name="connsiteX7" fmla="*/ 1143476 w 2333625"/>
-              <a:gd name="connsiteY7" fmla="*/ 369332 h 369332"/>
-              <a:gd name="connsiteX8" fmla="*/ 583406 w 2333625"/>
-              <a:gd name="connsiteY8" fmla="*/ 369332 h 369332"/>
-              <a:gd name="connsiteX9" fmla="*/ 0 w 2333625"/>
-              <a:gd name="connsiteY9" fmla="*/ 369332 h 369332"/>
-              <a:gd name="connsiteX10" fmla="*/ 0 w 2333625"/>
-              <a:gd name="connsiteY10" fmla="*/ 0 h 369332"/>
+              <a:gd name="csX0" fmla="*/ 0 w 2333625"/>
+              <a:gd name="csY0" fmla="*/ 0 h 369332"/>
+              <a:gd name="csX1" fmla="*/ 583406 w 2333625"/>
+              <a:gd name="csY1" fmla="*/ 0 h 369332"/>
+              <a:gd name="csX2" fmla="*/ 1213485 w 2333625"/>
+              <a:gd name="csY2" fmla="*/ 0 h 369332"/>
+              <a:gd name="csX3" fmla="*/ 1773555 w 2333625"/>
+              <a:gd name="csY3" fmla="*/ 0 h 369332"/>
+              <a:gd name="csX4" fmla="*/ 2333625 w 2333625"/>
+              <a:gd name="csY4" fmla="*/ 0 h 369332"/>
+              <a:gd name="csX5" fmla="*/ 2333625 w 2333625"/>
+              <a:gd name="csY5" fmla="*/ 369332 h 369332"/>
+              <a:gd name="csX6" fmla="*/ 1703546 w 2333625"/>
+              <a:gd name="csY6" fmla="*/ 369332 h 369332"/>
+              <a:gd name="csX7" fmla="*/ 1143476 w 2333625"/>
+              <a:gd name="csY7" fmla="*/ 369332 h 369332"/>
+              <a:gd name="csX8" fmla="*/ 583406 w 2333625"/>
+              <a:gd name="csY8" fmla="*/ 369332 h 369332"/>
+              <a:gd name="csX9" fmla="*/ 0 w 2333625"/>
+              <a:gd name="csY9" fmla="*/ 369332 h 369332"/>
+              <a:gd name="csX10" fmla="*/ 0 w 2333625"/>
+              <a:gd name="csY10" fmla="*/ 0 h 369332"/>
             </a:gdLst>
             <a:ahLst/>
             <a:cxnLst>
               <a:cxn ang="0">
-                <a:pos x="connsiteX0" y="connsiteY0"/>
-              </a:cxn>
-              <a:cxn ang="0">
-                <a:pos x="connsiteX1" y="connsiteY1"/>
-              </a:cxn>
-              <a:cxn ang="0">
-                <a:pos x="connsiteX2" y="connsiteY2"/>
-              </a:cxn>
-              <a:cxn ang="0">
-                <a:pos x="connsiteX3" y="connsiteY3"/>
-              </a:cxn>
-              <a:cxn ang="0">
-                <a:pos x="connsiteX4" y="connsiteY4"/>
-              </a:cxn>
-              <a:cxn ang="0">
-                <a:pos x="connsiteX5" y="connsiteY5"/>
-              </a:cxn>
-              <a:cxn ang="0">
-                <a:pos x="connsiteX6" y="connsiteY6"/>
-              </a:cxn>
-              <a:cxn ang="0">
-                <a:pos x="connsiteX7" y="connsiteY7"/>
-              </a:cxn>
-              <a:cxn ang="0">
-                <a:pos x="connsiteX8" y="connsiteY8"/>
-              </a:cxn>
-              <a:cxn ang="0">
-                <a:pos x="connsiteX9" y="connsiteY9"/>
-              </a:cxn>
-              <a:cxn ang="0">
-                <a:pos x="connsiteX10" y="connsiteY10"/>
+                <a:pos x="csX0" y="csY0"/>
+              </a:cxn>
+              <a:cxn ang="0">
+                <a:pos x="csX1" y="csY1"/>
+              </a:cxn>
+              <a:cxn ang="0">
+                <a:pos x="csX2" y="csY2"/>
+              </a:cxn>
+              <a:cxn ang="0">
+                <a:pos x="csX3" y="csY3"/>
+              </a:cxn>
+              <a:cxn ang="0">
+                <a:pos x="csX4" y="csY4"/>
+              </a:cxn>
+              <a:cxn ang="0">
+                <a:pos x="csX5" y="csY5"/>
+              </a:cxn>
+              <a:cxn ang="0">
+                <a:pos x="csX6" y="csY6"/>
+              </a:cxn>
+              <a:cxn ang="0">
+                <a:pos x="csX7" y="csY7"/>
+              </a:cxn>
+              <a:cxn ang="0">
+                <a:pos x="csX8" y="csY8"/>
+              </a:cxn>
+              <a:cxn ang="0">
+                <a:pos x="csX9" y="csY9"/>
+              </a:cxn>
+              <a:cxn ang="0">
+                <a:pos x="csX10" y="csY10"/>
               </a:cxn>
             </a:cxnLst>
             <a:rect l="l" t="t" r="r" b="b"/>

</xml_diff>

<commit_message>
feat(docs): update intro slides
</commit_message>
<xml_diff>
--- a/slides/1-intro.pptx
+++ b/slides/1-intro.pptx
@@ -5,7 +5,7 @@
     <p:sldMasterId id="2147483696" r:id="rId1"/>
   </p:sldMasterIdLst>
   <p:notesMasterIdLst>
-    <p:notesMasterId r:id="rId21"/>
+    <p:notesMasterId r:id="rId20"/>
   </p:notesMasterIdLst>
   <p:sldIdLst>
     <p:sldId id="256" r:id="rId2"/>
@@ -15,18 +15,17 @@
     <p:sldId id="265" r:id="rId6"/>
     <p:sldId id="258" r:id="rId7"/>
     <p:sldId id="259" r:id="rId8"/>
-    <p:sldId id="260" r:id="rId9"/>
-    <p:sldId id="262" r:id="rId10"/>
-    <p:sldId id="266" r:id="rId11"/>
-    <p:sldId id="267" r:id="rId12"/>
-    <p:sldId id="268" r:id="rId13"/>
-    <p:sldId id="269" r:id="rId14"/>
-    <p:sldId id="270" r:id="rId15"/>
-    <p:sldId id="271" r:id="rId16"/>
-    <p:sldId id="272" r:id="rId17"/>
-    <p:sldId id="273" r:id="rId18"/>
-    <p:sldId id="261" r:id="rId19"/>
-    <p:sldId id="274" r:id="rId20"/>
+    <p:sldId id="262" r:id="rId9"/>
+    <p:sldId id="266" r:id="rId10"/>
+    <p:sldId id="267" r:id="rId11"/>
+    <p:sldId id="268" r:id="rId12"/>
+    <p:sldId id="269" r:id="rId13"/>
+    <p:sldId id="270" r:id="rId14"/>
+    <p:sldId id="271" r:id="rId15"/>
+    <p:sldId id="272" r:id="rId16"/>
+    <p:sldId id="273" r:id="rId17"/>
+    <p:sldId id="261" r:id="rId18"/>
+    <p:sldId id="274" r:id="rId19"/>
   </p:sldIdLst>
   <p:sldSz cx="12192000" cy="6858000"/>
   <p:notesSz cx="6858000" cy="9144000"/>
@@ -627,23 +626,50 @@
           <a:p>
             <a:r>
               <a:rPr lang="en-US" dirty="0"/>
-              <a:t>Recent debates have been clouded by a misleading inference pattern, which we term the “Redescription Fallacy.” This fallacy arises when critics argue that a system cannot model a particular cognitive capacity, simply because its operations can be explained in less abstract and more deflationary terms. In the present context, the fallacy manifests in claims that LLMs could not possibly be good models of some cognitive capacity 𝜙 because their operations merely consist in a collection of statistical calculations, or linear algebra operations, or next-token predictions. Such arguments are only valid if accompanied by evidence demonstrating that a system, defined in these terms, is inherently incapable of implementing 𝜙. To illustrate, consider the flawed logic in asserting that a piano could not possibly produce harmony because it can be described as a collection of hammers striking strings, or (more pointedly) that brain activity could not possibly implement cognition because it can be described as a collection of neural firings. The critical question is not whether the operations of an LLM can be simplistically described in non-mental terms, but whether these operations, when appropriately organized, can implement the same processes or algorithms as the mind, when described at an appropriate level of computational abstraction.</a:t>
-            </a:r>
-          </a:p>
-          <a:p>
-            <a:r>
-              <a:rPr lang="en-US" dirty="0" err="1">
-                <a:ea typeface="Calibri"/>
-                <a:cs typeface="Calibri"/>
-              </a:rPr>
-              <a:t>Milliere</a:t>
-            </a:r>
-            <a:r>
-              <a:rPr lang="en-US" dirty="0">
-                <a:ea typeface="Calibri"/>
-                <a:cs typeface="Calibri"/>
-              </a:rPr>
-              <a:t> and Buckner, 2024</a:t>
+              <a:t>Welcome to introduction to large </a:t>
+            </a:r>
+            <a:r>
+              <a:rPr lang="en-US" dirty="0" err="1"/>
+              <a:t>langauge</a:t>
+            </a:r>
+            <a:r>
+              <a:rPr lang="en-US" dirty="0"/>
+              <a:t> models</a:t>
+            </a:r>
+          </a:p>
+          <a:p>
+            <a:endParaRPr lang="en-US" dirty="0"/>
+          </a:p>
+          <a:p>
+            <a:r>
+              <a:rPr lang="en-US" dirty="0"/>
+              <a:t>I’m Fin – MLE and I will be running workshop today</a:t>
+            </a:r>
+          </a:p>
+          <a:p>
+            <a:endParaRPr lang="en-US" dirty="0"/>
+          </a:p>
+          <a:p>
+            <a:r>
+              <a:rPr lang="en-US" dirty="0"/>
+              <a:t>Radzim and </a:t>
+            </a:r>
+            <a:r>
+              <a:rPr lang="en-US" dirty="0" err="1"/>
+              <a:t>Faibra</a:t>
+            </a:r>
+            <a:r>
+              <a:rPr lang="en-US" dirty="0"/>
+              <a:t> on hand to answer technical questions, who are engineers</a:t>
+            </a:r>
+          </a:p>
+          <a:p>
+            <a:endParaRPr lang="en-US" dirty="0"/>
+          </a:p>
+          <a:p>
+            <a:r>
+              <a:rPr lang="en-US" dirty="0"/>
+              <a:t>Will give you more of an intro on our group:</a:t>
             </a:r>
           </a:p>
         </p:txBody>
@@ -664,16 +690,989 @@
           <a:lstStyle/>
           <a:p>
             <a:fld id="{C2D7E69D-609B-4983-96D1-38CC478AEB14}" type="slidenum">
-              <a:t>8</a:t>
+              <a:rPr lang="en-GB" smtClean="0"/>
+              <a:t>1</a:t>
             </a:fld>
-            <a:endParaRPr lang="en-US"/>
+            <a:endParaRPr lang="en-GB"/>
           </a:p>
         </p:txBody>
       </p:sp>
     </p:spTree>
     <p:extLst>
       <p:ext uri="{BB962C8B-B14F-4D97-AF65-F5344CB8AC3E}">
-        <p14:creationId xmlns:p14="http://schemas.microsoft.com/office/powerpoint/2010/main" val="2758583674"/>
+        <p14:creationId xmlns:p14="http://schemas.microsoft.com/office/powerpoint/2010/main" val="2744497436"/>
+      </p:ext>
+    </p:extLst>
+  </p:cSld>
+  <p:clrMapOvr>
+    <a:masterClrMapping/>
+  </p:clrMapOvr>
+</p:notes>
+</file>
+
+<file path=ppt/notesSlides/notesSlide10.xml><?xml version="1.0" encoding="utf-8"?>
+<p:notes xmlns:a="http://schemas.openxmlformats.org/drawingml/2006/main" xmlns:r="http://schemas.openxmlformats.org/officeDocument/2006/relationships" xmlns:p="http://schemas.openxmlformats.org/presentationml/2006/main">
+  <p:cSld>
+    <p:spTree>
+      <p:nvGrpSpPr>
+        <p:cNvPr id="1" name=""/>
+        <p:cNvGrpSpPr/>
+        <p:nvPr/>
+      </p:nvGrpSpPr>
+      <p:grpSpPr>
+        <a:xfrm>
+          <a:off x="0" y="0"/>
+          <a:ext cx="0" cy="0"/>
+          <a:chOff x="0" y="0"/>
+          <a:chExt cx="0" cy="0"/>
+        </a:xfrm>
+      </p:grpSpPr>
+      <p:sp>
+        <p:nvSpPr>
+          <p:cNvPr id="2" name="Slide Image Placeholder 1"/>
+          <p:cNvSpPr>
+            <a:spLocks noGrp="1" noRot="1" noChangeAspect="1"/>
+          </p:cNvSpPr>
+          <p:nvPr>
+            <p:ph type="sldImg"/>
+          </p:nvPr>
+        </p:nvSpPr>
+        <p:spPr/>
+      </p:sp>
+      <p:sp>
+        <p:nvSpPr>
+          <p:cNvPr id="3" name="Notes Placeholder 2"/>
+          <p:cNvSpPr>
+            <a:spLocks noGrp="1"/>
+          </p:cNvSpPr>
+          <p:nvPr>
+            <p:ph type="body" idx="1"/>
+          </p:nvPr>
+        </p:nvSpPr>
+        <p:spPr/>
+        <p:txBody>
+          <a:bodyPr/>
+          <a:lstStyle/>
+          <a:p>
+            <a:endParaRPr lang="en-US" dirty="0"/>
+          </a:p>
+        </p:txBody>
+      </p:sp>
+      <p:sp>
+        <p:nvSpPr>
+          <p:cNvPr id="4" name="Slide Number Placeholder 3"/>
+          <p:cNvSpPr>
+            <a:spLocks noGrp="1"/>
+          </p:cNvSpPr>
+          <p:nvPr>
+            <p:ph type="sldNum" sz="quarter" idx="5"/>
+          </p:nvPr>
+        </p:nvSpPr>
+        <p:spPr/>
+        <p:txBody>
+          <a:bodyPr/>
+          <a:lstStyle/>
+          <a:p>
+            <a:fld id="{C2D7E69D-609B-4983-96D1-38CC478AEB14}" type="slidenum">
+              <a:rPr lang="en-GB" smtClean="0"/>
+              <a:t>15</a:t>
+            </a:fld>
+            <a:endParaRPr lang="en-GB"/>
+          </a:p>
+        </p:txBody>
+      </p:sp>
+    </p:spTree>
+    <p:extLst>
+      <p:ext uri="{BB962C8B-B14F-4D97-AF65-F5344CB8AC3E}">
+        <p14:creationId xmlns:p14="http://schemas.microsoft.com/office/powerpoint/2010/main" val="1079868011"/>
+      </p:ext>
+    </p:extLst>
+  </p:cSld>
+  <p:clrMapOvr>
+    <a:masterClrMapping/>
+  </p:clrMapOvr>
+</p:notes>
+</file>
+
+<file path=ppt/notesSlides/notesSlide2.xml><?xml version="1.0" encoding="utf-8"?>
+<p:notes xmlns:a="http://schemas.openxmlformats.org/drawingml/2006/main" xmlns:r="http://schemas.openxmlformats.org/officeDocument/2006/relationships" xmlns:p="http://schemas.openxmlformats.org/presentationml/2006/main">
+  <p:cSld>
+    <p:spTree>
+      <p:nvGrpSpPr>
+        <p:cNvPr id="1" name=""/>
+        <p:cNvGrpSpPr/>
+        <p:nvPr/>
+      </p:nvGrpSpPr>
+      <p:grpSpPr>
+        <a:xfrm>
+          <a:off x="0" y="0"/>
+          <a:ext cx="0" cy="0"/>
+          <a:chOff x="0" y="0"/>
+          <a:chExt cx="0" cy="0"/>
+        </a:xfrm>
+      </p:grpSpPr>
+      <p:sp>
+        <p:nvSpPr>
+          <p:cNvPr id="2" name="Slide Image Placeholder 1"/>
+          <p:cNvSpPr>
+            <a:spLocks noGrp="1" noRot="1" noChangeAspect="1"/>
+          </p:cNvSpPr>
+          <p:nvPr>
+            <p:ph type="sldImg"/>
+          </p:nvPr>
+        </p:nvSpPr>
+        <p:spPr/>
+      </p:sp>
+      <p:sp>
+        <p:nvSpPr>
+          <p:cNvPr id="3" name="Notes Placeholder 2"/>
+          <p:cNvSpPr>
+            <a:spLocks noGrp="1"/>
+          </p:cNvSpPr>
+          <p:nvPr>
+            <p:ph type="body" idx="1"/>
+          </p:nvPr>
+        </p:nvSpPr>
+        <p:spPr/>
+        <p:txBody>
+          <a:bodyPr/>
+          <a:lstStyle/>
+          <a:p>
+            <a:endParaRPr lang="en-US" dirty="0"/>
+          </a:p>
+          <a:p>
+            <a:r>
+              <a:rPr lang="en-US" dirty="0"/>
+              <a:t>Just before we get started, I would just like to give a brief overview of the Accelerate program.</a:t>
+            </a:r>
+          </a:p>
+          <a:p>
+            <a:endParaRPr lang="en-US" dirty="0"/>
+          </a:p>
+          <a:p>
+            <a:r>
+              <a:rPr lang="en-US" dirty="0"/>
+              <a:t>We are a group composed of researchers, machine learning engineers and </a:t>
+            </a:r>
+            <a:r>
+              <a:rPr lang="en-US" dirty="0" err="1"/>
+              <a:t>programme</a:t>
+            </a:r>
+            <a:r>
+              <a:rPr lang="en-US" dirty="0"/>
+              <a:t> staff.</a:t>
+            </a:r>
+          </a:p>
+          <a:p>
+            <a:endParaRPr lang="en-US" dirty="0"/>
+          </a:p>
+          <a:p>
+            <a:r>
+              <a:rPr lang="en-US" dirty="0"/>
+              <a:t>Our overarching goal is to support the adoption of AI in research at the university. </a:t>
+            </a:r>
+          </a:p>
+          <a:p>
+            <a:endParaRPr lang="en-US" dirty="0"/>
+          </a:p>
+          <a:p>
+            <a:r>
+              <a:rPr lang="en-US" dirty="0"/>
+              <a:t>We do this through activities such as</a:t>
+            </a:r>
+          </a:p>
+          <a:p>
+            <a:endParaRPr lang="en-US" dirty="0"/>
+          </a:p>
+          <a:p>
+            <a:r>
+              <a:rPr lang="en-US" dirty="0"/>
+              <a:t>Workshops (see in a second), AI Clinic, sections of university-wide workshops / events that are supported by us</a:t>
+            </a:r>
+          </a:p>
+          <a:p>
+            <a:endParaRPr lang="en-US" dirty="0"/>
+          </a:p>
+          <a:p>
+            <a:r>
+              <a:rPr lang="en-US" dirty="0"/>
+              <a:t>But also longer-term involvement on research projects in a research engineering capacity.</a:t>
+            </a:r>
+          </a:p>
+          <a:p>
+            <a:endParaRPr lang="en-US" dirty="0"/>
+          </a:p>
+          <a:p>
+            <a:r>
+              <a:rPr lang="en-US" dirty="0"/>
+              <a:t>Not just intersection of AI and Science!</a:t>
+            </a:r>
+          </a:p>
+          <a:p>
+            <a:endParaRPr lang="en-US" dirty="0"/>
+          </a:p>
+          <a:p>
+            <a:r>
+              <a:rPr lang="en-US" dirty="0"/>
+              <a:t>We’re finding more and more that researchers from the Humanities want to utilize machine learning methods, and we’re having to reassess what we think of as traditional science.</a:t>
+            </a:r>
+          </a:p>
+          <a:p>
+            <a:endParaRPr lang="en-US" dirty="0"/>
+          </a:p>
+        </p:txBody>
+      </p:sp>
+      <p:sp>
+        <p:nvSpPr>
+          <p:cNvPr id="4" name="Slide Number Placeholder 3"/>
+          <p:cNvSpPr>
+            <a:spLocks noGrp="1"/>
+          </p:cNvSpPr>
+          <p:nvPr>
+            <p:ph type="sldNum" sz="quarter" idx="5"/>
+          </p:nvPr>
+        </p:nvSpPr>
+        <p:spPr/>
+        <p:txBody>
+          <a:bodyPr/>
+          <a:lstStyle/>
+          <a:p>
+            <a:fld id="{C2D7E69D-609B-4983-96D1-38CC478AEB14}" type="slidenum">
+              <a:rPr lang="en-GB" smtClean="0"/>
+              <a:t>2</a:t>
+            </a:fld>
+            <a:endParaRPr lang="en-GB"/>
+          </a:p>
+        </p:txBody>
+      </p:sp>
+    </p:spTree>
+    <p:extLst>
+      <p:ext uri="{BB962C8B-B14F-4D97-AF65-F5344CB8AC3E}">
+        <p14:creationId xmlns:p14="http://schemas.microsoft.com/office/powerpoint/2010/main" val="3450249160"/>
+      </p:ext>
+    </p:extLst>
+  </p:cSld>
+  <p:clrMapOvr>
+    <a:masterClrMapping/>
+  </p:clrMapOvr>
+</p:notes>
+</file>
+
+<file path=ppt/notesSlides/notesSlide3.xml><?xml version="1.0" encoding="utf-8"?>
+<p:notes xmlns:a="http://schemas.openxmlformats.org/drawingml/2006/main" xmlns:r="http://schemas.openxmlformats.org/officeDocument/2006/relationships" xmlns:p="http://schemas.openxmlformats.org/presentationml/2006/main">
+  <p:cSld>
+    <p:spTree>
+      <p:nvGrpSpPr>
+        <p:cNvPr id="1" name=""/>
+        <p:cNvGrpSpPr/>
+        <p:nvPr/>
+      </p:nvGrpSpPr>
+      <p:grpSpPr>
+        <a:xfrm>
+          <a:off x="0" y="0"/>
+          <a:ext cx="0" cy="0"/>
+          <a:chOff x="0" y="0"/>
+          <a:chExt cx="0" cy="0"/>
+        </a:xfrm>
+      </p:grpSpPr>
+      <p:sp>
+        <p:nvSpPr>
+          <p:cNvPr id="2" name="Slide Image Placeholder 1"/>
+          <p:cNvSpPr>
+            <a:spLocks noGrp="1" noRot="1" noChangeAspect="1"/>
+          </p:cNvSpPr>
+          <p:nvPr>
+            <p:ph type="sldImg"/>
+          </p:nvPr>
+        </p:nvSpPr>
+        <p:spPr/>
+      </p:sp>
+      <p:sp>
+        <p:nvSpPr>
+          <p:cNvPr id="3" name="Notes Placeholder 2"/>
+          <p:cNvSpPr>
+            <a:spLocks noGrp="1"/>
+          </p:cNvSpPr>
+          <p:nvPr>
+            <p:ph type="body" idx="1"/>
+          </p:nvPr>
+        </p:nvSpPr>
+        <p:spPr/>
+        <p:txBody>
+          <a:bodyPr/>
+          <a:lstStyle/>
+          <a:p>
+            <a:r>
+              <a:rPr lang="en-US" dirty="0"/>
+              <a:t>We are ultimately here to facilitate this process of integrating AI into research.</a:t>
+            </a:r>
+          </a:p>
+          <a:p>
+            <a:endParaRPr lang="en-US" dirty="0"/>
+          </a:p>
+          <a:p>
+            <a:r>
+              <a:rPr lang="en-US" dirty="0"/>
+              <a:t>We run a couple of workshops at the moment: an introduction to large language models, a hands on LLMs, generative AI, diffusion models, docker, a packaging and publishing workshop, and now a new agents 4 science workshop</a:t>
+            </a:r>
+          </a:p>
+        </p:txBody>
+      </p:sp>
+      <p:sp>
+        <p:nvSpPr>
+          <p:cNvPr id="4" name="Slide Number Placeholder 3"/>
+          <p:cNvSpPr>
+            <a:spLocks noGrp="1"/>
+          </p:cNvSpPr>
+          <p:nvPr>
+            <p:ph type="sldNum" sz="quarter" idx="5"/>
+          </p:nvPr>
+        </p:nvSpPr>
+        <p:spPr/>
+        <p:txBody>
+          <a:bodyPr/>
+          <a:lstStyle/>
+          <a:p>
+            <a:fld id="{C2D7E69D-609B-4983-96D1-38CC478AEB14}" type="slidenum">
+              <a:rPr lang="en-GB" smtClean="0"/>
+              <a:t>3</a:t>
+            </a:fld>
+            <a:endParaRPr lang="en-GB"/>
+          </a:p>
+        </p:txBody>
+      </p:sp>
+    </p:spTree>
+    <p:extLst>
+      <p:ext uri="{BB962C8B-B14F-4D97-AF65-F5344CB8AC3E}">
+        <p14:creationId xmlns:p14="http://schemas.microsoft.com/office/powerpoint/2010/main" val="4144999791"/>
+      </p:ext>
+    </p:extLst>
+  </p:cSld>
+  <p:clrMapOvr>
+    <a:masterClrMapping/>
+  </p:clrMapOvr>
+</p:notes>
+</file>
+
+<file path=ppt/notesSlides/notesSlide4.xml><?xml version="1.0" encoding="utf-8"?>
+<p:notes xmlns:a="http://schemas.openxmlformats.org/drawingml/2006/main" xmlns:r="http://schemas.openxmlformats.org/officeDocument/2006/relationships" xmlns:p="http://schemas.openxmlformats.org/presentationml/2006/main">
+  <p:cSld>
+    <p:spTree>
+      <p:nvGrpSpPr>
+        <p:cNvPr id="1" name=""/>
+        <p:cNvGrpSpPr/>
+        <p:nvPr/>
+      </p:nvGrpSpPr>
+      <p:grpSpPr>
+        <a:xfrm>
+          <a:off x="0" y="0"/>
+          <a:ext cx="0" cy="0"/>
+          <a:chOff x="0" y="0"/>
+          <a:chExt cx="0" cy="0"/>
+        </a:xfrm>
+      </p:grpSpPr>
+      <p:sp>
+        <p:nvSpPr>
+          <p:cNvPr id="2" name="Slide Image Placeholder 1"/>
+          <p:cNvSpPr>
+            <a:spLocks noGrp="1" noRot="1" noChangeAspect="1"/>
+          </p:cNvSpPr>
+          <p:nvPr>
+            <p:ph type="sldImg"/>
+          </p:nvPr>
+        </p:nvSpPr>
+        <p:spPr/>
+      </p:sp>
+      <p:sp>
+        <p:nvSpPr>
+          <p:cNvPr id="3" name="Notes Placeholder 2"/>
+          <p:cNvSpPr>
+            <a:spLocks noGrp="1"/>
+          </p:cNvSpPr>
+          <p:nvPr>
+            <p:ph type="body" idx="1"/>
+          </p:nvPr>
+        </p:nvSpPr>
+        <p:spPr/>
+        <p:txBody>
+          <a:bodyPr/>
+          <a:lstStyle/>
+          <a:p>
+            <a:r>
+              <a:rPr lang="en-US" dirty="0"/>
+              <a:t>Allow 5 minutes</a:t>
+            </a:r>
+          </a:p>
+        </p:txBody>
+      </p:sp>
+      <p:sp>
+        <p:nvSpPr>
+          <p:cNvPr id="4" name="Slide Number Placeholder 3"/>
+          <p:cNvSpPr>
+            <a:spLocks noGrp="1"/>
+          </p:cNvSpPr>
+          <p:nvPr>
+            <p:ph type="sldNum" sz="quarter" idx="5"/>
+          </p:nvPr>
+        </p:nvSpPr>
+        <p:spPr/>
+        <p:txBody>
+          <a:bodyPr/>
+          <a:lstStyle/>
+          <a:p>
+            <a:fld id="{C2D7E69D-609B-4983-96D1-38CC478AEB14}" type="slidenum">
+              <a:rPr lang="en-GB" smtClean="0"/>
+              <a:t>5</a:t>
+            </a:fld>
+            <a:endParaRPr lang="en-GB"/>
+          </a:p>
+        </p:txBody>
+      </p:sp>
+    </p:spTree>
+    <p:extLst>
+      <p:ext uri="{BB962C8B-B14F-4D97-AF65-F5344CB8AC3E}">
+        <p14:creationId xmlns:p14="http://schemas.microsoft.com/office/powerpoint/2010/main" val="3075358069"/>
+      </p:ext>
+    </p:extLst>
+  </p:cSld>
+  <p:clrMapOvr>
+    <a:masterClrMapping/>
+  </p:clrMapOvr>
+</p:notes>
+</file>
+
+<file path=ppt/notesSlides/notesSlide5.xml><?xml version="1.0" encoding="utf-8"?>
+<p:notes xmlns:a="http://schemas.openxmlformats.org/drawingml/2006/main" xmlns:r="http://schemas.openxmlformats.org/officeDocument/2006/relationships" xmlns:p="http://schemas.openxmlformats.org/presentationml/2006/main">
+  <p:cSld>
+    <p:spTree>
+      <p:nvGrpSpPr>
+        <p:cNvPr id="1" name=""/>
+        <p:cNvGrpSpPr/>
+        <p:nvPr/>
+      </p:nvGrpSpPr>
+      <p:grpSpPr>
+        <a:xfrm>
+          <a:off x="0" y="0"/>
+          <a:ext cx="0" cy="0"/>
+          <a:chOff x="0" y="0"/>
+          <a:chExt cx="0" cy="0"/>
+        </a:xfrm>
+      </p:grpSpPr>
+      <p:sp>
+        <p:nvSpPr>
+          <p:cNvPr id="2" name="Slide Image Placeholder 1"/>
+          <p:cNvSpPr>
+            <a:spLocks noGrp="1" noRot="1" noChangeAspect="1"/>
+          </p:cNvSpPr>
+          <p:nvPr>
+            <p:ph type="sldImg"/>
+          </p:nvPr>
+        </p:nvSpPr>
+        <p:spPr/>
+      </p:sp>
+      <p:sp>
+        <p:nvSpPr>
+          <p:cNvPr id="3" name="Notes Placeholder 2"/>
+          <p:cNvSpPr>
+            <a:spLocks noGrp="1"/>
+          </p:cNvSpPr>
+          <p:nvPr>
+            <p:ph type="body" idx="1"/>
+          </p:nvPr>
+        </p:nvSpPr>
+        <p:spPr/>
+        <p:txBody>
+          <a:bodyPr/>
+          <a:lstStyle/>
+          <a:p>
+            <a:r>
+              <a:rPr lang="en-US" dirty="0"/>
+              <a:t>Going to think of our model as a Llama</a:t>
+            </a:r>
+          </a:p>
+          <a:p>
+            <a:endParaRPr lang="en-US" dirty="0"/>
+          </a:p>
+          <a:p>
+            <a:r>
+              <a:rPr lang="en-US" dirty="0"/>
+              <a:t>Has a specific meaning in the history of AI</a:t>
+            </a:r>
+          </a:p>
+          <a:p>
+            <a:endParaRPr lang="en-US" dirty="0"/>
+          </a:p>
+          <a:p>
+            <a:r>
+              <a:rPr lang="en-US" dirty="0"/>
+              <a:t>Llama is an acronym: Large Language Model Meta AI</a:t>
+            </a:r>
+          </a:p>
+          <a:p>
+            <a:endParaRPr lang="en-US" dirty="0"/>
+          </a:p>
+          <a:p>
+            <a:r>
+              <a:rPr lang="en-US" dirty="0"/>
+              <a:t>Released for research-only purposes by Meta in February 2023 following success of GPT-3.5 (ChatGPT moment, i.e. finetuned version of GPT-3) to prove you didn't need closed APIs and huge inference budgets</a:t>
+            </a:r>
+          </a:p>
+          <a:p>
+            <a:endParaRPr lang="en-US" dirty="0"/>
+          </a:p>
+          <a:p>
+            <a:r>
+              <a:rPr lang="en-US" dirty="0"/>
+              <a:t>Uses the same underlying architecture - it is an autoregressive decoder-only transformer. We will come back these words</a:t>
+            </a:r>
+          </a:p>
+          <a:p>
+            <a:endParaRPr lang="en-US" dirty="0"/>
+          </a:p>
+          <a:p>
+            <a:r>
+              <a:rPr lang="en-US" dirty="0"/>
+              <a:t>Shortly leaked and spawned the community of open weights models. </a:t>
+            </a:r>
+          </a:p>
+          <a:p>
+            <a:endParaRPr lang="en-US" dirty="0"/>
+          </a:p>
+          <a:p>
+            <a:r>
+              <a:rPr lang="en-US" dirty="0"/>
+              <a:t>As researchers, we tend to prefer open source models for various reasons so we will be using this as the source of our discussion on model architecture. Most differences between frontier models and Llama are too subtle or complex to discuss for the scope of this workshop</a:t>
+            </a:r>
+          </a:p>
+          <a:p>
+            <a:endParaRPr lang="en-US" dirty="0"/>
+          </a:p>
+          <a:p>
+            <a:r>
+              <a:rPr lang="en-US" dirty="0"/>
+              <a:t>The basic pieces, which will ultimately inform the narrative today are [go through]</a:t>
+            </a:r>
+          </a:p>
+          <a:p>
+            <a:endParaRPr lang="en-US" dirty="0"/>
+          </a:p>
+          <a:p>
+            <a:endParaRPr lang="en-US" dirty="0"/>
+          </a:p>
+        </p:txBody>
+      </p:sp>
+      <p:sp>
+        <p:nvSpPr>
+          <p:cNvPr id="4" name="Slide Number Placeholder 3"/>
+          <p:cNvSpPr>
+            <a:spLocks noGrp="1"/>
+          </p:cNvSpPr>
+          <p:nvPr>
+            <p:ph type="sldNum" sz="quarter" idx="5"/>
+          </p:nvPr>
+        </p:nvSpPr>
+        <p:spPr/>
+        <p:txBody>
+          <a:bodyPr/>
+          <a:lstStyle/>
+          <a:p>
+            <a:fld id="{C2D7E69D-609B-4983-96D1-38CC478AEB14}" type="slidenum">
+              <a:rPr lang="en-GB" smtClean="0"/>
+              <a:t>6</a:t>
+            </a:fld>
+            <a:endParaRPr lang="en-GB"/>
+          </a:p>
+        </p:txBody>
+      </p:sp>
+    </p:spTree>
+    <p:extLst>
+      <p:ext uri="{BB962C8B-B14F-4D97-AF65-F5344CB8AC3E}">
+        <p14:creationId xmlns:p14="http://schemas.microsoft.com/office/powerpoint/2010/main" val="243210352"/>
+      </p:ext>
+    </p:extLst>
+  </p:cSld>
+  <p:clrMapOvr>
+    <a:masterClrMapping/>
+  </p:clrMapOvr>
+</p:notes>
+</file>
+
+<file path=ppt/notesSlides/notesSlide6.xml><?xml version="1.0" encoding="utf-8"?>
+<p:notes xmlns:a="http://schemas.openxmlformats.org/drawingml/2006/main" xmlns:r="http://schemas.openxmlformats.org/officeDocument/2006/relationships" xmlns:p="http://schemas.openxmlformats.org/presentationml/2006/main">
+  <p:cSld>
+    <p:spTree>
+      <p:nvGrpSpPr>
+        <p:cNvPr id="1" name=""/>
+        <p:cNvGrpSpPr/>
+        <p:nvPr/>
+      </p:nvGrpSpPr>
+      <p:grpSpPr>
+        <a:xfrm>
+          <a:off x="0" y="0"/>
+          <a:ext cx="0" cy="0"/>
+          <a:chOff x="0" y="0"/>
+          <a:chExt cx="0" cy="0"/>
+        </a:xfrm>
+      </p:grpSpPr>
+      <p:sp>
+        <p:nvSpPr>
+          <p:cNvPr id="2" name="Slide Image Placeholder 1"/>
+          <p:cNvSpPr>
+            <a:spLocks noGrp="1" noRot="1" noChangeAspect="1"/>
+          </p:cNvSpPr>
+          <p:nvPr>
+            <p:ph type="sldImg"/>
+          </p:nvPr>
+        </p:nvSpPr>
+        <p:spPr/>
+      </p:sp>
+      <p:sp>
+        <p:nvSpPr>
+          <p:cNvPr id="3" name="Notes Placeholder 2"/>
+          <p:cNvSpPr>
+            <a:spLocks noGrp="1"/>
+          </p:cNvSpPr>
+          <p:nvPr>
+            <p:ph type="body" idx="1"/>
+          </p:nvPr>
+        </p:nvSpPr>
+        <p:spPr/>
+        <p:txBody>
+          <a:bodyPr/>
+          <a:lstStyle/>
+          <a:p>
+            <a:r>
+              <a:rPr lang="en-US" dirty="0"/>
+              <a:t>LLMs are stateless, so conversation history stuffed in a context window helps create illusion of state and gives models working memory.</a:t>
+            </a:r>
+          </a:p>
+          <a:p>
+            <a:endParaRPr lang="en-US" dirty="0"/>
+          </a:p>
+          <a:p>
+            <a:r>
+              <a:rPr lang="en-US" dirty="0"/>
+              <a:t>RAG; giving LLMs access to information that isn't baked inside its weights. Retrieve relevant information at inference time and stuff it into context window.</a:t>
+            </a:r>
+          </a:p>
+          <a:p>
+            <a:endParaRPr lang="en-US" dirty="0"/>
+          </a:p>
+          <a:p>
+            <a:r>
+              <a:rPr lang="en-US" dirty="0"/>
+              <a:t>Prompting; so-called prompt engineering, a quite atheoretical practice. It works but evidence is mostly restricted to empirical evidence, a recurring theme we will deal with.</a:t>
+            </a:r>
+          </a:p>
+          <a:p>
+            <a:endParaRPr lang="en-US" dirty="0"/>
+          </a:p>
+          <a:p>
+            <a:r>
+              <a:rPr lang="en-US" dirty="0"/>
+              <a:t>Tool-calling; especially relevant in the so-called agentic era</a:t>
+            </a:r>
+          </a:p>
+          <a:p>
+            <a:endParaRPr lang="en-US" dirty="0"/>
+          </a:p>
+          <a:p>
+            <a:r>
+              <a:rPr lang="en-US" dirty="0"/>
+              <a:t>Fine-tuning; or equivalently any post-training methodology, further improving model performance on down-stream tasks by 'fine-tuning' weights </a:t>
+            </a:r>
+          </a:p>
+        </p:txBody>
+      </p:sp>
+      <p:sp>
+        <p:nvSpPr>
+          <p:cNvPr id="4" name="Slide Number Placeholder 3"/>
+          <p:cNvSpPr>
+            <a:spLocks noGrp="1"/>
+          </p:cNvSpPr>
+          <p:nvPr>
+            <p:ph type="sldNum" sz="quarter" idx="5"/>
+          </p:nvPr>
+        </p:nvSpPr>
+        <p:spPr/>
+        <p:txBody>
+          <a:bodyPr/>
+          <a:lstStyle/>
+          <a:p>
+            <a:fld id="{C2D7E69D-609B-4983-96D1-38CC478AEB14}" type="slidenum">
+              <a:rPr lang="en-GB" smtClean="0"/>
+              <a:t>7</a:t>
+            </a:fld>
+            <a:endParaRPr lang="en-GB"/>
+          </a:p>
+        </p:txBody>
+      </p:sp>
+    </p:spTree>
+    <p:extLst>
+      <p:ext uri="{BB962C8B-B14F-4D97-AF65-F5344CB8AC3E}">
+        <p14:creationId xmlns:p14="http://schemas.microsoft.com/office/powerpoint/2010/main" val="2452359087"/>
+      </p:ext>
+    </p:extLst>
+  </p:cSld>
+  <p:clrMapOvr>
+    <a:masterClrMapping/>
+  </p:clrMapOvr>
+</p:notes>
+</file>
+
+<file path=ppt/notesSlides/notesSlide7.xml><?xml version="1.0" encoding="utf-8"?>
+<p:notes xmlns:a="http://schemas.openxmlformats.org/drawingml/2006/main" xmlns:r="http://schemas.openxmlformats.org/officeDocument/2006/relationships" xmlns:p="http://schemas.openxmlformats.org/presentationml/2006/main">
+  <p:cSld>
+    <p:spTree>
+      <p:nvGrpSpPr>
+        <p:cNvPr id="1" name=""/>
+        <p:cNvGrpSpPr/>
+        <p:nvPr/>
+      </p:nvGrpSpPr>
+      <p:grpSpPr>
+        <a:xfrm>
+          <a:off x="0" y="0"/>
+          <a:ext cx="0" cy="0"/>
+          <a:chOff x="0" y="0"/>
+          <a:chExt cx="0" cy="0"/>
+        </a:xfrm>
+      </p:grpSpPr>
+      <p:sp>
+        <p:nvSpPr>
+          <p:cNvPr id="2" name="Slide Image Placeholder 1"/>
+          <p:cNvSpPr>
+            <a:spLocks noGrp="1" noRot="1" noChangeAspect="1"/>
+          </p:cNvSpPr>
+          <p:nvPr>
+            <p:ph type="sldImg"/>
+          </p:nvPr>
+        </p:nvSpPr>
+        <p:spPr/>
+      </p:sp>
+      <p:sp>
+        <p:nvSpPr>
+          <p:cNvPr id="3" name="Notes Placeholder 2"/>
+          <p:cNvSpPr>
+            <a:spLocks noGrp="1"/>
+          </p:cNvSpPr>
+          <p:nvPr>
+            <p:ph type="body" idx="1"/>
+          </p:nvPr>
+        </p:nvSpPr>
+        <p:spPr/>
+        <p:txBody>
+          <a:bodyPr/>
+          <a:lstStyle/>
+          <a:p>
+            <a:r>
+              <a:rPr lang="en-US" dirty="0"/>
+              <a:t>Let's look at actually defining AI</a:t>
+            </a:r>
+          </a:p>
+        </p:txBody>
+      </p:sp>
+      <p:sp>
+        <p:nvSpPr>
+          <p:cNvPr id="4" name="Slide Number Placeholder 3"/>
+          <p:cNvSpPr>
+            <a:spLocks noGrp="1"/>
+          </p:cNvSpPr>
+          <p:nvPr>
+            <p:ph type="sldNum" sz="quarter" idx="5"/>
+          </p:nvPr>
+        </p:nvSpPr>
+        <p:spPr/>
+        <p:txBody>
+          <a:bodyPr/>
+          <a:lstStyle/>
+          <a:p>
+            <a:fld id="{C2D7E69D-609B-4983-96D1-38CC478AEB14}" type="slidenum">
+              <a:rPr lang="en-GB" smtClean="0"/>
+              <a:t>9</a:t>
+            </a:fld>
+            <a:endParaRPr lang="en-GB"/>
+          </a:p>
+        </p:txBody>
+      </p:sp>
+    </p:spTree>
+    <p:extLst>
+      <p:ext uri="{BB962C8B-B14F-4D97-AF65-F5344CB8AC3E}">
+        <p14:creationId xmlns:p14="http://schemas.microsoft.com/office/powerpoint/2010/main" val="2569798653"/>
+      </p:ext>
+    </p:extLst>
+  </p:cSld>
+  <p:clrMapOvr>
+    <a:masterClrMapping/>
+  </p:clrMapOvr>
+</p:notes>
+</file>
+
+<file path=ppt/notesSlides/notesSlide8.xml><?xml version="1.0" encoding="utf-8"?>
+<p:notes xmlns:a="http://schemas.openxmlformats.org/drawingml/2006/main" xmlns:r="http://schemas.openxmlformats.org/officeDocument/2006/relationships" xmlns:p="http://schemas.openxmlformats.org/presentationml/2006/main">
+  <p:cSld>
+    <p:spTree>
+      <p:nvGrpSpPr>
+        <p:cNvPr id="1" name=""/>
+        <p:cNvGrpSpPr/>
+        <p:nvPr/>
+      </p:nvGrpSpPr>
+      <p:grpSpPr>
+        <a:xfrm>
+          <a:off x="0" y="0"/>
+          <a:ext cx="0" cy="0"/>
+          <a:chOff x="0" y="0"/>
+          <a:chExt cx="0" cy="0"/>
+        </a:xfrm>
+      </p:grpSpPr>
+      <p:sp>
+        <p:nvSpPr>
+          <p:cNvPr id="2" name="Slide Image Placeholder 1"/>
+          <p:cNvSpPr>
+            <a:spLocks noGrp="1" noRot="1" noChangeAspect="1"/>
+          </p:cNvSpPr>
+          <p:nvPr>
+            <p:ph type="sldImg"/>
+          </p:nvPr>
+        </p:nvSpPr>
+        <p:spPr/>
+      </p:sp>
+      <p:sp>
+        <p:nvSpPr>
+          <p:cNvPr id="3" name="Notes Placeholder 2"/>
+          <p:cNvSpPr>
+            <a:spLocks noGrp="1"/>
+          </p:cNvSpPr>
+          <p:nvPr>
+            <p:ph type="body" idx="1"/>
+          </p:nvPr>
+        </p:nvSpPr>
+        <p:spPr/>
+        <p:txBody>
+          <a:bodyPr/>
+          <a:lstStyle/>
+          <a:p>
+            <a:r>
+              <a:rPr lang="en-US" dirty="0"/>
+              <a:t>Self supervision is where the training data labels itself. I.e. for next token prediction, don't need human labelling as with conventional supervised learning. The structure of the text already encodes the ground truth.</a:t>
+            </a:r>
+          </a:p>
+        </p:txBody>
+      </p:sp>
+      <p:sp>
+        <p:nvSpPr>
+          <p:cNvPr id="4" name="Slide Number Placeholder 3"/>
+          <p:cNvSpPr>
+            <a:spLocks noGrp="1"/>
+          </p:cNvSpPr>
+          <p:nvPr>
+            <p:ph type="sldNum" sz="quarter" idx="5"/>
+          </p:nvPr>
+        </p:nvSpPr>
+        <p:spPr/>
+        <p:txBody>
+          <a:bodyPr/>
+          <a:lstStyle/>
+          <a:p>
+            <a:fld id="{C2D7E69D-609B-4983-96D1-38CC478AEB14}" type="slidenum">
+              <a:rPr lang="en-GB" smtClean="0"/>
+              <a:t>13</a:t>
+            </a:fld>
+            <a:endParaRPr lang="en-GB"/>
+          </a:p>
+        </p:txBody>
+      </p:sp>
+    </p:spTree>
+    <p:extLst>
+      <p:ext uri="{BB962C8B-B14F-4D97-AF65-F5344CB8AC3E}">
+        <p14:creationId xmlns:p14="http://schemas.microsoft.com/office/powerpoint/2010/main" val="1911962667"/>
+      </p:ext>
+    </p:extLst>
+  </p:cSld>
+  <p:clrMapOvr>
+    <a:masterClrMapping/>
+  </p:clrMapOvr>
+</p:notes>
+</file>
+
+<file path=ppt/notesSlides/notesSlide9.xml><?xml version="1.0" encoding="utf-8"?>
+<p:notes xmlns:a="http://schemas.openxmlformats.org/drawingml/2006/main" xmlns:r="http://schemas.openxmlformats.org/officeDocument/2006/relationships" xmlns:p="http://schemas.openxmlformats.org/presentationml/2006/main">
+  <p:cSld>
+    <p:spTree>
+      <p:nvGrpSpPr>
+        <p:cNvPr id="1" name=""/>
+        <p:cNvGrpSpPr/>
+        <p:nvPr/>
+      </p:nvGrpSpPr>
+      <p:grpSpPr>
+        <a:xfrm>
+          <a:off x="0" y="0"/>
+          <a:ext cx="0" cy="0"/>
+          <a:chOff x="0" y="0"/>
+          <a:chExt cx="0" cy="0"/>
+        </a:xfrm>
+      </p:grpSpPr>
+      <p:sp>
+        <p:nvSpPr>
+          <p:cNvPr id="2" name="Slide Image Placeholder 1"/>
+          <p:cNvSpPr>
+            <a:spLocks noGrp="1" noRot="1" noChangeAspect="1"/>
+          </p:cNvSpPr>
+          <p:nvPr>
+            <p:ph type="sldImg"/>
+          </p:nvPr>
+        </p:nvSpPr>
+        <p:spPr/>
+      </p:sp>
+      <p:sp>
+        <p:nvSpPr>
+          <p:cNvPr id="3" name="Notes Placeholder 2"/>
+          <p:cNvSpPr>
+            <a:spLocks noGrp="1"/>
+          </p:cNvSpPr>
+          <p:nvPr>
+            <p:ph type="body" idx="1"/>
+          </p:nvPr>
+        </p:nvSpPr>
+        <p:spPr/>
+        <p:txBody>
+          <a:bodyPr/>
+          <a:lstStyle/>
+          <a:p>
+            <a:r>
+              <a:rPr lang="en-GB" dirty="0"/>
+              <a:t>The Act needs a practical, auditable way to classify and assess general purpose AI models without being able to directly test every possible capability. These indicators are its solution to that problem. </a:t>
+            </a:r>
+            <a:endParaRPr lang="en-US" dirty="0"/>
+          </a:p>
+        </p:txBody>
+      </p:sp>
+      <p:sp>
+        <p:nvSpPr>
+          <p:cNvPr id="4" name="Slide Number Placeholder 3"/>
+          <p:cNvSpPr>
+            <a:spLocks noGrp="1"/>
+          </p:cNvSpPr>
+          <p:nvPr>
+            <p:ph type="sldNum" sz="quarter" idx="5"/>
+          </p:nvPr>
+        </p:nvSpPr>
+        <p:spPr/>
+        <p:txBody>
+          <a:bodyPr/>
+          <a:lstStyle/>
+          <a:p>
+            <a:fld id="{C2D7E69D-609B-4983-96D1-38CC478AEB14}" type="slidenum">
+              <a:rPr lang="en-GB" smtClean="0"/>
+              <a:t>14</a:t>
+            </a:fld>
+            <a:endParaRPr lang="en-GB"/>
+          </a:p>
+        </p:txBody>
+      </p:sp>
+    </p:spTree>
+    <p:extLst>
+      <p:ext uri="{BB962C8B-B14F-4D97-AF65-F5344CB8AC3E}">
+        <p14:creationId xmlns:p14="http://schemas.microsoft.com/office/powerpoint/2010/main" val="975238628"/>
       </p:ext>
     </p:extLst>
   </p:cSld>
@@ -3587,194 +4586,6 @@
   <p:cSld>
     <p:spTree>
       <p:nvGrpSpPr>
-        <p:cNvPr id="1" name=""/>
-        <p:cNvGrpSpPr/>
-        <p:nvPr/>
-      </p:nvGrpSpPr>
-      <p:grpSpPr>
-        <a:xfrm>
-          <a:off x="0" y="0"/>
-          <a:ext cx="0" cy="0"/>
-          <a:chOff x="0" y="0"/>
-          <a:chExt cx="0" cy="0"/>
-        </a:xfrm>
-      </p:grpSpPr>
-      <p:sp>
-        <p:nvSpPr>
-          <p:cNvPr id="2" name="Title 1">
-            <a:extLst>
-              <a:ext uri="{FF2B5EF4-FFF2-40B4-BE49-F238E27FC236}">
-                <a16:creationId xmlns:a16="http://schemas.microsoft.com/office/drawing/2014/main" id="{7C33511F-8565-6D41-02BF-6E9296DCF3B4}"/>
-              </a:ext>
-            </a:extLst>
-          </p:cNvPr>
-          <p:cNvSpPr>
-            <a:spLocks noGrp="1"/>
-          </p:cNvSpPr>
-          <p:nvPr>
-            <p:ph type="title"/>
-          </p:nvPr>
-        </p:nvSpPr>
-        <p:spPr/>
-        <p:txBody>
-          <a:bodyPr/>
-          <a:lstStyle/>
-          <a:p>
-            <a:r>
-              <a:rPr lang="en-US" dirty="0"/>
-              <a:t>EU AI Act</a:t>
-            </a:r>
-          </a:p>
-        </p:txBody>
-      </p:sp>
-      <p:sp>
-        <p:nvSpPr>
-          <p:cNvPr id="3" name="Content Placeholder 2">
-            <a:extLst>
-              <a:ext uri="{FF2B5EF4-FFF2-40B4-BE49-F238E27FC236}">
-                <a16:creationId xmlns:a16="http://schemas.microsoft.com/office/drawing/2014/main" id="{C10ABB8D-3273-0866-F725-70CD2E52915C}"/>
-              </a:ext>
-            </a:extLst>
-          </p:cNvPr>
-          <p:cNvSpPr>
-            <a:spLocks noGrp="1"/>
-          </p:cNvSpPr>
-          <p:nvPr>
-            <p:ph idx="1"/>
-          </p:nvPr>
-        </p:nvSpPr>
-        <p:spPr/>
-        <p:txBody>
-          <a:bodyPr vert="horz" lIns="91440" tIns="45720" rIns="91440" bIns="45720" rtlCol="0" anchor="t">
-            <a:normAutofit/>
-          </a:bodyPr>
-          <a:lstStyle/>
-          <a:p>
-            <a:pPr marL="0" indent="0">
-              <a:buNone/>
-            </a:pPr>
-            <a:r>
-              <a:rPr lang="en-US" dirty="0"/>
-              <a:t>How does the AI Act define things...?</a:t>
-            </a:r>
-          </a:p>
-          <a:p>
-            <a:pPr marL="0" indent="0">
-              <a:buNone/>
-            </a:pPr>
-            <a:endParaRPr lang="en-US" dirty="0"/>
-          </a:p>
-          <a:p>
-            <a:pPr marL="0" indent="0">
-              <a:buNone/>
-            </a:pPr>
-            <a:endParaRPr lang="en-US" dirty="0">
-              <a:ea typeface="+mn-lt"/>
-              <a:cs typeface="+mn-lt"/>
-            </a:endParaRPr>
-          </a:p>
-        </p:txBody>
-      </p:sp>
-    </p:spTree>
-    <p:extLst>
-      <p:ext uri="{BB962C8B-B14F-4D97-AF65-F5344CB8AC3E}">
-        <p14:creationId xmlns:p14="http://schemas.microsoft.com/office/powerpoint/2010/main" val="1865729139"/>
-      </p:ext>
-    </p:extLst>
-  </p:cSld>
-  <p:clrMapOvr>
-    <a:masterClrMapping/>
-  </p:clrMapOvr>
-  <p:timing>
-    <p:tnLst>
-      <p:par>
-        <p:cTn id="1" dur="indefinite" restart="never" nodeType="tmRoot">
-          <p:childTnLst>
-            <p:seq concurrent="1" nextAc="seek">
-              <p:cTn id="2" dur="indefinite" nodeType="mainSeq">
-                <p:childTnLst>
-                  <p:par>
-                    <p:cTn id="3" fill="hold">
-                      <p:stCondLst>
-                        <p:cond delay="indefinite"/>
-                      </p:stCondLst>
-                      <p:childTnLst>
-                        <p:par>
-                          <p:cTn id="4" fill="hold">
-                            <p:stCondLst>
-                              <p:cond delay="0"/>
-                            </p:stCondLst>
-                            <p:childTnLst>
-                              <p:par>
-                                <p:cTn id="5" presetID="1" presetClass="entr" presetSubtype="0" fill="hold" grpId="0" nodeType="clickEffect">
-                                  <p:stCondLst>
-                                    <p:cond delay="0"/>
-                                  </p:stCondLst>
-                                  <p:childTnLst>
-                                    <p:set>
-                                      <p:cBhvr>
-                                        <p:cTn id="6" dur="1" fill="hold">
-                                          <p:stCondLst>
-                                            <p:cond delay="0"/>
-                                          </p:stCondLst>
-                                        </p:cTn>
-                                        <p:tgtEl>
-                                          <p:spTgt spid="3">
-                                            <p:txEl>
-                                              <p:pRg st="0" end="0"/>
-                                            </p:txEl>
-                                          </p:spTgt>
-                                        </p:tgtEl>
-                                        <p:attrNameLst>
-                                          <p:attrName>style.visibility</p:attrName>
-                                        </p:attrNameLst>
-                                      </p:cBhvr>
-                                      <p:to>
-                                        <p:strVal val="visible"/>
-                                      </p:to>
-                                    </p:set>
-                                  </p:childTnLst>
-                                </p:cTn>
-                              </p:par>
-                            </p:childTnLst>
-                          </p:cTn>
-                        </p:par>
-                      </p:childTnLst>
-                    </p:cTn>
-                  </p:par>
-                </p:childTnLst>
-              </p:cTn>
-              <p:prevCondLst>
-                <p:cond evt="onPrev" delay="0">
-                  <p:tgtEl>
-                    <p:sldTgt/>
-                  </p:tgtEl>
-                </p:cond>
-              </p:prevCondLst>
-              <p:nextCondLst>
-                <p:cond evt="onNext" delay="0">
-                  <p:tgtEl>
-                    <p:sldTgt/>
-                  </p:tgtEl>
-                </p:cond>
-              </p:nextCondLst>
-            </p:seq>
-          </p:childTnLst>
-        </p:cTn>
-      </p:par>
-    </p:tnLst>
-    <p:bldLst>
-      <p:bldP spid="3" grpId="0" build="p"/>
-    </p:bldLst>
-  </p:timing>
-</p:sld>
-</file>
-
-<file path=ppt/slides/slide11.xml><?xml version="1.0" encoding="utf-8"?>
-<p:sld xmlns:a="http://schemas.openxmlformats.org/drawingml/2006/main" xmlns:r="http://schemas.openxmlformats.org/officeDocument/2006/relationships" xmlns:p="http://schemas.openxmlformats.org/presentationml/2006/main">
-  <p:cSld>
-    <p:spTree>
-      <p:nvGrpSpPr>
         <p:cNvPr id="1" name="">
           <a:extLst>
             <a:ext uri="{FF2B5EF4-FFF2-40B4-BE49-F238E27FC236}">
@@ -3795,34 +4606,6 @@
       </p:grpSpPr>
       <p:sp>
         <p:nvSpPr>
-          <p:cNvPr id="2" name="Title 1">
-            <a:extLst>
-              <a:ext uri="{FF2B5EF4-FFF2-40B4-BE49-F238E27FC236}">
-                <a16:creationId xmlns:a16="http://schemas.microsoft.com/office/drawing/2014/main" id="{EFB3DCA2-5CF0-D9D9-D19D-5F184BF62F37}"/>
-              </a:ext>
-            </a:extLst>
-          </p:cNvPr>
-          <p:cNvSpPr>
-            <a:spLocks noGrp="1"/>
-          </p:cNvSpPr>
-          <p:nvPr>
-            <p:ph type="title"/>
-          </p:nvPr>
-        </p:nvSpPr>
-        <p:spPr/>
-        <p:txBody>
-          <a:bodyPr/>
-          <a:lstStyle/>
-          <a:p>
-            <a:r>
-              <a:rPr lang="en-US" dirty="0"/>
-              <a:t>EU AI Act</a:t>
-            </a:r>
-          </a:p>
-        </p:txBody>
-      </p:sp>
-      <p:sp>
-        <p:nvSpPr>
           <p:cNvPr id="3" name="Content Placeholder 2">
             <a:extLst>
               <a:ext uri="{FF2B5EF4-FFF2-40B4-BE49-F238E27FC236}">
@@ -3883,6 +4666,65 @@
           </a:p>
         </p:txBody>
       </p:sp>
+      <p:sp>
+        <p:nvSpPr>
+          <p:cNvPr id="5" name="Title 4">
+            <a:extLst>
+              <a:ext uri="{FF2B5EF4-FFF2-40B4-BE49-F238E27FC236}">
+                <a16:creationId xmlns:a16="http://schemas.microsoft.com/office/drawing/2014/main" id="{1700A706-5A9A-B94A-5E5E-F6185319F000}"/>
+              </a:ext>
+            </a:extLst>
+          </p:cNvPr>
+          <p:cNvSpPr>
+            <a:spLocks noGrp="1"/>
+          </p:cNvSpPr>
+          <p:nvPr>
+            <p:ph type="title"/>
+          </p:nvPr>
+        </p:nvSpPr>
+        <p:spPr/>
+        <p:txBody>
+          <a:bodyPr/>
+          <a:lstStyle/>
+          <a:p>
+            <a:r>
+              <a:rPr lang="en-US" dirty="0"/>
+              <a:t>EU AI Act </a:t>
+            </a:r>
+            <a:r>
+              <a:rPr lang="en-US" i="1" dirty="0">
+                <a:solidFill>
+                  <a:schemeClr val="bg2">
+                    <a:lumMod val="50000"/>
+                  </a:schemeClr>
+                </a:solidFill>
+              </a:rPr>
+              <a:t>(</a:t>
+            </a:r>
+            <a:r>
+              <a:rPr lang="en-GB" i="1" dirty="0">
+                <a:solidFill>
+                  <a:schemeClr val="bg2">
+                    <a:lumMod val="50000"/>
+                  </a:schemeClr>
+                </a:solidFill>
+              </a:rPr>
+              <a:t>August 2024</a:t>
+            </a:r>
+            <a:r>
+              <a:rPr lang="en-US" i="1" dirty="0">
+                <a:solidFill>
+                  <a:schemeClr val="bg2">
+                    <a:lumMod val="50000"/>
+                  </a:schemeClr>
+                </a:solidFill>
+              </a:rPr>
+              <a:t>)</a:t>
+            </a:r>
+            <a:endParaRPr lang="en-US" dirty="0"/>
+          </a:p>
+        </p:txBody>
+      </p:sp>
     </p:spTree>
     <p:extLst>
       <p:ext uri="{BB962C8B-B14F-4D97-AF65-F5344CB8AC3E}">
@@ -3896,7 +4738,7 @@
 </p:sld>
 </file>
 
-<file path=ppt/slides/slide12.xml><?xml version="1.0" encoding="utf-8"?>
+<file path=ppt/slides/slide11.xml><?xml version="1.0" encoding="utf-8"?>
 <p:sld xmlns:a="http://schemas.openxmlformats.org/drawingml/2006/main" xmlns:r="http://schemas.openxmlformats.org/officeDocument/2006/relationships" xmlns:p="http://schemas.openxmlformats.org/presentationml/2006/main">
   <p:cSld>
     <p:spTree>
@@ -3942,8 +4784,39 @@
           <a:p>
             <a:r>
               <a:rPr lang="en-US" dirty="0"/>
-              <a:t>EU AI Act</a:t>
-            </a:r>
+              <a:t>EU AI Act </a:t>
+            </a:r>
+            <a:r>
+              <a:rPr lang="en-US" i="1" dirty="0">
+                <a:solidFill>
+                  <a:schemeClr val="bg2">
+                    <a:lumMod val="50000"/>
+                  </a:schemeClr>
+                </a:solidFill>
+              </a:rPr>
+              <a:t>(</a:t>
+            </a:r>
+            <a:r>
+              <a:rPr lang="en-GB" i="1" dirty="0">
+                <a:solidFill>
+                  <a:schemeClr val="bg2">
+                    <a:lumMod val="50000"/>
+                  </a:schemeClr>
+                </a:solidFill>
+              </a:rPr>
+              <a:t>August 2024</a:t>
+            </a:r>
+            <a:r>
+              <a:rPr lang="en-US" i="1" dirty="0">
+                <a:solidFill>
+                  <a:schemeClr val="bg2">
+                    <a:lumMod val="50000"/>
+                  </a:schemeClr>
+                </a:solidFill>
+              </a:rPr>
+              <a:t>)</a:t>
+            </a:r>
+            <a:endParaRPr lang="en-US" dirty="0"/>
           </a:p>
         </p:txBody>
       </p:sp>
@@ -4022,7 +4895,7 @@
 </p:sld>
 </file>
 
-<file path=ppt/slides/slide13.xml><?xml version="1.0" encoding="utf-8"?>
+<file path=ppt/slides/slide12.xml><?xml version="1.0" encoding="utf-8"?>
 <p:sld xmlns:a="http://schemas.openxmlformats.org/drawingml/2006/main" xmlns:r="http://schemas.openxmlformats.org/officeDocument/2006/relationships" xmlns:p="http://schemas.openxmlformats.org/presentationml/2006/main">
   <p:cSld>
     <p:spTree>
@@ -4068,8 +4941,39 @@
           <a:p>
             <a:r>
               <a:rPr lang="en-US" dirty="0"/>
-              <a:t>EU AI Act</a:t>
-            </a:r>
+              <a:t>EU AI Act </a:t>
+            </a:r>
+            <a:r>
+              <a:rPr lang="en-US" i="1" dirty="0">
+                <a:solidFill>
+                  <a:schemeClr val="bg2">
+                    <a:lumMod val="50000"/>
+                  </a:schemeClr>
+                </a:solidFill>
+              </a:rPr>
+              <a:t>(</a:t>
+            </a:r>
+            <a:r>
+              <a:rPr lang="en-GB" i="1" dirty="0">
+                <a:solidFill>
+                  <a:schemeClr val="bg2">
+                    <a:lumMod val="50000"/>
+                  </a:schemeClr>
+                </a:solidFill>
+              </a:rPr>
+              <a:t>August 2024</a:t>
+            </a:r>
+            <a:r>
+              <a:rPr lang="en-US" i="1" dirty="0">
+                <a:solidFill>
+                  <a:schemeClr val="bg2">
+                    <a:lumMod val="50000"/>
+                  </a:schemeClr>
+                </a:solidFill>
+              </a:rPr>
+              <a:t>)</a:t>
+            </a:r>
+            <a:endParaRPr lang="en-US" dirty="0"/>
           </a:p>
         </p:txBody>
       </p:sp>
@@ -4148,7 +5052,7 @@
 </p:sld>
 </file>
 
-<file path=ppt/slides/slide14.xml><?xml version="1.0" encoding="utf-8"?>
+<file path=ppt/slides/slide13.xml><?xml version="1.0" encoding="utf-8"?>
 <p:sld xmlns:a="http://schemas.openxmlformats.org/drawingml/2006/main" xmlns:r="http://schemas.openxmlformats.org/officeDocument/2006/relationships" xmlns:p="http://schemas.openxmlformats.org/presentationml/2006/main">
   <p:cSld>
     <p:spTree>
@@ -4194,8 +5098,39 @@
           <a:p>
             <a:r>
               <a:rPr lang="en-US" dirty="0"/>
-              <a:t>EU AI Act</a:t>
-            </a:r>
+              <a:t>EU AI Act </a:t>
+            </a:r>
+            <a:r>
+              <a:rPr lang="en-US" i="1" dirty="0">
+                <a:solidFill>
+                  <a:schemeClr val="bg2">
+                    <a:lumMod val="50000"/>
+                  </a:schemeClr>
+                </a:solidFill>
+              </a:rPr>
+              <a:t>(</a:t>
+            </a:r>
+            <a:r>
+              <a:rPr lang="en-GB" i="1" dirty="0">
+                <a:solidFill>
+                  <a:schemeClr val="bg2">
+                    <a:lumMod val="50000"/>
+                  </a:schemeClr>
+                </a:solidFill>
+              </a:rPr>
+              <a:t>August 2024</a:t>
+            </a:r>
+            <a:r>
+              <a:rPr lang="en-US" i="1" dirty="0">
+                <a:solidFill>
+                  <a:schemeClr val="bg2">
+                    <a:lumMod val="50000"/>
+                  </a:schemeClr>
+                </a:solidFill>
+              </a:rPr>
+              <a:t>)</a:t>
+            </a:r>
+            <a:endParaRPr lang="en-US" dirty="0"/>
           </a:p>
         </p:txBody>
       </p:sp>
@@ -4376,7 +5311,7 @@
 </p:sld>
 </file>
 
-<file path=ppt/slides/slide15.xml><?xml version="1.0" encoding="utf-8"?>
+<file path=ppt/slides/slide14.xml><?xml version="1.0" encoding="utf-8"?>
 <p:sld xmlns:a="http://schemas.openxmlformats.org/drawingml/2006/main" xmlns:r="http://schemas.openxmlformats.org/officeDocument/2006/relationships" xmlns:p="http://schemas.openxmlformats.org/presentationml/2006/main">
   <p:cSld>
     <p:spTree>
@@ -4450,9 +5385,6 @@
           </a:bodyPr>
           <a:lstStyle/>
           <a:p>
-            <a:pPr marL="514350" indent="-514350">
-              <a:buAutoNum type="alphaLcPeriod"/>
-            </a:pPr>
             <a:r>
               <a:rPr lang="en-US" dirty="0">
                 <a:ea typeface="+mn-lt"/>
@@ -4463,9 +5395,6 @@
             <a:endParaRPr lang="en-US" dirty="0"/>
           </a:p>
           <a:p>
-            <a:pPr marL="514350" indent="-514350">
-              <a:buAutoNum type="alphaLcPeriod"/>
-            </a:pPr>
             <a:r>
               <a:rPr lang="en-US" dirty="0">
                 <a:ea typeface="+mn-lt"/>
@@ -4475,9 +5404,6 @@
             </a:r>
           </a:p>
           <a:p>
-            <a:pPr marL="514350" indent="-514350">
-              <a:buAutoNum type="alphaLcPeriod"/>
-            </a:pPr>
             <a:r>
               <a:rPr lang="en-US" dirty="0">
                 <a:ea typeface="+mn-lt"/>
@@ -4866,7 +5792,7 @@
 </p:sld>
 </file>
 
-<file path=ppt/slides/slide16.xml><?xml version="1.0" encoding="utf-8"?>
+<file path=ppt/slides/slide15.xml><?xml version="1.0" encoding="utf-8"?>
 <p:sld xmlns:a="http://schemas.openxmlformats.org/drawingml/2006/main" xmlns:r="http://schemas.openxmlformats.org/officeDocument/2006/relationships" xmlns:p="http://schemas.openxmlformats.org/presentationml/2006/main">
   <p:cSld>
     <p:spTree>
@@ -4940,9 +5866,6 @@
           </a:bodyPr>
           <a:lstStyle/>
           <a:p>
-            <a:pPr marL="514350" indent="-514350">
-              <a:buAutoNum type="alphaLcPeriod"/>
-            </a:pPr>
             <a:r>
               <a:rPr lang="en-US" dirty="0">
                 <a:ea typeface="+mn-lt"/>
@@ -4952,9 +5875,6 @@
             </a:r>
           </a:p>
           <a:p>
-            <a:pPr marL="514350" indent="-514350">
-              <a:buAutoNum type="alphaLcPeriod"/>
-            </a:pPr>
             <a:r>
               <a:rPr lang="en-US" dirty="0">
                 <a:ea typeface="+mn-lt"/>
@@ -4990,9 +5910,6 @@
             </a:r>
           </a:p>
           <a:p>
-            <a:pPr marL="514350" indent="-514350">
-              <a:buAutoNum type="alphaLcPeriod"/>
-            </a:pPr>
             <a:r>
               <a:rPr lang="en-US" dirty="0">
                 <a:ea typeface="+mn-lt"/>
@@ -5444,7 +6361,7 @@
 </p:sld>
 </file>
 
-<file path=ppt/slides/slide17.xml><?xml version="1.0" encoding="utf-8"?>
+<file path=ppt/slides/slide16.xml><?xml version="1.0" encoding="utf-8"?>
 <p:sld xmlns:a="http://schemas.openxmlformats.org/drawingml/2006/main" xmlns:r="http://schemas.openxmlformats.org/officeDocument/2006/relationships" xmlns:p="http://schemas.openxmlformats.org/presentationml/2006/main">
   <p:cSld>
     <p:spTree>
@@ -5672,7 +6589,7 @@
 </p:sld>
 </file>
 
-<file path=ppt/slides/slide18.xml><?xml version="1.0" encoding="utf-8"?>
+<file path=ppt/slides/slide17.xml><?xml version="1.0" encoding="utf-8"?>
 <p:sld xmlns:a="http://schemas.openxmlformats.org/drawingml/2006/main" xmlns:r="http://schemas.openxmlformats.org/officeDocument/2006/relationships" xmlns:p="http://schemas.openxmlformats.org/presentationml/2006/main">
   <p:cSld>
     <p:spTree>
@@ -5934,7 +6851,7 @@
 </p:sld>
 </file>
 
-<file path=ppt/slides/slide19.xml><?xml version="1.0" encoding="utf-8"?>
+<file path=ppt/slides/slide18.xml><?xml version="1.0" encoding="utf-8"?>
 <p:sld xmlns:a="http://schemas.openxmlformats.org/drawingml/2006/main" xmlns:r="http://schemas.openxmlformats.org/officeDocument/2006/relationships" xmlns:p="http://schemas.openxmlformats.org/presentationml/2006/main">
   <p:cSld>
     <p:spTree>
@@ -9047,6 +9964,36 @@
           </a:p>
         </p:txBody>
       </p:sp>
+      <p:pic>
+        <p:nvPicPr>
+          <p:cNvPr id="4" name="Picture 3">
+            <a:extLst>
+              <a:ext uri="{FF2B5EF4-FFF2-40B4-BE49-F238E27FC236}">
+                <a16:creationId xmlns:a16="http://schemas.microsoft.com/office/drawing/2014/main" id="{62F90085-2CFA-E241-70E3-58E8EC79428C}"/>
+              </a:ext>
+            </a:extLst>
+          </p:cNvPr>
+          <p:cNvPicPr>
+            <a:picLocks noChangeAspect="1"/>
+          </p:cNvPicPr>
+          <p:nvPr/>
+        </p:nvPicPr>
+        <p:blipFill>
+          <a:blip r:embed="rId3"/>
+          <a:stretch>
+            <a:fillRect/>
+          </a:stretch>
+        </p:blipFill>
+        <p:spPr>
+          <a:xfrm>
+            <a:off x="4798195" y="3429000"/>
+            <a:ext cx="2595609" cy="2609471"/>
+          </a:xfrm>
+          <a:prstGeom prst="rect">
+            <a:avLst/>
+          </a:prstGeom>
+        </p:spPr>
+      </p:pic>
     </p:spTree>
     <p:extLst>
       <p:ext uri="{BB962C8B-B14F-4D97-AF65-F5344CB8AC3E}">
@@ -9100,7 +10047,7 @@
           <a:p>
             <a:r>
               <a:rPr lang="en-US" dirty="0"/>
-              <a:t>Our goals</a:t>
+              <a:t>Workshop Goals</a:t>
             </a:r>
           </a:p>
         </p:txBody>
@@ -9154,14 +10101,7 @@
                 <a:ea typeface="+mn-lt"/>
                 <a:cs typeface="+mn-lt"/>
               </a:rPr>
-              <a:t>Better understand the challenges that researchers </a:t>
-            </a:r>
-            <a:r>
-              <a:rPr lang="en-US">
-                <a:ea typeface="+mn-lt"/>
-                <a:cs typeface="+mn-lt"/>
-              </a:rPr>
-              <a:t>face.</a:t>
+              <a:t>Better understand the challenges that researchers face.</a:t>
             </a:r>
           </a:p>
           <a:p>
@@ -9197,14 +10137,7 @@
                 <a:ea typeface="+mn-lt"/>
                 <a:cs typeface="+mn-lt"/>
               </a:rPr>
-              <a:t>Including </a:t>
-            </a:r>
-            <a:r>
-              <a:rPr lang="en-US">
-                <a:ea typeface="+mn-lt"/>
-                <a:cs typeface="+mn-lt"/>
-              </a:rPr>
-              <a:t>shared code</a:t>
+              <a:t>Including shared code</a:t>
             </a:r>
           </a:p>
           <a:p>
@@ -9215,7 +10148,7 @@
               </a:rPr>
               <a:t>Start to build a community of like-minded researchers across the university.</a:t>
             </a:r>
-            <a:endParaRPr lang="en-US"/>
+            <a:endParaRPr lang="en-US" dirty="0"/>
           </a:p>
         </p:txBody>
       </p:sp>
@@ -9636,6 +10569,239 @@
           </a:graphicData>
         </a:graphic>
       </p:graphicFrame>
+      <p:sp>
+        <p:nvSpPr>
+          <p:cNvPr id="6" name="Content Placeholder 2">
+            <a:extLst>
+              <a:ext uri="{FF2B5EF4-FFF2-40B4-BE49-F238E27FC236}">
+                <a16:creationId xmlns:a16="http://schemas.microsoft.com/office/drawing/2014/main" id="{13040332-75D0-405E-6D35-DCBEE6D0BE3E}"/>
+              </a:ext>
+            </a:extLst>
+          </p:cNvPr>
+          <p:cNvSpPr txBox="1">
+            <a:spLocks/>
+          </p:cNvSpPr>
+          <p:nvPr/>
+        </p:nvSpPr>
+        <p:spPr>
+          <a:xfrm>
+            <a:off x="838200" y="5196522"/>
+            <a:ext cx="10515600" cy="1661477"/>
+          </a:xfrm>
+          <a:prstGeom prst="rect">
+            <a:avLst/>
+          </a:prstGeom>
+        </p:spPr>
+        <p:txBody>
+          <a:bodyPr vert="horz" lIns="91440" tIns="45720" rIns="91440" bIns="45720" rtlCol="0" anchor="t">
+            <a:normAutofit/>
+          </a:bodyPr>
+          <a:lstStyle>
+            <a:lvl1pPr marL="228600" indent="-228600" algn="l" defTabSz="914400" rtl="0" eaLnBrk="1" latinLnBrk="0" hangingPunct="1">
+              <a:lnSpc>
+                <a:spcPct val="90000"/>
+              </a:lnSpc>
+              <a:spcBef>
+                <a:spcPts val="1000"/>
+              </a:spcBef>
+              <a:buFont typeface="Arial" panose="020B0604020202020204" pitchFamily="34" charset="0"/>
+              <a:buChar char="•"/>
+              <a:defRPr sz="2800" kern="1200">
+                <a:solidFill>
+                  <a:schemeClr val="tx1"/>
+                </a:solidFill>
+                <a:latin typeface="+mn-lt"/>
+                <a:ea typeface="+mn-ea"/>
+                <a:cs typeface="+mn-cs"/>
+              </a:defRPr>
+            </a:lvl1pPr>
+            <a:lvl2pPr marL="685800" indent="-228600" algn="l" defTabSz="914400" rtl="0" eaLnBrk="1" latinLnBrk="0" hangingPunct="1">
+              <a:lnSpc>
+                <a:spcPct val="90000"/>
+              </a:lnSpc>
+              <a:spcBef>
+                <a:spcPts val="500"/>
+              </a:spcBef>
+              <a:buFont typeface="Arial" panose="020B0604020202020204" pitchFamily="34" charset="0"/>
+              <a:buChar char="•"/>
+              <a:defRPr sz="2400" kern="1200">
+                <a:solidFill>
+                  <a:schemeClr val="tx1"/>
+                </a:solidFill>
+                <a:latin typeface="+mn-lt"/>
+                <a:ea typeface="+mn-ea"/>
+                <a:cs typeface="+mn-cs"/>
+              </a:defRPr>
+            </a:lvl2pPr>
+            <a:lvl3pPr marL="1143000" indent="-228600" algn="l" defTabSz="914400" rtl="0" eaLnBrk="1" latinLnBrk="0" hangingPunct="1">
+              <a:lnSpc>
+                <a:spcPct val="90000"/>
+              </a:lnSpc>
+              <a:spcBef>
+                <a:spcPts val="500"/>
+              </a:spcBef>
+              <a:buFont typeface="Arial" panose="020B0604020202020204" pitchFamily="34" charset="0"/>
+              <a:buChar char="•"/>
+              <a:defRPr sz="2000" kern="1200">
+                <a:solidFill>
+                  <a:schemeClr val="tx1"/>
+                </a:solidFill>
+                <a:latin typeface="+mn-lt"/>
+                <a:ea typeface="+mn-ea"/>
+                <a:cs typeface="+mn-cs"/>
+              </a:defRPr>
+            </a:lvl3pPr>
+            <a:lvl4pPr marL="1600200" indent="-228600" algn="l" defTabSz="914400" rtl="0" eaLnBrk="1" latinLnBrk="0" hangingPunct="1">
+              <a:lnSpc>
+                <a:spcPct val="90000"/>
+              </a:lnSpc>
+              <a:spcBef>
+                <a:spcPts val="500"/>
+              </a:spcBef>
+              <a:buFont typeface="Arial" panose="020B0604020202020204" pitchFamily="34" charset="0"/>
+              <a:buChar char="•"/>
+              <a:defRPr sz="1800" kern="1200">
+                <a:solidFill>
+                  <a:schemeClr val="tx1"/>
+                </a:solidFill>
+                <a:latin typeface="+mn-lt"/>
+                <a:ea typeface="+mn-ea"/>
+                <a:cs typeface="+mn-cs"/>
+              </a:defRPr>
+            </a:lvl4pPr>
+            <a:lvl5pPr marL="2057400" indent="-228600" algn="l" defTabSz="914400" rtl="0" eaLnBrk="1" latinLnBrk="0" hangingPunct="1">
+              <a:lnSpc>
+                <a:spcPct val="90000"/>
+              </a:lnSpc>
+              <a:spcBef>
+                <a:spcPts val="500"/>
+              </a:spcBef>
+              <a:buFont typeface="Arial" panose="020B0604020202020204" pitchFamily="34" charset="0"/>
+              <a:buChar char="•"/>
+              <a:defRPr sz="1800" kern="1200">
+                <a:solidFill>
+                  <a:schemeClr val="tx1"/>
+                </a:solidFill>
+                <a:latin typeface="+mn-lt"/>
+                <a:ea typeface="+mn-ea"/>
+                <a:cs typeface="+mn-cs"/>
+              </a:defRPr>
+            </a:lvl5pPr>
+            <a:lvl6pPr marL="2514600" indent="-228600" algn="l" defTabSz="914400" rtl="0" eaLnBrk="1" latinLnBrk="0" hangingPunct="1">
+              <a:lnSpc>
+                <a:spcPct val="90000"/>
+              </a:lnSpc>
+              <a:spcBef>
+                <a:spcPts val="500"/>
+              </a:spcBef>
+              <a:buFont typeface="Arial" panose="020B0604020202020204" pitchFamily="34" charset="0"/>
+              <a:buChar char="•"/>
+              <a:defRPr sz="1800" kern="1200">
+                <a:solidFill>
+                  <a:schemeClr val="tx1"/>
+                </a:solidFill>
+                <a:latin typeface="+mn-lt"/>
+                <a:ea typeface="+mn-ea"/>
+                <a:cs typeface="+mn-cs"/>
+              </a:defRPr>
+            </a:lvl6pPr>
+            <a:lvl7pPr marL="2971800" indent="-228600" algn="l" defTabSz="914400" rtl="0" eaLnBrk="1" latinLnBrk="0" hangingPunct="1">
+              <a:lnSpc>
+                <a:spcPct val="90000"/>
+              </a:lnSpc>
+              <a:spcBef>
+                <a:spcPts val="500"/>
+              </a:spcBef>
+              <a:buFont typeface="Arial" panose="020B0604020202020204" pitchFamily="34" charset="0"/>
+              <a:buChar char="•"/>
+              <a:defRPr sz="1800" kern="1200">
+                <a:solidFill>
+                  <a:schemeClr val="tx1"/>
+                </a:solidFill>
+                <a:latin typeface="+mn-lt"/>
+                <a:ea typeface="+mn-ea"/>
+                <a:cs typeface="+mn-cs"/>
+              </a:defRPr>
+            </a:lvl7pPr>
+            <a:lvl8pPr marL="3429000" indent="-228600" algn="l" defTabSz="914400" rtl="0" eaLnBrk="1" latinLnBrk="0" hangingPunct="1">
+              <a:lnSpc>
+                <a:spcPct val="90000"/>
+              </a:lnSpc>
+              <a:spcBef>
+                <a:spcPts val="500"/>
+              </a:spcBef>
+              <a:buFont typeface="Arial" panose="020B0604020202020204" pitchFamily="34" charset="0"/>
+              <a:buChar char="•"/>
+              <a:defRPr sz="1800" kern="1200">
+                <a:solidFill>
+                  <a:schemeClr val="tx1"/>
+                </a:solidFill>
+                <a:latin typeface="+mn-lt"/>
+                <a:ea typeface="+mn-ea"/>
+                <a:cs typeface="+mn-cs"/>
+              </a:defRPr>
+            </a:lvl8pPr>
+            <a:lvl9pPr marL="3886200" indent="-228600" algn="l" defTabSz="914400" rtl="0" eaLnBrk="1" latinLnBrk="0" hangingPunct="1">
+              <a:lnSpc>
+                <a:spcPct val="90000"/>
+              </a:lnSpc>
+              <a:spcBef>
+                <a:spcPts val="500"/>
+              </a:spcBef>
+              <a:buFont typeface="Arial" panose="020B0604020202020204" pitchFamily="34" charset="0"/>
+              <a:buChar char="•"/>
+              <a:defRPr sz="1800" kern="1200">
+                <a:solidFill>
+                  <a:schemeClr val="tx1"/>
+                </a:solidFill>
+                <a:latin typeface="+mn-lt"/>
+                <a:ea typeface="+mn-ea"/>
+                <a:cs typeface="+mn-cs"/>
+              </a:defRPr>
+            </a:lvl9pPr>
+          </a:lstStyle>
+          <a:p>
+            <a:pPr marL="0" indent="0">
+              <a:buNone/>
+            </a:pPr>
+            <a:r>
+              <a:rPr lang="en-US" dirty="0">
+                <a:solidFill>
+                  <a:schemeClr val="bg2">
+                    <a:lumMod val="50000"/>
+                  </a:schemeClr>
+                </a:solidFill>
+              </a:rPr>
+              <a:t>Slides available at:</a:t>
+            </a:r>
+          </a:p>
+          <a:p>
+            <a:pPr marL="0" indent="0">
+              <a:buNone/>
+            </a:pPr>
+            <a:r>
+              <a:rPr lang="en-US" b="1" dirty="0" err="1">
+                <a:solidFill>
+                  <a:schemeClr val="bg2">
+                    <a:lumMod val="50000"/>
+                  </a:schemeClr>
+                </a:solidFill>
+              </a:rPr>
+              <a:t>docs.science.ai.cam.ac.uk</a:t>
+            </a:r>
+            <a:r>
+              <a:rPr lang="en-US" b="1" dirty="0">
+                <a:solidFill>
+                  <a:schemeClr val="bg2">
+                    <a:lumMod val="50000"/>
+                  </a:schemeClr>
+                </a:solidFill>
+              </a:rPr>
+              <a:t>/large-language-models/</a:t>
+            </a:r>
+          </a:p>
+        </p:txBody>
+      </p:sp>
     </p:spTree>
     <p:extLst>
       <p:ext uri="{BB962C8B-B14F-4D97-AF65-F5344CB8AC3E}">
@@ -10164,7 +11330,7 @@
           <p:nvPr/>
         </p:nvPicPr>
         <p:blipFill>
-          <a:blip r:embed="rId2"/>
+          <a:blip r:embed="rId3"/>
           <a:stretch>
             <a:fillRect/>
           </a:stretch>
@@ -13026,11 +14192,11 @@
           <p:nvPr/>
         </p:nvPicPr>
         <p:blipFill>
-          <a:blip r:embed="rId2">
+          <a:blip r:embed="rId3">
             <a:extLst>
               <a:ext uri="{BEBA8EAE-BF5A-486C-A8C5-ECC9F3942E4B}">
                 <a14:imgProps xmlns:a14="http://schemas.microsoft.com/office/drawing/2010/main">
-                  <a14:imgLayer r:embed="rId3">
+                  <a14:imgLayer r:embed="rId4">
                     <a14:imgEffect>
                       <a14:backgroundRemoval t="10000" b="90000" l="10000" r="90000"/>
                     </a14:imgEffect>
@@ -13516,7 +14682,7 @@
           <p:cNvPr id="2" name="Title 1">
             <a:extLst>
               <a:ext uri="{FF2B5EF4-FFF2-40B4-BE49-F238E27FC236}">
-                <a16:creationId xmlns:a16="http://schemas.microsoft.com/office/drawing/2014/main" id="{2622F7F8-D800-192B-AA88-485BF564DAB3}"/>
+                <a16:creationId xmlns:a16="http://schemas.microsoft.com/office/drawing/2014/main" id="{96041BF3-F107-F9B0-5EDB-4373BB4196B4}"/>
               </a:ext>
             </a:extLst>
           </p:cNvPr>
@@ -13534,7 +14700,7 @@
           <a:p>
             <a:r>
               <a:rPr lang="en-US" dirty="0"/>
-              <a:t>A comparison with humans</a:t>
+              <a:t>Some definitions</a:t>
             </a:r>
           </a:p>
         </p:txBody>
@@ -13544,7 +14710,7 @@
           <p:cNvPr id="3" name="Content Placeholder 2">
             <a:extLst>
               <a:ext uri="{FF2B5EF4-FFF2-40B4-BE49-F238E27FC236}">
-                <a16:creationId xmlns:a16="http://schemas.microsoft.com/office/drawing/2014/main" id="{39D4A751-4A71-6574-70A1-136794DB1F1C}"/>
+                <a16:creationId xmlns:a16="http://schemas.microsoft.com/office/drawing/2014/main" id="{BACC3A7C-33D4-2896-0AC9-9DA08F6ED357}"/>
               </a:ext>
             </a:extLst>
           </p:cNvPr>
@@ -13555,10 +14721,15 @@
             <p:ph idx="1"/>
           </p:nvPr>
         </p:nvSpPr>
-        <p:spPr/>
+        <p:spPr>
+          <a:xfrm>
+            <a:off x="838200" y="1825624"/>
+            <a:ext cx="10900410" cy="5032375"/>
+          </a:xfrm>
+        </p:spPr>
         <p:txBody>
           <a:bodyPr vert="horz" lIns="91440" tIns="45720" rIns="91440" bIns="45720" rtlCol="0" anchor="t">
-            <a:normAutofit/>
+            <a:normAutofit fontScale="70000" lnSpcReduction="20000"/>
           </a:bodyPr>
           <a:lstStyle/>
           <a:p>
@@ -13566,184 +14737,322 @@
               <a:buNone/>
             </a:pPr>
             <a:r>
-              <a:rPr lang="en-US" dirty="0"/>
-              <a:t>Is it reasonable to say that a large language model cannot do some cognitive tasks?</a:t>
+              <a:rPr lang="en-US" b="1" dirty="0">
+                <a:solidFill>
+                  <a:srgbClr val="7030A0"/>
+                </a:solidFill>
+                <a:ea typeface="+mn-lt"/>
+                <a:cs typeface="+mn-lt"/>
+              </a:rPr>
+              <a:t>Model </a:t>
+            </a:r>
+            <a:r>
+              <a:rPr lang="en-US" dirty="0">
+                <a:ea typeface="+mn-lt"/>
+                <a:cs typeface="+mn-lt"/>
+              </a:rPr>
+              <a:t>The thing you train and use to generate text.</a:t>
             </a:r>
           </a:p>
           <a:p>
             <a:pPr marL="0" indent="0">
               <a:buNone/>
             </a:pPr>
-            <a:endParaRPr lang="en-US" dirty="0"/>
+            <a:r>
+              <a:rPr lang="en-US" b="1" dirty="0">
+                <a:solidFill>
+                  <a:srgbClr val="7030A0"/>
+                </a:solidFill>
+                <a:ea typeface="+mn-lt"/>
+                <a:cs typeface="+mn-lt"/>
+              </a:rPr>
+              <a:t>Architecture </a:t>
+            </a:r>
+            <a:r>
+              <a:rPr lang="en-US" dirty="0">
+                <a:ea typeface="+mn-lt"/>
+                <a:cs typeface="+mn-lt"/>
+              </a:rPr>
+              <a:t>The high-level structure of the model.</a:t>
+            </a:r>
           </a:p>
           <a:p>
             <a:pPr marL="0" indent="0">
               <a:buNone/>
             </a:pPr>
             <a:r>
-              <a:rPr lang="en-US" dirty="0"/>
-              <a:t>What do you mean when you say </a:t>
-            </a:r>
-            <a:r>
-              <a:rPr lang="en-US" b="1" i="1" dirty="0">
+              <a:rPr lang="en-US" b="1" dirty="0">
                 <a:solidFill>
                   <a:srgbClr val="7030A0"/>
                 </a:solidFill>
+                <a:ea typeface="+mn-lt"/>
+                <a:cs typeface="+mn-lt"/>
               </a:rPr>
-              <a:t>AI</a:t>
-            </a:r>
-            <a:r>
-              <a:rPr lang="en-US" i="1" dirty="0"/>
-              <a:t>...</a:t>
-            </a:r>
-            <a:r>
-              <a:rPr lang="en-US" dirty="0"/>
-              <a:t>?</a:t>
-            </a:r>
+              <a:t>Parameters </a:t>
+            </a:r>
+            <a:r>
+              <a:rPr lang="en-US" dirty="0">
+                <a:ea typeface="+mn-lt"/>
+                <a:cs typeface="+mn-lt"/>
+              </a:rPr>
+              <a:t>(or weights) The internal knobs and dials that get altered during the course of training.</a:t>
+            </a:r>
+          </a:p>
+          <a:p>
+            <a:pPr marL="0" indent="0">
+              <a:buNone/>
+            </a:pPr>
+            <a:r>
+              <a:rPr lang="en-US" b="1" dirty="0">
+                <a:solidFill>
+                  <a:srgbClr val="7030A0"/>
+                </a:solidFill>
+                <a:ea typeface="+mn-lt"/>
+                <a:cs typeface="+mn-lt"/>
+              </a:rPr>
+              <a:t>Context </a:t>
+            </a:r>
+            <a:r>
+              <a:rPr lang="en-US" dirty="0">
+                <a:ea typeface="+mn-lt"/>
+                <a:cs typeface="+mn-lt"/>
+              </a:rPr>
+              <a:t>The input to the LLM.</a:t>
+            </a:r>
+          </a:p>
+          <a:p>
+            <a:pPr marL="0" indent="0">
+              <a:buNone/>
+            </a:pPr>
+            <a:r>
+              <a:rPr lang="en-US" b="1" dirty="0">
+                <a:solidFill>
+                  <a:srgbClr val="7030A0"/>
+                </a:solidFill>
+                <a:ea typeface="+mn-lt"/>
+                <a:cs typeface="+mn-lt"/>
+              </a:rPr>
+              <a:t>Embedding </a:t>
+            </a:r>
+            <a:r>
+              <a:rPr lang="en-US" dirty="0">
+                <a:ea typeface="+mn-lt"/>
+                <a:cs typeface="+mn-lt"/>
+              </a:rPr>
+              <a:t>A high-dimensional representation of text.</a:t>
+            </a:r>
+          </a:p>
+          <a:p>
+            <a:pPr marL="0" indent="0">
+              <a:buNone/>
+            </a:pPr>
+            <a:r>
+              <a:rPr lang="en-US" b="1" dirty="0">
+                <a:solidFill>
+                  <a:srgbClr val="7030A0"/>
+                </a:solidFill>
+                <a:ea typeface="+mn-lt"/>
+                <a:cs typeface="+mn-lt"/>
+              </a:rPr>
+              <a:t>Token </a:t>
+            </a:r>
+            <a:r>
+              <a:rPr lang="en-US" dirty="0">
+                <a:ea typeface="+mn-lt"/>
+                <a:cs typeface="+mn-lt"/>
+              </a:rPr>
+              <a:t>The smallest unit of text fed into a model.</a:t>
+            </a:r>
+          </a:p>
+          <a:p>
+            <a:pPr marL="0" indent="0">
+              <a:buNone/>
+            </a:pPr>
+            <a:r>
+              <a:rPr lang="en-US" b="1" dirty="0">
+                <a:solidFill>
+                  <a:srgbClr val="7030A0"/>
+                </a:solidFill>
+                <a:ea typeface="+mn-lt"/>
+                <a:cs typeface="+mn-lt"/>
+              </a:rPr>
+              <a:t>Pre-training </a:t>
+            </a:r>
+            <a:r>
+              <a:rPr lang="en-US" dirty="0">
+                <a:ea typeface="+mn-lt"/>
+                <a:cs typeface="+mn-lt"/>
+              </a:rPr>
+              <a:t>The first stage of training the LLM, and usually the most expensive.</a:t>
+            </a:r>
+          </a:p>
+          <a:p>
+            <a:pPr marL="0" indent="0">
+              <a:buNone/>
+            </a:pPr>
+            <a:r>
+              <a:rPr lang="en-US" b="1" dirty="0">
+                <a:solidFill>
+                  <a:srgbClr val="7030A0"/>
+                </a:solidFill>
+                <a:ea typeface="+mn-lt"/>
+                <a:cs typeface="+mn-lt"/>
+              </a:rPr>
+              <a:t>Post-training </a:t>
+            </a:r>
+            <a:r>
+              <a:rPr lang="en-US" dirty="0">
+                <a:ea typeface="+mn-lt"/>
+                <a:cs typeface="+mn-lt"/>
+              </a:rPr>
+              <a:t>The second stage of training for working beyond general language understanding</a:t>
+            </a:r>
+          </a:p>
+          <a:p>
+            <a:pPr marL="0" indent="0">
+              <a:buNone/>
+            </a:pPr>
+            <a:r>
+              <a:rPr lang="en-US" b="1" dirty="0">
+                <a:solidFill>
+                  <a:srgbClr val="7030A0"/>
+                </a:solidFill>
+                <a:ea typeface="+mn-lt"/>
+                <a:cs typeface="+mn-lt"/>
+              </a:rPr>
+              <a:t>Fine-tuning </a:t>
+            </a:r>
+            <a:r>
+              <a:rPr lang="en-US" dirty="0">
+                <a:ea typeface="+mn-lt"/>
+                <a:cs typeface="+mn-lt"/>
+              </a:rPr>
+              <a:t>Training the LLM to do a particular task.</a:t>
+            </a:r>
+          </a:p>
+          <a:p>
+            <a:pPr marL="0" indent="0">
+              <a:buNone/>
+            </a:pPr>
+            <a:r>
+              <a:rPr lang="en-US" b="1" dirty="0">
+                <a:solidFill>
+                  <a:srgbClr val="7030A0"/>
+                </a:solidFill>
+                <a:ea typeface="+mn-lt"/>
+                <a:cs typeface="+mn-lt"/>
+              </a:rPr>
+              <a:t>Inference </a:t>
+            </a:r>
+            <a:r>
+              <a:rPr lang="en-US" dirty="0">
+                <a:ea typeface="+mn-lt"/>
+                <a:cs typeface="+mn-lt"/>
+              </a:rPr>
+              <a:t>The act of calling the model for text generation.</a:t>
+            </a:r>
+          </a:p>
+          <a:p>
+            <a:pPr marL="0" indent="0">
+              <a:buNone/>
+            </a:pPr>
+            <a:r>
+              <a:rPr lang="en-US" b="1" dirty="0">
+                <a:solidFill>
+                  <a:srgbClr val="7030A0"/>
+                </a:solidFill>
+                <a:ea typeface="+mn-lt"/>
+                <a:cs typeface="+mn-lt"/>
+              </a:rPr>
+              <a:t>Quantization </a:t>
+            </a:r>
+            <a:r>
+              <a:rPr lang="en-US" dirty="0">
+                <a:ea typeface="+mn-lt"/>
+                <a:cs typeface="+mn-lt"/>
+              </a:rPr>
+              <a:t>Reducing the size of a model.</a:t>
+            </a:r>
+          </a:p>
+          <a:p>
+            <a:pPr marL="0" indent="0">
+              <a:buNone/>
+            </a:pPr>
+            <a:r>
+              <a:rPr lang="en-US" b="1" dirty="0">
+                <a:solidFill>
+                  <a:srgbClr val="7030A0"/>
+                </a:solidFill>
+                <a:ea typeface="+mn-lt"/>
+                <a:cs typeface="+mn-lt"/>
+              </a:rPr>
+              <a:t>Source </a:t>
+            </a:r>
+            <a:r>
+              <a:rPr lang="en-US" dirty="0">
+                <a:ea typeface="+mn-lt"/>
+                <a:cs typeface="+mn-lt"/>
+              </a:rPr>
+              <a:t>The availability of the model (can be open or closed).</a:t>
+            </a:r>
+          </a:p>
+          <a:p>
+            <a:pPr marL="0" indent="0">
+              <a:buNone/>
+            </a:pPr>
+            <a:r>
+              <a:rPr lang="en-US" b="1" dirty="0">
+                <a:solidFill>
+                  <a:srgbClr val="7030A0"/>
+                </a:solidFill>
+                <a:ea typeface="+mn-lt"/>
+                <a:cs typeface="+mn-lt"/>
+              </a:rPr>
+              <a:t>Modality </a:t>
+            </a:r>
+            <a:r>
+              <a:rPr lang="en-US" dirty="0">
+                <a:ea typeface="+mn-lt"/>
+                <a:cs typeface="+mn-lt"/>
+              </a:rPr>
+              <a:t>Defined by the type of data the model is trained on (e.g. text or images).</a:t>
+            </a:r>
+          </a:p>
+          <a:p>
+            <a:pPr marL="0" indent="0">
+              <a:buNone/>
+            </a:pPr>
+            <a:r>
+              <a:rPr lang="en-US" b="1" dirty="0">
+                <a:solidFill>
+                  <a:srgbClr val="7030A0"/>
+                </a:solidFill>
+                <a:ea typeface="+mn-lt"/>
+                <a:cs typeface="+mn-lt"/>
+              </a:rPr>
+              <a:t>API </a:t>
+            </a:r>
+            <a:r>
+              <a:rPr lang="en-US" dirty="0">
+                <a:ea typeface="+mn-lt"/>
+                <a:cs typeface="+mn-lt"/>
+              </a:rPr>
+              <a:t>(Application Programming Interface) The means by which you can interact with a model.</a:t>
+            </a:r>
+            <a:endParaRPr lang="en-US" dirty="0"/>
           </a:p>
         </p:txBody>
       </p:sp>
     </p:spTree>
     <p:extLst>
       <p:ext uri="{BB962C8B-B14F-4D97-AF65-F5344CB8AC3E}">
-        <p14:creationId xmlns:p14="http://schemas.microsoft.com/office/powerpoint/2010/main" val="3408820217"/>
+        <p14:creationId xmlns:p14="http://schemas.microsoft.com/office/powerpoint/2010/main" val="2828243406"/>
       </p:ext>
     </p:extLst>
   </p:cSld>
   <p:clrMapOvr>
     <a:masterClrMapping/>
   </p:clrMapOvr>
-  <p:timing>
-    <p:tnLst>
-      <p:par>
-        <p:cTn id="1" dur="indefinite" restart="never" nodeType="tmRoot">
-          <p:childTnLst>
-            <p:seq concurrent="1" nextAc="seek">
-              <p:cTn id="2" dur="indefinite" nodeType="mainSeq">
-                <p:childTnLst>
-                  <p:par>
-                    <p:cTn id="3" fill="hold">
-                      <p:stCondLst>
-                        <p:cond delay="indefinite"/>
-                      </p:stCondLst>
-                      <p:childTnLst>
-                        <p:par>
-                          <p:cTn id="4" fill="hold">
-                            <p:stCondLst>
-                              <p:cond delay="0"/>
-                            </p:stCondLst>
-                            <p:childTnLst>
-                              <p:par>
-                                <p:cTn id="5" presetID="1" presetClass="entr" presetSubtype="0" fill="hold" grpId="0" nodeType="clickEffect">
-                                  <p:stCondLst>
-                                    <p:cond delay="0"/>
-                                  </p:stCondLst>
-                                  <p:childTnLst>
-                                    <p:set>
-                                      <p:cBhvr>
-                                        <p:cTn id="6" dur="1" fill="hold">
-                                          <p:stCondLst>
-                                            <p:cond delay="0"/>
-                                          </p:stCondLst>
-                                        </p:cTn>
-                                        <p:tgtEl>
-                                          <p:spTgt spid="3">
-                                            <p:txEl>
-                                              <p:pRg st="0" end="0"/>
-                                            </p:txEl>
-                                          </p:spTgt>
-                                        </p:tgtEl>
-                                        <p:attrNameLst>
-                                          <p:attrName>style.visibility</p:attrName>
-                                        </p:attrNameLst>
-                                      </p:cBhvr>
-                                      <p:to>
-                                        <p:strVal val="visible"/>
-                                      </p:to>
-                                    </p:set>
-                                  </p:childTnLst>
-                                </p:cTn>
-                              </p:par>
-                            </p:childTnLst>
-                          </p:cTn>
-                        </p:par>
-                      </p:childTnLst>
-                    </p:cTn>
-                  </p:par>
-                  <p:par>
-                    <p:cTn id="7" fill="hold">
-                      <p:stCondLst>
-                        <p:cond delay="indefinite"/>
-                      </p:stCondLst>
-                      <p:childTnLst>
-                        <p:par>
-                          <p:cTn id="8" fill="hold">
-                            <p:stCondLst>
-                              <p:cond delay="0"/>
-                            </p:stCondLst>
-                            <p:childTnLst>
-                              <p:par>
-                                <p:cTn id="9" presetID="1" presetClass="entr" presetSubtype="0" fill="hold" grpId="0" nodeType="clickEffect">
-                                  <p:stCondLst>
-                                    <p:cond delay="0"/>
-                                  </p:stCondLst>
-                                  <p:childTnLst>
-                                    <p:set>
-                                      <p:cBhvr>
-                                        <p:cTn id="10" dur="1" fill="hold">
-                                          <p:stCondLst>
-                                            <p:cond delay="0"/>
-                                          </p:stCondLst>
-                                        </p:cTn>
-                                        <p:tgtEl>
-                                          <p:spTgt spid="3">
-                                            <p:txEl>
-                                              <p:pRg st="2" end="2"/>
-                                            </p:txEl>
-                                          </p:spTgt>
-                                        </p:tgtEl>
-                                        <p:attrNameLst>
-                                          <p:attrName>style.visibility</p:attrName>
-                                        </p:attrNameLst>
-                                      </p:cBhvr>
-                                      <p:to>
-                                        <p:strVal val="visible"/>
-                                      </p:to>
-                                    </p:set>
-                                  </p:childTnLst>
-                                </p:cTn>
-                              </p:par>
-                            </p:childTnLst>
-                          </p:cTn>
-                        </p:par>
-                      </p:childTnLst>
-                    </p:cTn>
-                  </p:par>
-                </p:childTnLst>
-              </p:cTn>
-              <p:prevCondLst>
-                <p:cond evt="onPrev" delay="0">
-                  <p:tgtEl>
-                    <p:sldTgt/>
-                  </p:tgtEl>
-                </p:cond>
-              </p:prevCondLst>
-              <p:nextCondLst>
-                <p:cond evt="onNext" delay="0">
-                  <p:tgtEl>
-                    <p:sldTgt/>
-                  </p:tgtEl>
-                </p:cond>
-              </p:nextCondLst>
-            </p:seq>
-          </p:childTnLst>
-        </p:cTn>
-      </p:par>
-    </p:tnLst>
-    <p:bldLst>
-      <p:bldP spid="3" grpId="0" build="p"/>
-    </p:bldLst>
-  </p:timing>
 </p:sld>
 </file>
 
@@ -13769,7 +15078,7 @@
           <p:cNvPr id="2" name="Title 1">
             <a:extLst>
               <a:ext uri="{FF2B5EF4-FFF2-40B4-BE49-F238E27FC236}">
-                <a16:creationId xmlns:a16="http://schemas.microsoft.com/office/drawing/2014/main" id="{96041BF3-F107-F9B0-5EDB-4373BB4196B4}"/>
+                <a16:creationId xmlns:a16="http://schemas.microsoft.com/office/drawing/2014/main" id="{7C33511F-8565-6D41-02BF-6E9296DCF3B4}"/>
               </a:ext>
             </a:extLst>
           </p:cNvPr>
@@ -13787,7 +15096,37 @@
           <a:p>
             <a:r>
               <a:rPr lang="en-US" dirty="0"/>
-              <a:t>Some definitions</a:t>
+              <a:t>EU AI Act </a:t>
+            </a:r>
+            <a:r>
+              <a:rPr lang="en-US" i="1" dirty="0">
+                <a:solidFill>
+                  <a:schemeClr val="bg2">
+                    <a:lumMod val="50000"/>
+                  </a:schemeClr>
+                </a:solidFill>
+              </a:rPr>
+              <a:t>(</a:t>
+            </a:r>
+            <a:r>
+              <a:rPr lang="en-GB" i="1" dirty="0">
+                <a:solidFill>
+                  <a:schemeClr val="bg2">
+                    <a:lumMod val="50000"/>
+                  </a:schemeClr>
+                </a:solidFill>
+              </a:rPr>
+              <a:t>August 2024</a:t>
+            </a:r>
+            <a:r>
+              <a:rPr lang="en-US" i="1" dirty="0">
+                <a:solidFill>
+                  <a:schemeClr val="bg2">
+                    <a:lumMod val="50000"/>
+                  </a:schemeClr>
+                </a:solidFill>
+              </a:rPr>
+              <a:t>)</a:t>
             </a:r>
           </a:p>
         </p:txBody>
@@ -13797,7 +15136,7 @@
           <p:cNvPr id="3" name="Content Placeholder 2">
             <a:extLst>
               <a:ext uri="{FF2B5EF4-FFF2-40B4-BE49-F238E27FC236}">
-                <a16:creationId xmlns:a16="http://schemas.microsoft.com/office/drawing/2014/main" id="{BACC3A7C-33D4-2896-0AC9-9DA08F6ED357}"/>
+                <a16:creationId xmlns:a16="http://schemas.microsoft.com/office/drawing/2014/main" id="{C10ABB8D-3273-0866-F725-70CD2E52915C}"/>
               </a:ext>
             </a:extLst>
           </p:cNvPr>
@@ -13811,7 +15150,7 @@
         <p:spPr/>
         <p:txBody>
           <a:bodyPr vert="horz" lIns="91440" tIns="45720" rIns="91440" bIns="45720" rtlCol="0" anchor="t">
-            <a:normAutofit fontScale="62500" lnSpcReduction="20000"/>
+            <a:normAutofit/>
           </a:bodyPr>
           <a:lstStyle/>
           <a:p>
@@ -13819,340 +15158,31 @@
               <a:buNone/>
             </a:pPr>
             <a:r>
-              <a:rPr lang="en-US" b="1">
-                <a:solidFill>
-                  <a:srgbClr val="7030A0"/>
-                </a:solidFill>
-                <a:ea typeface="+mn-lt"/>
-                <a:cs typeface="+mn-lt"/>
-              </a:rPr>
-              <a:t>Model </a:t>
-            </a:r>
-            <a:r>
-              <a:rPr lang="en-US">
-                <a:ea typeface="+mn-lt"/>
-                <a:cs typeface="+mn-lt"/>
-              </a:rPr>
-              <a:t>The thing you train and use to generate text.</a:t>
-            </a:r>
+              <a:rPr lang="en-US" dirty="0"/>
+              <a:t>How does the AI Act define things...?</a:t>
+            </a:r>
+          </a:p>
+          <a:p>
+            <a:pPr marL="0" indent="0">
+              <a:buNone/>
+            </a:pPr>
+            <a:endParaRPr lang="en-US" dirty="0"/>
+          </a:p>
+          <a:p>
+            <a:pPr marL="0" indent="0">
+              <a:buNone/>
+            </a:pPr>
             <a:endParaRPr lang="en-US" dirty="0">
               <a:ea typeface="+mn-lt"/>
               <a:cs typeface="+mn-lt"/>
             </a:endParaRPr>
           </a:p>
-          <a:p>
-            <a:pPr marL="0" indent="0">
-              <a:buNone/>
-            </a:pPr>
-            <a:r>
-              <a:rPr lang="en-US" b="1" dirty="0">
-                <a:solidFill>
-                  <a:srgbClr val="7030A0"/>
-                </a:solidFill>
-                <a:ea typeface="+mn-lt"/>
-                <a:cs typeface="+mn-lt"/>
-              </a:rPr>
-              <a:t>Architecture </a:t>
-            </a:r>
-            <a:r>
-              <a:rPr lang="en-US" dirty="0">
-                <a:ea typeface="+mn-lt"/>
-                <a:cs typeface="+mn-lt"/>
-              </a:rPr>
-              <a:t>The </a:t>
-            </a:r>
-            <a:r>
-              <a:rPr lang="en-US">
-                <a:ea typeface="+mn-lt"/>
-                <a:cs typeface="+mn-lt"/>
-              </a:rPr>
-              <a:t>high-level structure of the model.</a:t>
-            </a:r>
-          </a:p>
-          <a:p>
-            <a:pPr marL="0" indent="0">
-              <a:buNone/>
-            </a:pPr>
-            <a:r>
-              <a:rPr lang="en-US" b="1" dirty="0">
-                <a:solidFill>
-                  <a:srgbClr val="7030A0"/>
-                </a:solidFill>
-                <a:ea typeface="+mn-lt"/>
-                <a:cs typeface="+mn-lt"/>
-              </a:rPr>
-              <a:t>Parameters </a:t>
-            </a:r>
-            <a:r>
-              <a:rPr lang="en-US" dirty="0">
-                <a:ea typeface="+mn-lt"/>
-                <a:cs typeface="+mn-lt"/>
-              </a:rPr>
-              <a:t>(or weights) The internal knobs and dials that get altered </a:t>
-            </a:r>
-            <a:r>
-              <a:rPr lang="en-US">
-                <a:ea typeface="+mn-lt"/>
-                <a:cs typeface="+mn-lt"/>
-              </a:rPr>
-              <a:t>during the course of training.</a:t>
-            </a:r>
-          </a:p>
-          <a:p>
-            <a:pPr marL="0" indent="0">
-              <a:buNone/>
-            </a:pPr>
-            <a:r>
-              <a:rPr lang="en-US" b="1" dirty="0">
-                <a:solidFill>
-                  <a:srgbClr val="7030A0"/>
-                </a:solidFill>
-                <a:ea typeface="+mn-lt"/>
-                <a:cs typeface="+mn-lt"/>
-              </a:rPr>
-              <a:t>Context </a:t>
-            </a:r>
-            <a:r>
-              <a:rPr lang="en-US" dirty="0">
-                <a:ea typeface="+mn-lt"/>
-                <a:cs typeface="+mn-lt"/>
-              </a:rPr>
-              <a:t>The input to the LLM.</a:t>
-            </a:r>
-          </a:p>
-          <a:p>
-            <a:pPr marL="0" indent="0">
-              <a:buNone/>
-            </a:pPr>
-            <a:r>
-              <a:rPr lang="en-US" b="1" dirty="0">
-                <a:solidFill>
-                  <a:srgbClr val="7030A0"/>
-                </a:solidFill>
-                <a:ea typeface="+mn-lt"/>
-                <a:cs typeface="+mn-lt"/>
-              </a:rPr>
-              <a:t>Embedding </a:t>
-            </a:r>
-            <a:r>
-              <a:rPr lang="en-US" dirty="0">
-                <a:ea typeface="+mn-lt"/>
-                <a:cs typeface="+mn-lt"/>
-              </a:rPr>
-              <a:t>A high-dimensional representation of text.</a:t>
-            </a:r>
-          </a:p>
-          <a:p>
-            <a:pPr marL="0" indent="0">
-              <a:buNone/>
-            </a:pPr>
-            <a:r>
-              <a:rPr lang="en-US" b="1" dirty="0">
-                <a:solidFill>
-                  <a:srgbClr val="7030A0"/>
-                </a:solidFill>
-                <a:ea typeface="+mn-lt"/>
-                <a:cs typeface="+mn-lt"/>
-              </a:rPr>
-              <a:t>Token </a:t>
-            </a:r>
-            <a:r>
-              <a:rPr lang="en-US" dirty="0">
-                <a:ea typeface="+mn-lt"/>
-                <a:cs typeface="+mn-lt"/>
-              </a:rPr>
-              <a:t>The smallest unit of text fed into a model.</a:t>
-            </a:r>
-          </a:p>
-          <a:p>
-            <a:pPr marL="0" indent="0">
-              <a:buNone/>
-            </a:pPr>
-            <a:r>
-              <a:rPr lang="en-US" b="1" dirty="0">
-                <a:solidFill>
-                  <a:srgbClr val="7030A0"/>
-                </a:solidFill>
-                <a:ea typeface="+mn-lt"/>
-                <a:cs typeface="+mn-lt"/>
-              </a:rPr>
-              <a:t>Pretraining </a:t>
-            </a:r>
-            <a:r>
-              <a:rPr lang="en-US" dirty="0">
-                <a:ea typeface="+mn-lt"/>
-                <a:cs typeface="+mn-lt"/>
-              </a:rPr>
-              <a:t>The first stage of </a:t>
-            </a:r>
-            <a:r>
-              <a:rPr lang="en-US">
-                <a:ea typeface="+mn-lt"/>
-                <a:cs typeface="+mn-lt"/>
-              </a:rPr>
-              <a:t>training the LLM, and usually the most expensive.</a:t>
-            </a:r>
-          </a:p>
-          <a:p>
-            <a:pPr marL="0" indent="0">
-              <a:buNone/>
-            </a:pPr>
-            <a:r>
-              <a:rPr lang="en-US" dirty="0">
-                <a:ea typeface="+mn-lt"/>
-                <a:cs typeface="+mn-lt"/>
-              </a:rPr>
-              <a:t> </a:t>
-            </a:r>
-            <a:r>
-              <a:rPr lang="en-US" b="1">
-                <a:solidFill>
-                  <a:srgbClr val="7030A0"/>
-                </a:solidFill>
-                <a:ea typeface="+mn-lt"/>
-                <a:cs typeface="+mn-lt"/>
-              </a:rPr>
-              <a:t>Finetuning </a:t>
-            </a:r>
-            <a:r>
-              <a:rPr lang="en-US">
-                <a:ea typeface="+mn-lt"/>
-                <a:cs typeface="+mn-lt"/>
-              </a:rPr>
-              <a:t>Training the LLM to do a particular task.</a:t>
-            </a:r>
-          </a:p>
-          <a:p>
-            <a:pPr marL="0" indent="0">
-              <a:buNone/>
-            </a:pPr>
-            <a:r>
-              <a:rPr lang="en-US" b="1" dirty="0">
-                <a:solidFill>
-                  <a:srgbClr val="7030A0"/>
-                </a:solidFill>
-                <a:ea typeface="+mn-lt"/>
-                <a:cs typeface="+mn-lt"/>
-              </a:rPr>
-              <a:t>Inference </a:t>
-            </a:r>
-            <a:r>
-              <a:rPr lang="en-US" dirty="0">
-                <a:ea typeface="+mn-lt"/>
-                <a:cs typeface="+mn-lt"/>
-              </a:rPr>
-              <a:t>The act of calling the model for text generation.</a:t>
-            </a:r>
-          </a:p>
-          <a:p>
-            <a:pPr marL="0" indent="0">
-              <a:buNone/>
-            </a:pPr>
-            <a:r>
-              <a:rPr lang="en-US" b="1" dirty="0">
-                <a:solidFill>
-                  <a:srgbClr val="7030A0"/>
-                </a:solidFill>
-                <a:ea typeface="+mn-lt"/>
-                <a:cs typeface="+mn-lt"/>
-              </a:rPr>
-              <a:t>Quantization </a:t>
-            </a:r>
-            <a:r>
-              <a:rPr lang="en-US" dirty="0">
-                <a:ea typeface="+mn-lt"/>
-                <a:cs typeface="+mn-lt"/>
-              </a:rPr>
-              <a:t>Reducing the size of a model.</a:t>
-            </a:r>
-          </a:p>
-          <a:p>
-            <a:pPr marL="0" indent="0">
-              <a:buNone/>
-            </a:pPr>
-            <a:r>
-              <a:rPr lang="en-US" b="1" dirty="0">
-                <a:solidFill>
-                  <a:srgbClr val="7030A0"/>
-                </a:solidFill>
-                <a:ea typeface="+mn-lt"/>
-                <a:cs typeface="+mn-lt"/>
-              </a:rPr>
-              <a:t>Source </a:t>
-            </a:r>
-            <a:r>
-              <a:rPr lang="en-US" dirty="0">
-                <a:ea typeface="+mn-lt"/>
-                <a:cs typeface="+mn-lt"/>
-              </a:rPr>
-              <a:t>The availability of the model (can be open </a:t>
-            </a:r>
-            <a:r>
-              <a:rPr lang="en-US">
-                <a:ea typeface="+mn-lt"/>
-                <a:cs typeface="+mn-lt"/>
-              </a:rPr>
-              <a:t>or closed).</a:t>
-            </a:r>
-          </a:p>
-          <a:p>
-            <a:pPr marL="0" indent="0">
-              <a:buNone/>
-            </a:pPr>
-            <a:r>
-              <a:rPr lang="en-US" b="1" dirty="0">
-                <a:solidFill>
-                  <a:srgbClr val="7030A0"/>
-                </a:solidFill>
-                <a:ea typeface="+mn-lt"/>
-                <a:cs typeface="+mn-lt"/>
-              </a:rPr>
-              <a:t>Modality </a:t>
-            </a:r>
-            <a:r>
-              <a:rPr lang="en-US" dirty="0">
-                <a:ea typeface="+mn-lt"/>
-                <a:cs typeface="+mn-lt"/>
-              </a:rPr>
-              <a:t>Defined by the type of data the model is trained on (e.g.</a:t>
-            </a:r>
-            <a:r>
-              <a:rPr lang="en-US">
-                <a:ea typeface="+mn-lt"/>
-                <a:cs typeface="+mn-lt"/>
-              </a:rPr>
-              <a:t> text or images).</a:t>
-            </a:r>
-          </a:p>
-          <a:p>
-            <a:pPr marL="0" indent="0">
-              <a:buNone/>
-            </a:pPr>
-            <a:r>
-              <a:rPr lang="en-US" b="1" dirty="0">
-                <a:solidFill>
-                  <a:srgbClr val="7030A0"/>
-                </a:solidFill>
-                <a:ea typeface="+mn-lt"/>
-                <a:cs typeface="+mn-lt"/>
-              </a:rPr>
-              <a:t>API </a:t>
-            </a:r>
-            <a:r>
-              <a:rPr lang="en-US" dirty="0">
-                <a:ea typeface="+mn-lt"/>
-                <a:cs typeface="+mn-lt"/>
-              </a:rPr>
-              <a:t>(Application Programming Interface) The means by which you can interact with a model.</a:t>
-            </a:r>
-            <a:endParaRPr lang="en-US"/>
-          </a:p>
         </p:txBody>
       </p:sp>
     </p:spTree>
     <p:extLst>
       <p:ext uri="{BB962C8B-B14F-4D97-AF65-F5344CB8AC3E}">
-        <p14:creationId xmlns:p14="http://schemas.microsoft.com/office/powerpoint/2010/main" val="2828243406"/>
+        <p14:creationId xmlns:p14="http://schemas.microsoft.com/office/powerpoint/2010/main" val="1865729139"/>
       </p:ext>
     </p:extLst>
   </p:cSld>

</xml_diff>

<commit_message>
chore(slides): add timings to intro slides
</commit_message>
<xml_diff>
--- a/slides/1-intro.pptx
+++ b/slides/1-intro.pptx
@@ -314,7 +314,7 @@
           </a:lstStyle>
           <a:p>
             <a:fld id="{2DE082D9-00CE-4FDC-82D3-FDE16CD37225}" type="datetimeFigureOut">
-              <a:t>4/30/26</a:t>
+              <a:t>5/1/26</a:t>
             </a:fld>
             <a:endParaRPr lang="en-US"/>
           </a:p>
@@ -626,6 +626,54 @@
           <a:p>
             <a:r>
               <a:rPr lang="en-US" dirty="0"/>
+              <a:t>[TIMINGS]</a:t>
+            </a:r>
+          </a:p>
+          <a:p>
+            <a:endParaRPr lang="en-US" dirty="0"/>
+          </a:p>
+          <a:p>
+            <a:r>
+              <a:rPr lang="en-US" dirty="0"/>
+              <a:t>Practice: 40m</a:t>
+            </a:r>
+          </a:p>
+          <a:p>
+            <a:r>
+              <a:rPr lang="en-US" dirty="0"/>
+              <a:t>Target: 45m</a:t>
+            </a:r>
+          </a:p>
+          <a:p>
+            <a:endParaRPr lang="en-US" dirty="0"/>
+          </a:p>
+          <a:p>
+            <a:r>
+              <a:rPr lang="en-US" dirty="0"/>
+              <a:t>Start time: 9:35</a:t>
+            </a:r>
+          </a:p>
+          <a:p>
+            <a:r>
+              <a:rPr lang="en-US" dirty="0"/>
+              <a:t>End time: 10:20</a:t>
+            </a:r>
+          </a:p>
+          <a:p>
+            <a:endParaRPr lang="en-US" dirty="0"/>
+          </a:p>
+          <a:p>
+            <a:r>
+              <a:rPr lang="en-US" dirty="0"/>
+              <a:t>---</a:t>
+            </a:r>
+          </a:p>
+          <a:p>
+            <a:endParaRPr lang="en-US" dirty="0"/>
+          </a:p>
+          <a:p>
+            <a:r>
+              <a:rPr lang="en-US" dirty="0"/>
               <a:t>Welcome to introduction to large </a:t>
             </a:r>
             <a:r>
@@ -1013,7 +1061,7 @@
           <a:p>
             <a:r>
               <a:rPr lang="en-US" dirty="0"/>
-              <a:t>We run a couple of workshops at the moment: an introduction to large language models, a hands on LLMs, generative AI, diffusion models, docker, a packaging and publishing workshop, and now a new agents 4 science workshop</a:t>
+              <a:t>We run a couple of workshops at the moment: an introduction to large language models, a hands on LLMs, generative AI, diffusion models, docker, a packaging and publishing workshop.</a:t>
             </a:r>
           </a:p>
         </p:txBody>
@@ -1811,7 +1859,7 @@
           <a:p>
             <a:fld id="{C764DE79-268F-4C1A-8933-263129D2AF90}" type="datetimeFigureOut">
               <a:rPr lang="en-US" dirty="0"/>
-              <a:t>4/30/26</a:t>
+              <a:t>5/1/26</a:t>
             </a:fld>
             <a:endParaRPr lang="en-US" dirty="0"/>
           </a:p>
@@ -1979,7 +2027,7 @@
           <a:p>
             <a:fld id="{C764DE79-268F-4C1A-8933-263129D2AF90}" type="datetimeFigureOut">
               <a:rPr lang="en-US" dirty="0"/>
-              <a:t>4/30/26</a:t>
+              <a:t>5/1/26</a:t>
             </a:fld>
             <a:endParaRPr lang="en-US" dirty="0"/>
           </a:p>
@@ -2157,7 +2205,7 @@
           <a:p>
             <a:fld id="{C764DE79-268F-4C1A-8933-263129D2AF90}" type="datetimeFigureOut">
               <a:rPr lang="en-US" dirty="0"/>
-              <a:t>4/30/26</a:t>
+              <a:t>5/1/26</a:t>
             </a:fld>
             <a:endParaRPr lang="en-US" dirty="0"/>
           </a:p>
@@ -2325,7 +2373,7 @@
           <a:p>
             <a:fld id="{C764DE79-268F-4C1A-8933-263129D2AF90}" type="datetimeFigureOut">
               <a:rPr lang="en-US" dirty="0"/>
-              <a:t>4/30/26</a:t>
+              <a:t>5/1/26</a:t>
             </a:fld>
             <a:endParaRPr lang="en-US" dirty="0"/>
           </a:p>
@@ -2570,7 +2618,7 @@
           <a:p>
             <a:fld id="{C764DE79-268F-4C1A-8933-263129D2AF90}" type="datetimeFigureOut">
               <a:rPr lang="en-US" dirty="0"/>
-              <a:t>4/30/26</a:t>
+              <a:t>5/1/26</a:t>
             </a:fld>
             <a:endParaRPr lang="en-US" dirty="0"/>
           </a:p>
@@ -2799,7 +2847,7 @@
           <a:p>
             <a:fld id="{C764DE79-268F-4C1A-8933-263129D2AF90}" type="datetimeFigureOut">
               <a:rPr lang="en-US" dirty="0"/>
-              <a:t>4/30/26</a:t>
+              <a:t>5/1/26</a:t>
             </a:fld>
             <a:endParaRPr lang="en-US" dirty="0"/>
           </a:p>
@@ -3163,7 +3211,7 @@
           <a:p>
             <a:fld id="{C764DE79-268F-4C1A-8933-263129D2AF90}" type="datetimeFigureOut">
               <a:rPr lang="en-US" dirty="0"/>
-              <a:t>4/30/26</a:t>
+              <a:t>5/1/26</a:t>
             </a:fld>
             <a:endParaRPr lang="en-US" dirty="0"/>
           </a:p>
@@ -3280,7 +3328,7 @@
           <a:p>
             <a:fld id="{C764DE79-268F-4C1A-8933-263129D2AF90}" type="datetimeFigureOut">
               <a:rPr lang="en-US" dirty="0"/>
-              <a:t>4/30/26</a:t>
+              <a:t>5/1/26</a:t>
             </a:fld>
             <a:endParaRPr lang="en-US" dirty="0"/>
           </a:p>
@@ -3375,7 +3423,7 @@
           <a:p>
             <a:fld id="{C764DE79-268F-4C1A-8933-263129D2AF90}" type="datetimeFigureOut">
               <a:rPr lang="en-US" dirty="0"/>
-              <a:t>4/30/26</a:t>
+              <a:t>5/1/26</a:t>
             </a:fld>
             <a:endParaRPr lang="en-US" dirty="0"/>
           </a:p>
@@ -3650,7 +3698,7 @@
           <a:p>
             <a:fld id="{C764DE79-268F-4C1A-8933-263129D2AF90}" type="datetimeFigureOut">
               <a:rPr lang="en-US" dirty="0"/>
-              <a:t>4/30/26</a:t>
+              <a:t>5/1/26</a:t>
             </a:fld>
             <a:endParaRPr lang="en-US" dirty="0"/>
           </a:p>
@@ -3902,7 +3950,7 @@
           <a:p>
             <a:fld id="{C764DE79-268F-4C1A-8933-263129D2AF90}" type="datetimeFigureOut">
               <a:rPr lang="en-US" dirty="0"/>
-              <a:t>4/30/26</a:t>
+              <a:t>5/1/26</a:t>
             </a:fld>
             <a:endParaRPr lang="en-US" dirty="0"/>
           </a:p>
@@ -4113,7 +4161,7 @@
           <a:p>
             <a:fld id="{C764DE79-268F-4C1A-8933-263129D2AF90}" type="datetimeFigureOut">
               <a:rPr lang="en-US" dirty="0"/>
-              <a:t>4/30/26</a:t>
+              <a:t>5/1/26</a:t>
             </a:fld>
             <a:endParaRPr lang="en-US" dirty="0"/>
           </a:p>

</xml_diff>

<commit_message>
chore(slides): add timings and update note for sampling
</commit_message>
<xml_diff>
--- a/slides/1-intro.pptx
+++ b/slides/1-intro.pptx
@@ -314,7 +314,7 @@
           </a:lstStyle>
           <a:p>
             <a:fld id="{2DE082D9-00CE-4FDC-82D3-FDE16CD37225}" type="datetimeFigureOut">
-              <a:t>5/1/26</a:t>
+              <a:t>5/8/26</a:t>
             </a:fld>
             <a:endParaRPr lang="en-US"/>
           </a:p>
@@ -1859,7 +1859,7 @@
           <a:p>
             <a:fld id="{C764DE79-268F-4C1A-8933-263129D2AF90}" type="datetimeFigureOut">
               <a:rPr lang="en-US" dirty="0"/>
-              <a:t>5/1/26</a:t>
+              <a:t>5/8/26</a:t>
             </a:fld>
             <a:endParaRPr lang="en-US" dirty="0"/>
           </a:p>
@@ -2027,7 +2027,7 @@
           <a:p>
             <a:fld id="{C764DE79-268F-4C1A-8933-263129D2AF90}" type="datetimeFigureOut">
               <a:rPr lang="en-US" dirty="0"/>
-              <a:t>5/1/26</a:t>
+              <a:t>5/8/26</a:t>
             </a:fld>
             <a:endParaRPr lang="en-US" dirty="0"/>
           </a:p>
@@ -2205,7 +2205,7 @@
           <a:p>
             <a:fld id="{C764DE79-268F-4C1A-8933-263129D2AF90}" type="datetimeFigureOut">
               <a:rPr lang="en-US" dirty="0"/>
-              <a:t>5/1/26</a:t>
+              <a:t>5/8/26</a:t>
             </a:fld>
             <a:endParaRPr lang="en-US" dirty="0"/>
           </a:p>
@@ -2373,7 +2373,7 @@
           <a:p>
             <a:fld id="{C764DE79-268F-4C1A-8933-263129D2AF90}" type="datetimeFigureOut">
               <a:rPr lang="en-US" dirty="0"/>
-              <a:t>5/1/26</a:t>
+              <a:t>5/8/26</a:t>
             </a:fld>
             <a:endParaRPr lang="en-US" dirty="0"/>
           </a:p>
@@ -2618,7 +2618,7 @@
           <a:p>
             <a:fld id="{C764DE79-268F-4C1A-8933-263129D2AF90}" type="datetimeFigureOut">
               <a:rPr lang="en-US" dirty="0"/>
-              <a:t>5/1/26</a:t>
+              <a:t>5/8/26</a:t>
             </a:fld>
             <a:endParaRPr lang="en-US" dirty="0"/>
           </a:p>
@@ -2847,7 +2847,7 @@
           <a:p>
             <a:fld id="{C764DE79-268F-4C1A-8933-263129D2AF90}" type="datetimeFigureOut">
               <a:rPr lang="en-US" dirty="0"/>
-              <a:t>5/1/26</a:t>
+              <a:t>5/8/26</a:t>
             </a:fld>
             <a:endParaRPr lang="en-US" dirty="0"/>
           </a:p>
@@ -3211,7 +3211,7 @@
           <a:p>
             <a:fld id="{C764DE79-268F-4C1A-8933-263129D2AF90}" type="datetimeFigureOut">
               <a:rPr lang="en-US" dirty="0"/>
-              <a:t>5/1/26</a:t>
+              <a:t>5/8/26</a:t>
             </a:fld>
             <a:endParaRPr lang="en-US" dirty="0"/>
           </a:p>
@@ -3328,7 +3328,7 @@
           <a:p>
             <a:fld id="{C764DE79-268F-4C1A-8933-263129D2AF90}" type="datetimeFigureOut">
               <a:rPr lang="en-US" dirty="0"/>
-              <a:t>5/1/26</a:t>
+              <a:t>5/8/26</a:t>
             </a:fld>
             <a:endParaRPr lang="en-US" dirty="0"/>
           </a:p>
@@ -3423,7 +3423,7 @@
           <a:p>
             <a:fld id="{C764DE79-268F-4C1A-8933-263129D2AF90}" type="datetimeFigureOut">
               <a:rPr lang="en-US" dirty="0"/>
-              <a:t>5/1/26</a:t>
+              <a:t>5/8/26</a:t>
             </a:fld>
             <a:endParaRPr lang="en-US" dirty="0"/>
           </a:p>
@@ -3698,7 +3698,7 @@
           <a:p>
             <a:fld id="{C764DE79-268F-4C1A-8933-263129D2AF90}" type="datetimeFigureOut">
               <a:rPr lang="en-US" dirty="0"/>
-              <a:t>5/1/26</a:t>
+              <a:t>5/8/26</a:t>
             </a:fld>
             <a:endParaRPr lang="en-US" dirty="0"/>
           </a:p>
@@ -3950,7 +3950,7 @@
           <a:p>
             <a:fld id="{C764DE79-268F-4C1A-8933-263129D2AF90}" type="datetimeFigureOut">
               <a:rPr lang="en-US" dirty="0"/>
-              <a:t>5/1/26</a:t>
+              <a:t>5/8/26</a:t>
             </a:fld>
             <a:endParaRPr lang="en-US" dirty="0"/>
           </a:p>
@@ -4161,7 +4161,7 @@
           <a:p>
             <a:fld id="{C764DE79-268F-4C1A-8933-263129D2AF90}" type="datetimeFigureOut">
               <a:rPr lang="en-US" dirty="0"/>
-              <a:t>5/1/26</a:t>
+              <a:t>5/8/26</a:t>
             </a:fld>
             <a:endParaRPr lang="en-US" dirty="0"/>
           </a:p>

</xml_diff>